<commit_message>
CF06: rebuild slides as teleprompter — exact script text per slide
Co-Authored-By: Claude Sonnet 4.6 <noreply@anthropic.com>
</commit_message>
<xml_diff>
--- a/codefest/cf06/presentation/cf06_cllm_slides.pptx
+++ b/codefest/cf06/presentation/cf06_cllm_slides.pptx
@@ -12,7 +12,6 @@
     <p:sldId id="260" r:id="rId11"/>
     <p:sldId id="261" r:id="rId12"/>
     <p:sldId id="262" r:id="rId13"/>
-    <p:sldId id="263" r:id="rId14"/>
   </p:sldIdLst>
   <p:sldSz cx="12188952" cy="6858000" type="screen4x3"/>
   <p:notesSz cx="6858000" cy="9144000"/>
@@ -3146,7 +3145,7 @@
         </p:nvSpPr>
         <p:spPr>
           <a:xfrm>
-            <a:off x="0" y="2743200"/>
+            <a:off x="0" y="2834640"/>
             <a:ext cx="12188952" cy="73152"/>
           </a:xfrm>
           <a:prstGeom prst="rect">
@@ -3189,8 +3188,8 @@
         </p:nvSpPr>
         <p:spPr>
           <a:xfrm>
-            <a:off x="457200" y="1097280"/>
-            <a:ext cx="11247120" cy="1280160"/>
+            <a:off x="457200" y="1005840"/>
+            <a:ext cx="11247120" cy="1463040"/>
           </a:xfrm>
           <a:prstGeom prst="rect">
             <a:avLst/>
@@ -3198,14 +3197,14 @@
           <a:noFill/>
         </p:spPr>
         <p:txBody>
-          <a:bodyPr wrap="square">
+          <a:bodyPr wrap="none">
             <a:spAutoFit/>
           </a:bodyPr>
           <a:lstStyle/>
           <a:p>
             <a:pPr algn="ctr"/>
             <a:r>
-              <a:rPr sz="5200" b="1">
+              <a:rPr sz="5600" b="1">
                 <a:solidFill>
                   <a:srgbClr val="FFFFFF"/>
                 </a:solidFill>
@@ -3223,8 +3222,8 @@
         </p:nvSpPr>
         <p:spPr>
           <a:xfrm>
-            <a:off x="457200" y="2560320"/>
-            <a:ext cx="11247120" cy="731520"/>
+            <a:off x="457200" y="2606040"/>
+            <a:ext cx="11247120" cy="640080"/>
           </a:xfrm>
           <a:prstGeom prst="rect">
             <a:avLst/>
@@ -3232,14 +3231,14 @@
           <a:noFill/>
         </p:spPr>
         <p:txBody>
-          <a:bodyPr wrap="square">
+          <a:bodyPr wrap="none">
             <a:spAutoFit/>
           </a:bodyPr>
           <a:lstStyle/>
           <a:p>
             <a:pPr algn="ctr"/>
             <a:r>
-              <a:rPr sz="2800" b="0">
+              <a:rPr sz="2600">
                 <a:solidFill>
                   <a:srgbClr val="BFD7ED"/>
                 </a:solidFill>
@@ -3257,8 +3256,8 @@
         </p:nvSpPr>
         <p:spPr>
           <a:xfrm>
-            <a:off x="457200" y="5852160"/>
-            <a:ext cx="11247120" cy="640080"/>
+            <a:off x="457200" y="5943600"/>
+            <a:ext cx="11247120" cy="548640"/>
           </a:xfrm>
           <a:prstGeom prst="rect">
             <a:avLst/>
@@ -3266,14 +3265,14 @@
           <a:noFill/>
         </p:spPr>
         <p:txBody>
-          <a:bodyPr wrap="square">
+          <a:bodyPr wrap="none">
             <a:spAutoFit/>
           </a:bodyPr>
           <a:lstStyle/>
           <a:p>
             <a:pPr algn="ctr"/>
             <a:r>
-              <a:rPr sz="1600" b="0">
+              <a:rPr sz="1500">
                 <a:solidFill>
                   <a:srgbClr val="9DC3E6"/>
                 </a:solidFill>
@@ -3316,7 +3315,7 @@
             <a:avLst/>
           </a:prstGeom>
           <a:solidFill>
-            <a:srgbClr val="F2F2F2"/>
+            <a:srgbClr val="F4F4F4"/>
           </a:solidFill>
           <a:ln>
             <a:noFill/>
@@ -3353,7 +3352,7 @@
         <p:spPr>
           <a:xfrm>
             <a:off x="0" y="0"/>
-            <a:ext cx="12188952" cy="1005840"/>
+            <a:ext cx="12188952" cy="502920"/>
           </a:xfrm>
           <a:prstGeom prst="rect">
             <a:avLst/>
@@ -3389,47 +3388,13 @@
       </p:sp>
       <p:sp>
         <p:nvSpPr>
-          <p:cNvPr id="4" name="TextBox 3"/>
-          <p:cNvSpPr txBox="1"/>
-          <p:nvPr/>
-        </p:nvSpPr>
-        <p:spPr>
-          <a:xfrm>
-            <a:off x="274320" y="91440"/>
-            <a:ext cx="11612880" cy="822960"/>
-          </a:xfrm>
-          <a:prstGeom prst="rect">
-            <a:avLst/>
-          </a:prstGeom>
-          <a:noFill/>
-        </p:spPr>
-        <p:txBody>
-          <a:bodyPr wrap="square">
-            <a:spAutoFit/>
-          </a:bodyPr>
-          <a:lstStyle/>
-          <a:p>
-            <a:pPr algn="l"/>
-            <a:r>
-              <a:rPr sz="3200" b="1">
-                <a:solidFill>
-                  <a:srgbClr val="FFFFFF"/>
-                </a:solidFill>
-              </a:rPr>
-              <a:t>What Is a Crossbar MAC?</a:t>
-            </a:r>
-          </a:p>
-        </p:txBody>
-      </p:sp>
-      <p:sp>
-        <p:nvSpPr>
-          <p:cNvPr id="5" name="Rectangle 4"/>
+          <p:cNvPr id="4" name="Rectangle 3"/>
           <p:cNvSpPr/>
           <p:nvPr/>
         </p:nvSpPr>
         <p:spPr>
           <a:xfrm>
-            <a:off x="0" y="1005840"/>
+            <a:off x="0" y="502920"/>
             <a:ext cx="12188952" cy="54864"/>
           </a:xfrm>
           <a:prstGeom prst="rect">
@@ -3464,9 +3429,171 @@
           </a:p>
         </p:txBody>
       </p:sp>
+      <p:sp>
+        <p:nvSpPr>
+          <p:cNvPr id="5" name="TextBox 4"/>
+          <p:cNvSpPr txBox="1"/>
+          <p:nvPr/>
+        </p:nvSpPr>
+        <p:spPr>
+          <a:xfrm>
+            <a:off x="228600" y="54864"/>
+            <a:ext cx="11887200" cy="438912"/>
+          </a:xfrm>
+          <a:prstGeom prst="rect">
+            <a:avLst/>
+          </a:prstGeom>
+          <a:noFill/>
+        </p:spPr>
+        <p:txBody>
+          <a:bodyPr wrap="none">
+            <a:spAutoFit/>
+          </a:bodyPr>
+          <a:lstStyle/>
+          <a:p>
+            <a:pPr algn="l"/>
+            <a:r>
+              <a:rPr sz="2200" b="1">
+                <a:solidFill>
+                  <a:srgbClr val="FFFFFF"/>
+                </a:solidFill>
+              </a:rPr>
+              <a:t>The Design</a:t>
+            </a:r>
+          </a:p>
+        </p:txBody>
+      </p:sp>
+      <p:sp>
+        <p:nvSpPr>
+          <p:cNvPr id="6" name="TextBox 5"/>
+          <p:cNvSpPr txBox="1"/>
+          <p:nvPr/>
+        </p:nvSpPr>
+        <p:spPr>
+          <a:xfrm>
+            <a:off x="274320" y="685800"/>
+            <a:ext cx="6858000" cy="5943600"/>
+          </a:xfrm>
+          <a:prstGeom prst="rect">
+            <a:avLst/>
+          </a:prstGeom>
+          <a:noFill/>
+        </p:spPr>
+        <p:txBody>
+          <a:bodyPr wrap="square">
+            <a:spAutoFit/>
+          </a:bodyPr>
+          <a:lstStyle/>
+          <a:p>
+            <a:pPr>
+              <a:spcBef>
+                <a:spcPts val="500"/>
+              </a:spcBef>
+            </a:pPr>
+            <a:r>
+              <a:rPr sz="1900">
+                <a:solidFill>
+                  <a:srgbClr val="222222"/>
+                </a:solidFill>
+              </a:rPr>
+              <a:t>For CF06 CLLM I had Claude Sonnet 4.6 generate a 4-by-4 binary-weight crossbar MAC unit in SystemVerilog.</a:t>
+            </a:r>
+          </a:p>
+          <a:p>
+            <a:pPr>
+              <a:spcBef>
+                <a:spcPts val="500"/>
+              </a:spcBef>
+            </a:pPr>
+            <a:r>
+              <a:rPr sz="1900">
+                <a:solidFill>
+                  <a:srgbClr val="222222"/>
+                </a:solidFill>
+              </a:rPr>
+              <a:t/>
+            </a:r>
+          </a:p>
+          <a:p>
+            <a:pPr>
+              <a:spcBef>
+                <a:spcPts val="500"/>
+              </a:spcBef>
+            </a:pPr>
+            <a:r>
+              <a:rPr sz="1900">
+                <a:solidFill>
+                  <a:srgbClr val="222222"/>
+                </a:solidFill>
+              </a:rPr>
+              <a:t>So about the design. The module takes four 8-bit signed inputs, a 4-by-4 weight matrix</a:t>
+            </a:r>
+          </a:p>
+          <a:p>
+            <a:pPr>
+              <a:spcBef>
+                <a:spcPts val="500"/>
+              </a:spcBef>
+            </a:pPr>
+            <a:r>
+              <a:rPr sz="1900">
+                <a:solidFill>
+                  <a:srgbClr val="222222"/>
+                </a:solidFill>
+              </a:rPr>
+              <a:t>where each weight is either plus-one or minus-one, and produces four 10-bit signed outputs.</a:t>
+            </a:r>
+          </a:p>
+          <a:p>
+            <a:pPr>
+              <a:spcBef>
+                <a:spcPts val="500"/>
+              </a:spcBef>
+            </a:pPr>
+            <a:r>
+              <a:rPr sz="1900">
+                <a:solidFill>
+                  <a:srgbClr val="222222"/>
+                </a:solidFill>
+              </a:rPr>
+              <a:t>Each clock cycle, every output computes a dot product, so basically you multiply each input</a:t>
+            </a:r>
+          </a:p>
+          <a:p>
+            <a:pPr>
+              <a:spcBef>
+                <a:spcPts val="500"/>
+              </a:spcBef>
+            </a:pPr>
+            <a:r>
+              <a:rPr sz="1900">
+                <a:solidFill>
+                  <a:srgbClr val="222222"/>
+                </a:solidFill>
+              </a:rPr>
+              <a:t>by its weight at that row-column intersection and add them up. That's what the crossbar does,</a:t>
+            </a:r>
+          </a:p>
+          <a:p>
+            <a:pPr>
+              <a:spcBef>
+                <a:spcPts val="500"/>
+              </a:spcBef>
+            </a:pPr>
+            <a:r>
+              <a:rPr sz="1900">
+                <a:solidFill>
+                  <a:srgbClr val="222222"/>
+                </a:solidFill>
+              </a:rPr>
+              <a:t>a grid of wires where rows carry inputs, columns carry outputs, and the weights sit at the intersections.</a:t>
+            </a:r>
+          </a:p>
+        </p:txBody>
+      </p:sp>
       <p:pic>
         <p:nvPicPr>
-          <p:cNvPr id="6" name="Picture 5" descr="crossbar.png"/>
+          <p:cNvPr id="7" name="Picture 6" descr="crossbar.png"/>
           <p:cNvPicPr>
             <a:picLocks noChangeAspect="1"/>
           </p:cNvPicPr>
@@ -3480,142 +3607,14 @@
         </p:blipFill>
         <p:spPr>
           <a:xfrm>
-            <a:off x="274320" y="1188720"/>
-            <a:ext cx="5118152" cy="5029200"/>
+            <a:off x="7223760" y="731520"/>
+            <a:ext cx="5583438" cy="5486400"/>
           </a:xfrm>
           <a:prstGeom prst="rect">
             <a:avLst/>
           </a:prstGeom>
         </p:spPr>
       </p:pic>
-      <p:sp>
-        <p:nvSpPr>
-          <p:cNvPr id="7" name="TextBox 6"/>
-          <p:cNvSpPr txBox="1"/>
-          <p:nvPr/>
-        </p:nvSpPr>
-        <p:spPr>
-          <a:xfrm>
-            <a:off x="5486400" y="1371600"/>
-            <a:ext cx="6400800" cy="5029200"/>
-          </a:xfrm>
-          <a:prstGeom prst="rect">
-            <a:avLst/>
-          </a:prstGeom>
-          <a:noFill/>
-        </p:spPr>
-        <p:txBody>
-          <a:bodyPr wrap="square">
-            <a:spAutoFit/>
-          </a:bodyPr>
-          <a:lstStyle/>
-          <a:p>
-            <a:pPr>
-              <a:spcBef>
-                <a:spcPts val="400"/>
-              </a:spcBef>
-            </a:pPr>
-            <a:r>
-              <a:rPr sz="1700">
-                <a:solidFill>
-                  <a:srgbClr val="444444"/>
-                </a:solidFill>
-              </a:rPr>
-              <a:t>• Four 8-bit signed inputs (rows)</a:t>
-            </a:r>
-          </a:p>
-          <a:p>
-            <a:pPr>
-              <a:spcBef>
-                <a:spcPts val="400"/>
-              </a:spcBef>
-            </a:pPr>
-            <a:r>
-              <a:rPr sz="1700">
-                <a:solidFill>
-                  <a:srgbClr val="444444"/>
-                </a:solidFill>
-              </a:rPr>
-              <a:t>• 4×4 weight matrix — each weight is +1 or −1</a:t>
-            </a:r>
-          </a:p>
-          <a:p>
-            <a:pPr>
-              <a:spcBef>
-                <a:spcPts val="400"/>
-              </a:spcBef>
-            </a:pPr>
-            <a:r>
-              <a:rPr sz="1700">
-                <a:solidFill>
-                  <a:srgbClr val="444444"/>
-                </a:solidFill>
-              </a:rPr>
-              <a:t>• Four 10-bit signed outputs (columns)</a:t>
-            </a:r>
-          </a:p>
-          <a:p>
-            <a:pPr>
-              <a:spcBef>
-                <a:spcPts val="400"/>
-              </a:spcBef>
-            </a:pPr>
-            <a:r>
-              <a:rPr sz="1700">
-                <a:solidFill>
-                  <a:srgbClr val="444444"/>
-                </a:solidFill>
-              </a:rPr>
-              <a:t>• Each output computes a dot product every cycle</a:t>
-            </a:r>
-          </a:p>
-          <a:p>
-            <a:pPr>
-              <a:spcBef>
-                <a:spcPts val="400"/>
-              </a:spcBef>
-            </a:pPr>
-            <a:r>
-              <a:rPr sz="1700">
-                <a:solidFill>
-                  <a:srgbClr val="444444"/>
-                </a:solidFill>
-              </a:rPr>
-              <a:t>• Grid of wires — weights sit at the intersections</a:t>
-            </a:r>
-          </a:p>
-          <a:p>
-            <a:pPr>
-              <a:spcBef>
-                <a:spcPts val="400"/>
-              </a:spcBef>
-            </a:pPr>
-            <a:r>
-              <a:rPr sz="1700">
-                <a:solidFill>
-                  <a:srgbClr val="444444"/>
-                </a:solidFill>
-              </a:rPr>
-              <a:t>• so basically you multiply each input by its weight</a:t>
-            </a:r>
-          </a:p>
-          <a:p>
-            <a:pPr lvl="1">
-              <a:spcBef>
-                <a:spcPts val="400"/>
-              </a:spcBef>
-            </a:pPr>
-            <a:r>
-              <a:rPr sz="1700">
-                <a:solidFill>
-                  <a:srgbClr val="444444"/>
-                </a:solidFill>
-              </a:rPr>
-              <a:t>  – at that row-column intersection and add them up</a:t>
-            </a:r>
-          </a:p>
-        </p:txBody>
-      </p:sp>
     </p:spTree>
   </p:cSld>
   <p:clrMapOvr>
@@ -3649,7 +3648,7 @@
             <a:avLst/>
           </a:prstGeom>
           <a:solidFill>
-            <a:srgbClr val="F2F2F2"/>
+            <a:srgbClr val="F4F4F4"/>
           </a:solidFill>
           <a:ln>
             <a:noFill/>
@@ -3686,7 +3685,7 @@
         <p:spPr>
           <a:xfrm>
             <a:off x="0" y="0"/>
-            <a:ext cx="12188952" cy="1005840"/>
+            <a:ext cx="12188952" cy="502920"/>
           </a:xfrm>
           <a:prstGeom prst="rect">
             <a:avLst/>
@@ -3722,47 +3721,13 @@
       </p:sp>
       <p:sp>
         <p:nvSpPr>
-          <p:cNvPr id="4" name="TextBox 3"/>
-          <p:cNvSpPr txBox="1"/>
-          <p:nvPr/>
-        </p:nvSpPr>
-        <p:spPr>
-          <a:xfrm>
-            <a:off x="274320" y="91440"/>
-            <a:ext cx="11612880" cy="822960"/>
-          </a:xfrm>
-          <a:prstGeom prst="rect">
-            <a:avLst/>
-          </a:prstGeom>
-          <a:noFill/>
-        </p:spPr>
-        <p:txBody>
-          <a:bodyPr wrap="square">
-            <a:spAutoFit/>
-          </a:bodyPr>
-          <a:lstStyle/>
-          <a:p>
-            <a:pPr algn="l"/>
-            <a:r>
-              <a:rPr sz="3200" b="1">
-                <a:solidFill>
-                  <a:srgbClr val="FFFFFF"/>
-                </a:solidFill>
-              </a:rPr>
-              <a:t>Module Architecture — 3 Stages</a:t>
-            </a:r>
-          </a:p>
-        </p:txBody>
-      </p:sp>
-      <p:sp>
-        <p:nvSpPr>
-          <p:cNvPr id="5" name="Rectangle 4"/>
+          <p:cNvPr id="4" name="Rectangle 3"/>
           <p:cNvSpPr/>
           <p:nvPr/>
         </p:nvSpPr>
         <p:spPr>
           <a:xfrm>
-            <a:off x="0" y="1005840"/>
+            <a:off x="0" y="502920"/>
             <a:ext cx="12188952" cy="54864"/>
           </a:xfrm>
           <a:prstGeom prst="rect">
@@ -3797,9 +3762,171 @@
           </a:p>
         </p:txBody>
       </p:sp>
+      <p:sp>
+        <p:nvSpPr>
+          <p:cNvPr id="5" name="TextBox 4"/>
+          <p:cNvSpPr txBox="1"/>
+          <p:nvPr/>
+        </p:nvSpPr>
+        <p:spPr>
+          <a:xfrm>
+            <a:off x="228600" y="54864"/>
+            <a:ext cx="11887200" cy="438912"/>
+          </a:xfrm>
+          <a:prstGeom prst="rect">
+            <a:avLst/>
+          </a:prstGeom>
+          <a:noFill/>
+        </p:spPr>
+        <p:txBody>
+          <a:bodyPr wrap="none">
+            <a:spAutoFit/>
+          </a:bodyPr>
+          <a:lstStyle/>
+          <a:p>
+            <a:pPr algn="l"/>
+            <a:r>
+              <a:rPr sz="2200" b="1">
+                <a:solidFill>
+                  <a:srgbClr val="FFFFFF"/>
+                </a:solidFill>
+              </a:rPr>
+              <a:t>The Design — 3 Stages</a:t>
+            </a:r>
+          </a:p>
+        </p:txBody>
+      </p:sp>
+      <p:sp>
+        <p:nvSpPr>
+          <p:cNvPr id="6" name="TextBox 5"/>
+          <p:cNvSpPr txBox="1"/>
+          <p:nvPr/>
+        </p:nvSpPr>
+        <p:spPr>
+          <a:xfrm>
+            <a:off x="274320" y="685800"/>
+            <a:ext cx="6858000" cy="4572000"/>
+          </a:xfrm>
+          <a:prstGeom prst="rect">
+            <a:avLst/>
+          </a:prstGeom>
+          <a:noFill/>
+        </p:spPr>
+        <p:txBody>
+          <a:bodyPr wrap="square">
+            <a:spAutoFit/>
+          </a:bodyPr>
+          <a:lstStyle/>
+          <a:p>
+            <a:pPr>
+              <a:spcBef>
+                <a:spcPts val="500"/>
+              </a:spcBef>
+            </a:pPr>
+            <a:r>
+              <a:rPr sz="1900">
+                <a:solidFill>
+                  <a:srgbClr val="222222"/>
+                </a:solidFill>
+              </a:rPr>
+              <a:t>The module has three stages. First stage is the weight register, it's a flip-flop that latches</a:t>
+            </a:r>
+          </a:p>
+          <a:p>
+            <a:pPr>
+              <a:spcBef>
+                <a:spcPts val="500"/>
+              </a:spcBef>
+            </a:pPr>
+            <a:r>
+              <a:rPr sz="1900">
+                <a:solidFill>
+                  <a:srgbClr val="222222"/>
+                </a:solidFill>
+              </a:rPr>
+              <a:t>the full weight matrix when you pulse weight_load high. Claude packed the entire 4-by-4 matrix</a:t>
+            </a:r>
+          </a:p>
+          <a:p>
+            <a:pPr>
+              <a:spcBef>
+                <a:spcPts val="500"/>
+              </a:spcBef>
+            </a:pPr>
+            <a:r>
+              <a:rPr sz="1900">
+                <a:solidFill>
+                  <a:srgbClr val="222222"/>
+                </a:solidFill>
+              </a:rPr>
+              <a:t>into a single 16-bit flat register, where bit 4i plus j holds weight[i][j]. For an example,</a:t>
+            </a:r>
+          </a:p>
+          <a:p>
+            <a:pPr>
+              <a:spcBef>
+                <a:spcPts val="500"/>
+              </a:spcBef>
+            </a:pPr>
+            <a:r>
+              <a:rPr sz="1900">
+                <a:solidFill>
+                  <a:srgbClr val="222222"/>
+                </a:solidFill>
+              </a:rPr>
+              <a:t>bit zero is weight[0][0], bit four would be weight[1][0], and so on. I asked Claude why it</a:t>
+            </a:r>
+          </a:p>
+          <a:p>
+            <a:pPr>
+              <a:spcBef>
+                <a:spcPts val="500"/>
+              </a:spcBef>
+            </a:pPr>
+            <a:r>
+              <a:rPr sz="1900">
+                <a:solidFill>
+                  <a:srgbClr val="222222"/>
+                </a:solidFill>
+              </a:rPr>
+              <a:t>went with a flat register and it said it actually loads the entire matrix in exactly one clock</a:t>
+            </a:r>
+          </a:p>
+          <a:p>
+            <a:pPr>
+              <a:spcBef>
+                <a:spcPts val="500"/>
+              </a:spcBef>
+            </a:pPr>
+            <a:r>
+              <a:rPr sz="1900">
+                <a:solidFill>
+                  <a:srgbClr val="222222"/>
+                </a:solidFill>
+              </a:rPr>
+              <a:t>cycle. Like if you loaded row by row, that would've taken four cycles and you'd need an address</a:t>
+            </a:r>
+          </a:p>
+          <a:p>
+            <a:pPr>
+              <a:spcBef>
+                <a:spcPts val="500"/>
+              </a:spcBef>
+            </a:pPr>
+            <a:r>
+              <a:rPr sz="1900">
+                <a:solidFill>
+                  <a:srgbClr val="222222"/>
+                </a:solidFill>
+              </a:rPr>
+              <a:t>counter to track which row you're on, so the flat register just keeps it simple.</a:t>
+            </a:r>
+          </a:p>
+        </p:txBody>
+      </p:sp>
       <p:pic>
         <p:nvPicPr>
-          <p:cNvPr id="6" name="Picture 5" descr="pipeline.png"/>
+          <p:cNvPr id="7" name="Picture 6" descr="pipeline.png"/>
           <p:cNvPicPr>
             <a:picLocks noChangeAspect="1"/>
           </p:cNvPicPr>
@@ -3813,127 +3940,38 @@
         </p:blipFill>
         <p:spPr>
           <a:xfrm>
-            <a:off x="274320" y="1280160"/>
-            <a:ext cx="11430000" cy="4220756"/>
+            <a:off x="274320" y="5303520"/>
+            <a:ext cx="6858000" cy="2532453"/>
           </a:xfrm>
           <a:prstGeom prst="rect">
             <a:avLst/>
           </a:prstGeom>
         </p:spPr>
       </p:pic>
-      <p:sp>
-        <p:nvSpPr>
-          <p:cNvPr id="7" name="TextBox 6"/>
-          <p:cNvSpPr txBox="1"/>
+      <p:pic>
+        <p:nvPicPr>
+          <p:cNvPr id="8" name="Picture 7" descr="encoding.png"/>
+          <p:cNvPicPr>
+            <a:picLocks noChangeAspect="1"/>
+          </p:cNvPicPr>
           <p:nvPr/>
-        </p:nvSpPr>
-        <p:spPr>
-          <a:xfrm>
-            <a:off x="365760" y="4023360"/>
-            <a:ext cx="11430000" cy="2651760"/>
+        </p:nvPicPr>
+        <p:blipFill>
+          <a:blip r:embed="rId3"/>
+          <a:stretch>
+            <a:fillRect/>
+          </a:stretch>
+        </p:blipFill>
+        <p:spPr>
+          <a:xfrm>
+            <a:off x="7223760" y="685800"/>
+            <a:ext cx="4754880" cy="1621073"/>
           </a:xfrm>
           <a:prstGeom prst="rect">
             <a:avLst/>
           </a:prstGeom>
-          <a:noFill/>
-        </p:spPr>
-        <p:txBody>
-          <a:bodyPr wrap="square">
-            <a:spAutoFit/>
-          </a:bodyPr>
-          <a:lstStyle/>
-          <a:p>
-            <a:pPr>
-              <a:spcBef>
-                <a:spcPts val="400"/>
-              </a:spcBef>
-            </a:pPr>
-            <a:r>
-              <a:rPr sz="1600">
-                <a:solidFill>
-                  <a:srgbClr val="444444"/>
-                </a:solidFill>
-              </a:rPr>
-              <a:t>• Stage 1 — Weight Register</a:t>
-            </a:r>
-          </a:p>
-          <a:p>
-            <a:pPr lvl="1">
-              <a:spcBef>
-                <a:spcPts val="400"/>
-              </a:spcBef>
-            </a:pPr>
-            <a:r>
-              <a:rPr sz="1600">
-                <a:solidFill>
-                  <a:srgbClr val="444444"/>
-                </a:solidFill>
-              </a:rPr>
-              <a:t>  – flip-flop that latches full 4×4 matrix on weight_load</a:t>
-            </a:r>
-          </a:p>
-          <a:p>
-            <a:pPr>
-              <a:spcBef>
-                <a:spcPts val="400"/>
-              </a:spcBef>
-            </a:pPr>
-            <a:r>
-              <a:rPr sz="1600">
-                <a:solidFill>
-                  <a:srgbClr val="444444"/>
-                </a:solidFill>
-              </a:rPr>
-              <a:t>• Stage 2 — Combinational MAC</a:t>
-            </a:r>
-          </a:p>
-          <a:p>
-            <a:pPr lvl="1">
-              <a:spcBef>
-                <a:spcPts val="400"/>
-              </a:spcBef>
-            </a:pPr>
-            <a:r>
-              <a:rPr sz="1600">
-                <a:solidFill>
-                  <a:srgbClr val="444444"/>
-                </a:solidFill>
-              </a:rPr>
-              <a:t>  – just wires, no clock — computes all 4 dot products at the same time</a:t>
-            </a:r>
-          </a:p>
-          <a:p>
-            <a:pPr>
-              <a:spcBef>
-                <a:spcPts val="400"/>
-              </a:spcBef>
-            </a:pPr>
-            <a:r>
-              <a:rPr sz="1600">
-                <a:solidFill>
-                  <a:srgbClr val="444444"/>
-                </a:solidFill>
-              </a:rPr>
-              <a:t>• Stage 3 — Output Register</a:t>
-            </a:r>
-          </a:p>
-          <a:p>
-            <a:pPr lvl="1">
-              <a:spcBef>
-                <a:spcPts val="400"/>
-              </a:spcBef>
-            </a:pPr>
-            <a:r>
-              <a:rPr sz="1600">
-                <a:solidFill>
-                  <a:srgbClr val="444444"/>
-                </a:solidFill>
-              </a:rPr>
-              <a:t>  – latches results on next rising edge</a:t>
-            </a:r>
-          </a:p>
-        </p:txBody>
-      </p:sp>
+        </p:spPr>
+      </p:pic>
     </p:spTree>
   </p:cSld>
   <p:clrMapOvr>
@@ -3967,7 +4005,7 @@
             <a:avLst/>
           </a:prstGeom>
           <a:solidFill>
-            <a:srgbClr val="F2F2F2"/>
+            <a:srgbClr val="F4F4F4"/>
           </a:solidFill>
           <a:ln>
             <a:noFill/>
@@ -4004,7 +4042,7 @@
         <p:spPr>
           <a:xfrm>
             <a:off x="0" y="0"/>
-            <a:ext cx="12188952" cy="1005840"/>
+            <a:ext cx="12188952" cy="502920"/>
           </a:xfrm>
           <a:prstGeom prst="rect">
             <a:avLst/>
@@ -4040,47 +4078,13 @@
       </p:sp>
       <p:sp>
         <p:nvSpPr>
-          <p:cNvPr id="4" name="TextBox 3"/>
-          <p:cNvSpPr txBox="1"/>
-          <p:nvPr/>
-        </p:nvSpPr>
-        <p:spPr>
-          <a:xfrm>
-            <a:off x="274320" y="91440"/>
-            <a:ext cx="11612880" cy="822960"/>
-          </a:xfrm>
-          <a:prstGeom prst="rect">
-            <a:avLst/>
-          </a:prstGeom>
-          <a:noFill/>
-        </p:spPr>
-        <p:txBody>
-          <a:bodyPr wrap="square">
-            <a:spAutoFit/>
-          </a:bodyPr>
-          <a:lstStyle/>
-          <a:p>
-            <a:pPr algn="l"/>
-            <a:r>
-              <a:rPr sz="3200" b="1">
-                <a:solidFill>
-                  <a:srgbClr val="FFFFFF"/>
-                </a:solidFill>
-              </a:rPr>
-              <a:t>Weight Encoding — Flat 16-bit Register</a:t>
-            </a:r>
-          </a:p>
-        </p:txBody>
-      </p:sp>
-      <p:sp>
-        <p:nvSpPr>
-          <p:cNvPr id="5" name="Rectangle 4"/>
+          <p:cNvPr id="4" name="Rectangle 3"/>
           <p:cNvSpPr/>
           <p:nvPr/>
         </p:nvSpPr>
         <p:spPr>
           <a:xfrm>
-            <a:off x="0" y="1005840"/>
+            <a:off x="0" y="502920"/>
             <a:ext cx="12188952" cy="54864"/>
           </a:xfrm>
           <a:prstGeom prst="rect">
@@ -4115,9 +4119,156 @@
           </a:p>
         </p:txBody>
       </p:sp>
+      <p:sp>
+        <p:nvSpPr>
+          <p:cNvPr id="5" name="TextBox 4"/>
+          <p:cNvSpPr txBox="1"/>
+          <p:nvPr/>
+        </p:nvSpPr>
+        <p:spPr>
+          <a:xfrm>
+            <a:off x="228600" y="54864"/>
+            <a:ext cx="11887200" cy="438912"/>
+          </a:xfrm>
+          <a:prstGeom prst="rect">
+            <a:avLst/>
+          </a:prstGeom>
+          <a:noFill/>
+        </p:spPr>
+        <p:txBody>
+          <a:bodyPr wrap="none">
+            <a:spAutoFit/>
+          </a:bodyPr>
+          <a:lstStyle/>
+          <a:p>
+            <a:pPr algn="l"/>
+            <a:r>
+              <a:rPr sz="2200" b="1">
+                <a:solidFill>
+                  <a:srgbClr val="FFFFFF"/>
+                </a:solidFill>
+              </a:rPr>
+              <a:t>The Design — MAC &amp; Output Bit Width</a:t>
+            </a:r>
+          </a:p>
+        </p:txBody>
+      </p:sp>
+      <p:sp>
+        <p:nvSpPr>
+          <p:cNvPr id="6" name="TextBox 5"/>
+          <p:cNvSpPr txBox="1"/>
+          <p:nvPr/>
+        </p:nvSpPr>
+        <p:spPr>
+          <a:xfrm>
+            <a:off x="274320" y="685800"/>
+            <a:ext cx="6858000" cy="5029200"/>
+          </a:xfrm>
+          <a:prstGeom prst="rect">
+            <a:avLst/>
+          </a:prstGeom>
+          <a:noFill/>
+        </p:spPr>
+        <p:txBody>
+          <a:bodyPr wrap="square">
+            <a:spAutoFit/>
+          </a:bodyPr>
+          <a:lstStyle/>
+          <a:p>
+            <a:pPr>
+              <a:spcBef>
+                <a:spcPts val="500"/>
+              </a:spcBef>
+            </a:pPr>
+            <a:r>
+              <a:rPr sz="1900">
+                <a:solidFill>
+                  <a:srgbClr val="222222"/>
+                </a:solidFill>
+              </a:rPr>
+              <a:t>The second stage is the combinational MAC, those are just wires, no clock, which sign-extends</a:t>
+            </a:r>
+          </a:p>
+          <a:p>
+            <a:pPr>
+              <a:spcBef>
+                <a:spcPts val="500"/>
+              </a:spcBef>
+            </a:pPr>
+            <a:r>
+              <a:rPr sz="1900">
+                <a:solidFill>
+                  <a:srgbClr val="222222"/>
+                </a:solidFill>
+              </a:rPr>
+              <a:t>the inputs to 10 bits and computes all four dot products at the same time. Then the third stage</a:t>
+            </a:r>
+          </a:p>
+          <a:p>
+            <a:pPr>
+              <a:spcBef>
+                <a:spcPts val="500"/>
+              </a:spcBef>
+            </a:pPr>
+            <a:r>
+              <a:rPr sz="1900">
+                <a:solidFill>
+                  <a:srgbClr val="222222"/>
+                </a:solidFill>
+              </a:rPr>
+              <a:t>is the output register, which latches the results on the next rising edge.</a:t>
+            </a:r>
+          </a:p>
+          <a:p>
+            <a:pPr>
+              <a:spcBef>
+                <a:spcPts val="500"/>
+              </a:spcBef>
+            </a:pPr>
+            <a:r>
+              <a:rPr sz="1900">
+                <a:solidFill>
+                  <a:srgbClr val="222222"/>
+                </a:solidFill>
+              </a:rPr>
+              <a:t/>
+            </a:r>
+          </a:p>
+          <a:p>
+            <a:pPr>
+              <a:spcBef>
+                <a:spcPts val="500"/>
+              </a:spcBef>
+            </a:pPr>
+            <a:r>
+              <a:rPr sz="1900">
+                <a:solidFill>
+                  <a:srgbClr val="222222"/>
+                </a:solidFill>
+              </a:rPr>
+              <a:t>As for the output bit width, worst case is four inputs at plus or minus 127, so 4 times 127</a:t>
+            </a:r>
+          </a:p>
+          <a:p>
+            <a:pPr>
+              <a:spcBef>
+                <a:spcPts val="500"/>
+              </a:spcBef>
+            </a:pPr>
+            <a:r>
+              <a:rPr sz="1900">
+                <a:solidFill>
+                  <a:srgbClr val="222222"/>
+                </a:solidFill>
+              </a:rPr>
+              <a:t>is 508. And 10-bit signed goes up to 511, which clears the threshold we need.</a:t>
+            </a:r>
+          </a:p>
+        </p:txBody>
+      </p:sp>
       <p:pic>
         <p:nvPicPr>
-          <p:cNvPr id="6" name="Picture 5" descr="encoding.png"/>
+          <p:cNvPr id="7" name="Picture 6" descr="pipeline.png"/>
           <p:cNvPicPr>
             <a:picLocks noChangeAspect="1"/>
           </p:cNvPicPr>
@@ -4131,112 +4282,14 @@
         </p:blipFill>
         <p:spPr>
           <a:xfrm>
-            <a:off x="274320" y="1188720"/>
-            <a:ext cx="11430000" cy="3896810"/>
+            <a:off x="7223760" y="685800"/>
+            <a:ext cx="4754880" cy="1755834"/>
           </a:xfrm>
           <a:prstGeom prst="rect">
             <a:avLst/>
           </a:prstGeom>
         </p:spPr>
       </p:pic>
-      <p:sp>
-        <p:nvSpPr>
-          <p:cNvPr id="7" name="TextBox 6"/>
-          <p:cNvSpPr txBox="1"/>
-          <p:nvPr/>
-        </p:nvSpPr>
-        <p:spPr>
-          <a:xfrm>
-            <a:off x="365760" y="3749039"/>
-            <a:ext cx="11430000" cy="2651760"/>
-          </a:xfrm>
-          <a:prstGeom prst="rect">
-            <a:avLst/>
-          </a:prstGeom>
-          <a:noFill/>
-        </p:spPr>
-        <p:txBody>
-          <a:bodyPr wrap="square">
-            <a:spAutoFit/>
-          </a:bodyPr>
-          <a:lstStyle/>
-          <a:p>
-            <a:pPr>
-              <a:spcBef>
-                <a:spcPts val="400"/>
-              </a:spcBef>
-            </a:pPr>
-            <a:r>
-              <a:rPr sz="1700">
-                <a:solidFill>
-                  <a:srgbClr val="444444"/>
-                </a:solidFill>
-              </a:rPr>
-              <a:t>• bit (4i + j) holds weight[i][j]</a:t>
-            </a:r>
-          </a:p>
-          <a:p>
-            <a:pPr lvl="1">
-              <a:spcBef>
-                <a:spcPts val="400"/>
-              </a:spcBef>
-            </a:pPr>
-            <a:r>
-              <a:rPr sz="1700">
-                <a:solidFill>
-                  <a:srgbClr val="444444"/>
-                </a:solidFill>
-              </a:rPr>
-              <a:t>  – For an example: bit 0 = w[0][0],  bit 4 = w[1][0]</a:t>
-            </a:r>
-          </a:p>
-          <a:p>
-            <a:pPr>
-              <a:spcBef>
-                <a:spcPts val="400"/>
-              </a:spcBef>
-            </a:pPr>
-            <a:r>
-              <a:rPr sz="1700">
-                <a:solidFill>
-                  <a:srgbClr val="444444"/>
-                </a:solidFill>
-              </a:rPr>
-              <a:t>• Loads the entire 4×4 matrix in exactly 1 clock cycle</a:t>
-            </a:r>
-          </a:p>
-          <a:p>
-            <a:pPr>
-              <a:spcBef>
-                <a:spcPts val="400"/>
-              </a:spcBef>
-            </a:pPr>
-            <a:r>
-              <a:rPr sz="1700">
-                <a:solidFill>
-                  <a:srgbClr val="444444"/>
-                </a:solidFill>
-              </a:rPr>
-              <a:t>• vs. row-by-row: 4 cycles + an address counter on top of that</a:t>
-            </a:r>
-          </a:p>
-          <a:p>
-            <a:pPr>
-              <a:spcBef>
-                <a:spcPts val="400"/>
-              </a:spcBef>
-            </a:pPr>
-            <a:r>
-              <a:rPr sz="1700">
-                <a:solidFill>
-                  <a:srgbClr val="444444"/>
-                </a:solidFill>
-              </a:rPr>
-              <a:t>• Claude went with flat register to keep it simple</a:t>
-            </a:r>
-          </a:p>
-        </p:txBody>
-      </p:sp>
     </p:spTree>
   </p:cSld>
   <p:clrMapOvr>
@@ -4270,7 +4323,7 @@
             <a:avLst/>
           </a:prstGeom>
           <a:solidFill>
-            <a:srgbClr val="F2F2F2"/>
+            <a:srgbClr val="F4F4F4"/>
           </a:solidFill>
           <a:ln>
             <a:noFill/>
@@ -4307,7 +4360,7 @@
         <p:spPr>
           <a:xfrm>
             <a:off x="0" y="0"/>
-            <a:ext cx="12188952" cy="1005840"/>
+            <a:ext cx="12188952" cy="502920"/>
           </a:xfrm>
           <a:prstGeom prst="rect">
             <a:avLst/>
@@ -4343,47 +4396,13 @@
       </p:sp>
       <p:sp>
         <p:nvSpPr>
-          <p:cNvPr id="4" name="TextBox 3"/>
-          <p:cNvSpPr txBox="1"/>
-          <p:nvPr/>
-        </p:nvSpPr>
-        <p:spPr>
-          <a:xfrm>
-            <a:off x="274320" y="91440"/>
-            <a:ext cx="11612880" cy="822960"/>
-          </a:xfrm>
-          <a:prstGeom prst="rect">
-            <a:avLst/>
-          </a:prstGeom>
-          <a:noFill/>
-        </p:spPr>
-        <p:txBody>
-          <a:bodyPr wrap="square">
-            <a:spAutoFit/>
-          </a:bodyPr>
-          <a:lstStyle/>
-          <a:p>
-            <a:pPr algn="l"/>
-            <a:r>
-              <a:rPr sz="3200" b="1">
-                <a:solidFill>
-                  <a:srgbClr val="FFFFFF"/>
-                </a:solidFill>
-              </a:rPr>
-              <a:t>Output Bit Width — Why 10 Bits?</a:t>
-            </a:r>
-          </a:p>
-        </p:txBody>
-      </p:sp>
-      <p:sp>
-        <p:nvSpPr>
-          <p:cNvPr id="5" name="Rectangle 4"/>
+          <p:cNvPr id="4" name="Rectangle 3"/>
           <p:cNvSpPr/>
           <p:nvPr/>
         </p:nvSpPr>
         <p:spPr>
           <a:xfrm>
-            <a:off x="0" y="1005840"/>
+            <a:off x="0" y="502920"/>
             <a:ext cx="12188952" cy="54864"/>
           </a:xfrm>
           <a:prstGeom prst="rect">
@@ -4420,14 +4439,14 @@
       </p:sp>
       <p:sp>
         <p:nvSpPr>
-          <p:cNvPr id="6" name="TextBox 5"/>
+          <p:cNvPr id="5" name="TextBox 4"/>
           <p:cNvSpPr txBox="1"/>
           <p:nvPr/>
         </p:nvSpPr>
         <p:spPr>
           <a:xfrm>
-            <a:off x="914400" y="1371600"/>
-            <a:ext cx="4572000" cy="457200"/>
+            <a:off x="228600" y="54864"/>
+            <a:ext cx="11887200" cy="438912"/>
           </a:xfrm>
           <a:prstGeom prst="rect">
             <a:avLst/>
@@ -4435,78 +4454,33 @@
           <a:noFill/>
         </p:spPr>
         <p:txBody>
-          <a:bodyPr wrap="square">
+          <a:bodyPr wrap="none">
             <a:spAutoFit/>
           </a:bodyPr>
           <a:lstStyle/>
           <a:p>
             <a:pPr algn="l"/>
             <a:r>
-              <a:rPr sz="1800" b="1">
-                <a:solidFill>
-                  <a:srgbClr val="1F4E79"/>
+              <a:rPr sz="2200" b="1">
+                <a:solidFill>
+                  <a:srgbClr val="FFFFFF"/>
                 </a:solidFill>
               </a:rPr>
-              <a:t>Worst case:</a:t>
-            </a:r>
-          </a:p>
-        </p:txBody>
-      </p:sp>
-      <p:sp>
-        <p:nvSpPr>
-          <p:cNvPr id="7" name="Rectangle 6"/>
-          <p:cNvSpPr/>
-          <p:nvPr/>
-        </p:nvSpPr>
-        <p:spPr>
-          <a:xfrm>
-            <a:off x="731520" y="1920240"/>
-            <a:ext cx="5029200" cy="822960"/>
-          </a:xfrm>
-          <a:prstGeom prst="rect">
-            <a:avLst/>
-          </a:prstGeom>
-          <a:solidFill>
-            <a:srgbClr val="FFFFFF"/>
-          </a:solidFill>
-          <a:ln w="12700">
-            <a:solidFill>
-              <a:srgbClr val="1F4E79"/>
-            </a:solidFill>
-          </a:ln>
-        </p:spPr>
-        <p:style>
-          <a:lnRef idx="1">
-            <a:schemeClr val="accent1"/>
-          </a:lnRef>
-          <a:fillRef idx="3">
-            <a:schemeClr val="accent1"/>
-          </a:fillRef>
-          <a:effectRef idx="2">
-            <a:schemeClr val="accent1"/>
-          </a:effectRef>
-          <a:fontRef idx="minor">
-            <a:schemeClr val="lt1"/>
-          </a:fontRef>
-        </p:style>
-        <p:txBody>
-          <a:bodyPr rtlCol="0" anchor="ctr"/>
-          <a:lstStyle/>
-          <a:p>
-            <a:pPr algn="ctr"/>
-          </a:p>
-        </p:txBody>
-      </p:sp>
-      <p:sp>
-        <p:nvSpPr>
-          <p:cNvPr id="8" name="TextBox 7"/>
+              <a:t>The Testbench — Setup</a:t>
+            </a:r>
+          </a:p>
+        </p:txBody>
+      </p:sp>
+      <p:sp>
+        <p:nvSpPr>
+          <p:cNvPr id="6" name="TextBox 5"/>
           <p:cNvSpPr txBox="1"/>
           <p:nvPr/>
         </p:nvSpPr>
         <p:spPr>
           <a:xfrm>
-            <a:off x="822960" y="1993392"/>
-            <a:ext cx="4846320" cy="365760"/>
+            <a:off x="274320" y="685800"/>
+            <a:ext cx="6858000" cy="5943600"/>
           </a:xfrm>
           <a:prstGeom prst="rect">
             <a:avLst/>
@@ -4519,493 +4493,151 @@
           </a:bodyPr>
           <a:lstStyle/>
           <a:p>
-            <a:pPr algn="l"/>
-            <a:r>
-              <a:rPr sz="1400" b="0">
-                <a:solidFill>
-                  <a:srgbClr val="444444"/>
+            <a:pPr>
+              <a:spcBef>
+                <a:spcPts val="500"/>
+              </a:spcBef>
+            </a:pPr>
+            <a:r>
+              <a:rPr sz="1900">
+                <a:solidFill>
+                  <a:srgbClr val="222222"/>
                 </a:solidFill>
               </a:rPr>
-              <a:t>4 inputs × max value</a:t>
-            </a:r>
-          </a:p>
-        </p:txBody>
-      </p:sp>
-      <p:sp>
-        <p:nvSpPr>
-          <p:cNvPr id="9" name="TextBox 8"/>
-          <p:cNvSpPr txBox="1"/>
+              <a:t>So about the testbench. Claude loaded the weight matrix from the assignment spec, which is</a:t>
+            </a:r>
+          </a:p>
+          <a:p>
+            <a:pPr>
+              <a:spcBef>
+                <a:spcPts val="500"/>
+              </a:spcBef>
+            </a:pPr>
+            <a:r>
+              <a:rPr sz="1900">
+                <a:solidFill>
+                  <a:srgbClr val="222222"/>
+                </a:solidFill>
+              </a:rPr>
+              <a:t>plus-one, minus-one, plus-one, minus-one on row zero, plus-one, plus-one, minus-one, minus-one</a:t>
+            </a:r>
+          </a:p>
+          <a:p>
+            <a:pPr>
+              <a:spcBef>
+                <a:spcPts val="500"/>
+              </a:spcBef>
+            </a:pPr>
+            <a:r>
+              <a:rPr sz="1900">
+                <a:solidFill>
+                  <a:srgbClr val="222222"/>
+                </a:solidFill>
+              </a:rPr>
+              <a:t>on row one, and so on, and then it applied inputs of 10, 20, 30, and 40.</a:t>
+            </a:r>
+          </a:p>
+          <a:p>
+            <a:pPr>
+              <a:spcBef>
+                <a:spcPts val="500"/>
+              </a:spcBef>
+            </a:pPr>
+            <a:r>
+              <a:rPr sz="1900">
+                <a:solidFill>
+                  <a:srgbClr val="222222"/>
+                </a:solidFill>
+              </a:rPr>
+              <a:t/>
+            </a:r>
+          </a:p>
+          <a:p>
+            <a:pPr>
+              <a:spcBef>
+                <a:spcPts val="500"/>
+              </a:spcBef>
+            </a:pPr>
+            <a:r>
+              <a:rPr sz="1900">
+                <a:solidFill>
+                  <a:srgbClr val="222222"/>
+                </a:solidFill>
+              </a:rPr>
+              <a:t>Before running the simulation I hand-calculated the expected outputs, so for example, column zero,</a:t>
+            </a:r>
+          </a:p>
+          <a:p>
+            <a:pPr>
+              <a:spcBef>
+                <a:spcPts val="500"/>
+              </a:spcBef>
+            </a:pPr>
+            <a:r>
+              <a:rPr sz="1900">
+                <a:solidFill>
+                  <a:srgbClr val="222222"/>
+                </a:solidFill>
+              </a:rPr>
+              <a:t>you get plus-ten from row 0, plus-twenty from row 1, and then minus-thirty and minus-forty from</a:t>
+            </a:r>
+          </a:p>
+          <a:p>
+            <a:pPr>
+              <a:spcBef>
+                <a:spcPts val="500"/>
+              </a:spcBef>
+            </a:pPr>
+            <a:r>
+              <a:rPr sz="1900">
+                <a:solidFill>
+                  <a:srgbClr val="222222"/>
+                </a:solidFill>
+              </a:rPr>
+              <a:t>rows 2 and 3, and so that adds up to minus-40. I did the same for all four columns and got</a:t>
+            </a:r>
+          </a:p>
+          <a:p>
+            <a:pPr>
+              <a:spcBef>
+                <a:spcPts val="500"/>
+              </a:spcBef>
+            </a:pPr>
+            <a:r>
+              <a:rPr sz="1900">
+                <a:solidFill>
+                  <a:srgbClr val="222222"/>
+                </a:solidFill>
+              </a:rPr>
+              <a:t>minus-40, zero, minus-20, and minus-20.</a:t>
+            </a:r>
+          </a:p>
+        </p:txBody>
+      </p:sp>
+      <p:pic>
+        <p:nvPicPr>
+          <p:cNvPr id="7" name="Picture 6" descr="crossbar.png"/>
+          <p:cNvPicPr>
+            <a:picLocks noChangeAspect="1"/>
+          </p:cNvPicPr>
           <p:nvPr/>
-        </p:nvSpPr>
-        <p:spPr>
-          <a:xfrm>
-            <a:off x="822960" y="2304288"/>
-            <a:ext cx="4846320" cy="411480"/>
+        </p:nvPicPr>
+        <p:blipFill>
+          <a:blip r:embed="rId2"/>
+          <a:stretch>
+            <a:fillRect/>
+          </a:stretch>
+        </p:blipFill>
+        <p:spPr>
+          <a:xfrm>
+            <a:off x="7223760" y="731520"/>
+            <a:ext cx="5583438" cy="5486400"/>
           </a:xfrm>
           <a:prstGeom prst="rect">
             <a:avLst/>
           </a:prstGeom>
-          <a:noFill/>
-        </p:spPr>
-        <p:txBody>
-          <a:bodyPr wrap="square">
-            <a:spAutoFit/>
-          </a:bodyPr>
-          <a:lstStyle/>
-          <a:p>
-            <a:pPr algn="l"/>
-            <a:r>
-              <a:rPr sz="1800" b="1">
-                <a:solidFill>
-                  <a:srgbClr val="1F4E79"/>
-                </a:solidFill>
-              </a:rPr>
-              <a:t>4 × 127  =  508</a:t>
-            </a:r>
-          </a:p>
-        </p:txBody>
-      </p:sp>
-      <p:sp>
-        <p:nvSpPr>
-          <p:cNvPr id="10" name="TextBox 9"/>
-          <p:cNvSpPr txBox="1"/>
-          <p:nvPr/>
-        </p:nvSpPr>
-        <p:spPr>
-          <a:xfrm>
-            <a:off x="3200400" y="2788920"/>
-            <a:ext cx="457200" cy="274320"/>
-          </a:xfrm>
-          <a:prstGeom prst="rect">
-            <a:avLst/>
-          </a:prstGeom>
-          <a:noFill/>
-        </p:spPr>
-        <p:txBody>
-          <a:bodyPr wrap="square">
-            <a:spAutoFit/>
-          </a:bodyPr>
-          <a:lstStyle/>
-          <a:p>
-            <a:pPr algn="ctr"/>
-            <a:r>
-              <a:rPr sz="1600" b="0">
-                <a:solidFill>
-                  <a:srgbClr val="1A7A4A"/>
-                </a:solidFill>
-              </a:rPr>
-              <a:t>↓</a:t>
-            </a:r>
-          </a:p>
-        </p:txBody>
-      </p:sp>
-      <p:sp>
-        <p:nvSpPr>
-          <p:cNvPr id="11" name="Rectangle 10"/>
-          <p:cNvSpPr/>
-          <p:nvPr/>
-        </p:nvSpPr>
-        <p:spPr>
-          <a:xfrm>
-            <a:off x="731520" y="2971800"/>
-            <a:ext cx="5029200" cy="822960"/>
-          </a:xfrm>
-          <a:prstGeom prst="rect">
-            <a:avLst/>
-          </a:prstGeom>
-          <a:solidFill>
-            <a:srgbClr val="FFFFFF"/>
-          </a:solidFill>
-          <a:ln w="12700">
-            <a:solidFill>
-              <a:srgbClr val="1F4E79"/>
-            </a:solidFill>
-          </a:ln>
-        </p:spPr>
-        <p:style>
-          <a:lnRef idx="1">
-            <a:schemeClr val="accent1"/>
-          </a:lnRef>
-          <a:fillRef idx="3">
-            <a:schemeClr val="accent1"/>
-          </a:fillRef>
-          <a:effectRef idx="2">
-            <a:schemeClr val="accent1"/>
-          </a:effectRef>
-          <a:fontRef idx="minor">
-            <a:schemeClr val="lt1"/>
-          </a:fontRef>
-        </p:style>
-        <p:txBody>
-          <a:bodyPr rtlCol="0" anchor="ctr"/>
-          <a:lstStyle/>
-          <a:p>
-            <a:pPr algn="ctr"/>
-          </a:p>
-        </p:txBody>
-      </p:sp>
-      <p:sp>
-        <p:nvSpPr>
-          <p:cNvPr id="12" name="TextBox 11"/>
-          <p:cNvSpPr txBox="1"/>
-          <p:nvPr/>
-        </p:nvSpPr>
-        <p:spPr>
-          <a:xfrm>
-            <a:off x="822960" y="3044952"/>
-            <a:ext cx="4846320" cy="365760"/>
-          </a:xfrm>
-          <a:prstGeom prst="rect">
-            <a:avLst/>
-          </a:prstGeom>
-          <a:noFill/>
-        </p:spPr>
-        <p:txBody>
-          <a:bodyPr wrap="square">
-            <a:spAutoFit/>
-          </a:bodyPr>
-          <a:lstStyle/>
-          <a:p>
-            <a:pPr algn="l"/>
-            <a:r>
-              <a:rPr sz="1400" b="0">
-                <a:solidFill>
-                  <a:srgbClr val="444444"/>
-                </a:solidFill>
-              </a:rPr>
-              <a:t>10-bit signed range</a:t>
-            </a:r>
-          </a:p>
-        </p:txBody>
-      </p:sp>
-      <p:sp>
-        <p:nvSpPr>
-          <p:cNvPr id="13" name="TextBox 12"/>
-          <p:cNvSpPr txBox="1"/>
-          <p:nvPr/>
-        </p:nvSpPr>
-        <p:spPr>
-          <a:xfrm>
-            <a:off x="822960" y="3355848"/>
-            <a:ext cx="4846320" cy="411480"/>
-          </a:xfrm>
-          <a:prstGeom prst="rect">
-            <a:avLst/>
-          </a:prstGeom>
-          <a:noFill/>
-        </p:spPr>
-        <p:txBody>
-          <a:bodyPr wrap="square">
-            <a:spAutoFit/>
-          </a:bodyPr>
-          <a:lstStyle/>
-          <a:p>
-            <a:pPr algn="l"/>
-            <a:r>
-              <a:rPr sz="1800" b="1">
-                <a:solidFill>
-                  <a:srgbClr val="1F4E79"/>
-                </a:solidFill>
-              </a:rPr>
-              <a:t>−512  to  +511</a:t>
-            </a:r>
-          </a:p>
-        </p:txBody>
-      </p:sp>
-      <p:sp>
-        <p:nvSpPr>
-          <p:cNvPr id="14" name="TextBox 13"/>
-          <p:cNvSpPr txBox="1"/>
-          <p:nvPr/>
-        </p:nvSpPr>
-        <p:spPr>
-          <a:xfrm>
-            <a:off x="3200400" y="3840480"/>
-            <a:ext cx="457200" cy="274320"/>
-          </a:xfrm>
-          <a:prstGeom prst="rect">
-            <a:avLst/>
-          </a:prstGeom>
-          <a:noFill/>
-        </p:spPr>
-        <p:txBody>
-          <a:bodyPr wrap="square">
-            <a:spAutoFit/>
-          </a:bodyPr>
-          <a:lstStyle/>
-          <a:p>
-            <a:pPr algn="ctr"/>
-            <a:r>
-              <a:rPr sz="1600" b="0">
-                <a:solidFill>
-                  <a:srgbClr val="1A7A4A"/>
-                </a:solidFill>
-              </a:rPr>
-              <a:t>↓</a:t>
-            </a:r>
-          </a:p>
-        </p:txBody>
-      </p:sp>
-      <p:sp>
-        <p:nvSpPr>
-          <p:cNvPr id="15" name="Rectangle 14"/>
-          <p:cNvSpPr/>
-          <p:nvPr/>
-        </p:nvSpPr>
-        <p:spPr>
-          <a:xfrm>
-            <a:off x="731520" y="4023360"/>
-            <a:ext cx="5029200" cy="822960"/>
-          </a:xfrm>
-          <a:prstGeom prst="rect">
-            <a:avLst/>
-          </a:prstGeom>
-          <a:solidFill>
-            <a:srgbClr val="FFFFFF"/>
-          </a:solidFill>
-          <a:ln w="12700">
-            <a:solidFill>
-              <a:srgbClr val="1F4E79"/>
-            </a:solidFill>
-          </a:ln>
-        </p:spPr>
-        <p:style>
-          <a:lnRef idx="1">
-            <a:schemeClr val="accent1"/>
-          </a:lnRef>
-          <a:fillRef idx="3">
-            <a:schemeClr val="accent1"/>
-          </a:fillRef>
-          <a:effectRef idx="2">
-            <a:schemeClr val="accent1"/>
-          </a:effectRef>
-          <a:fontRef idx="minor">
-            <a:schemeClr val="lt1"/>
-          </a:fontRef>
-        </p:style>
-        <p:txBody>
-          <a:bodyPr rtlCol="0" anchor="ctr"/>
-          <a:lstStyle/>
-          <a:p>
-            <a:pPr algn="ctr"/>
-          </a:p>
-        </p:txBody>
-      </p:sp>
-      <p:sp>
-        <p:nvSpPr>
-          <p:cNvPr id="16" name="TextBox 15"/>
-          <p:cNvSpPr txBox="1"/>
-          <p:nvPr/>
-        </p:nvSpPr>
-        <p:spPr>
-          <a:xfrm>
-            <a:off x="822960" y="4096512"/>
-            <a:ext cx="4846320" cy="365760"/>
-          </a:xfrm>
-          <a:prstGeom prst="rect">
-            <a:avLst/>
-          </a:prstGeom>
-          <a:noFill/>
-        </p:spPr>
-        <p:txBody>
-          <a:bodyPr wrap="square">
-            <a:spAutoFit/>
-          </a:bodyPr>
-          <a:lstStyle/>
-          <a:p>
-            <a:pPr algn="l"/>
-            <a:r>
-              <a:rPr sz="1400" b="0">
-                <a:solidFill>
-                  <a:srgbClr val="444444"/>
-                </a:solidFill>
-              </a:rPr>
-              <a:t>511 &gt; 508</a:t>
-            </a:r>
-          </a:p>
-        </p:txBody>
-      </p:sp>
-      <p:sp>
-        <p:nvSpPr>
-          <p:cNvPr id="17" name="TextBox 16"/>
-          <p:cNvSpPr txBox="1"/>
-          <p:nvPr/>
-        </p:nvSpPr>
-        <p:spPr>
-          <a:xfrm>
-            <a:off x="822960" y="4407408"/>
-            <a:ext cx="4846320" cy="411480"/>
-          </a:xfrm>
-          <a:prstGeom prst="rect">
-            <a:avLst/>
-          </a:prstGeom>
-          <a:noFill/>
-        </p:spPr>
-        <p:txBody>
-          <a:bodyPr wrap="square">
-            <a:spAutoFit/>
-          </a:bodyPr>
-          <a:lstStyle/>
-          <a:p>
-            <a:pPr algn="l"/>
-            <a:r>
-              <a:rPr sz="1800" b="1">
-                <a:solidFill>
-                  <a:srgbClr val="1F4E79"/>
-                </a:solidFill>
-              </a:rPr>
-              <a:t>clears the threshold we need ✓</a:t>
-            </a:r>
-          </a:p>
-        </p:txBody>
-      </p:sp>
-      <p:sp>
-        <p:nvSpPr>
-          <p:cNvPr id="18" name="Rectangle 17"/>
-          <p:cNvSpPr/>
-          <p:nvPr/>
-        </p:nvSpPr>
-        <p:spPr>
-          <a:xfrm>
-            <a:off x="6400800" y="1371600"/>
-            <a:ext cx="5303520" cy="4389120"/>
-          </a:xfrm>
-          <a:prstGeom prst="rect">
-            <a:avLst/>
-          </a:prstGeom>
-          <a:solidFill>
-            <a:srgbClr val="FFFFFF"/>
-          </a:solidFill>
-          <a:ln w="12700">
-            <a:solidFill>
-              <a:srgbClr val="1A7A4A"/>
-            </a:solidFill>
-          </a:ln>
-        </p:spPr>
-        <p:style>
-          <a:lnRef idx="1">
-            <a:schemeClr val="accent1"/>
-          </a:lnRef>
-          <a:fillRef idx="3">
-            <a:schemeClr val="accent1"/>
-          </a:fillRef>
-          <a:effectRef idx="2">
-            <a:schemeClr val="accent1"/>
-          </a:effectRef>
-          <a:fontRef idx="minor">
-            <a:schemeClr val="lt1"/>
-          </a:fontRef>
-        </p:style>
-        <p:txBody>
-          <a:bodyPr rtlCol="0" anchor="ctr"/>
-          <a:lstStyle/>
-          <a:p>
-            <a:pPr algn="ctr"/>
-          </a:p>
-        </p:txBody>
-      </p:sp>
-      <p:sp>
-        <p:nvSpPr>
-          <p:cNvPr id="19" name="TextBox 18"/>
-          <p:cNvSpPr txBox="1"/>
-          <p:nvPr/>
-        </p:nvSpPr>
-        <p:spPr>
-          <a:xfrm>
-            <a:off x="6492240" y="1463040"/>
-            <a:ext cx="5120640" cy="457200"/>
-          </a:xfrm>
-          <a:prstGeom prst="rect">
-            <a:avLst/>
-          </a:prstGeom>
-          <a:noFill/>
-        </p:spPr>
-        <p:txBody>
-          <a:bodyPr wrap="square">
-            <a:spAutoFit/>
-          </a:bodyPr>
-          <a:lstStyle/>
-          <a:p>
-            <a:pPr algn="l"/>
-            <a:r>
-              <a:rPr sz="1500" b="1">
-                <a:solidFill>
-                  <a:srgbClr val="1A7A4A"/>
-                </a:solidFill>
-              </a:rPr>
-              <a:t>Why not 9-bit?</a:t>
-            </a:r>
-          </a:p>
-        </p:txBody>
-      </p:sp>
-      <p:sp>
-        <p:nvSpPr>
-          <p:cNvPr id="20" name="TextBox 19"/>
-          <p:cNvSpPr txBox="1"/>
-          <p:nvPr/>
-        </p:nvSpPr>
-        <p:spPr>
-          <a:xfrm>
-            <a:off x="6492240" y="2011680"/>
-            <a:ext cx="5029200" cy="2286000"/>
-          </a:xfrm>
-          <a:prstGeom prst="rect">
-            <a:avLst/>
-          </a:prstGeom>
-          <a:noFill/>
-        </p:spPr>
-        <p:txBody>
-          <a:bodyPr wrap="square">
-            <a:spAutoFit/>
-          </a:bodyPr>
-          <a:lstStyle/>
-          <a:p>
-            <a:pPr>
-              <a:spcBef>
-                <a:spcPts val="400"/>
-              </a:spcBef>
-            </a:pPr>
-            <a:r>
-              <a:rPr sz="1500">
-                <a:solidFill>
-                  <a:srgbClr val="444444"/>
-                </a:solidFill>
-              </a:rPr>
-              <a:t>• 9-bit signed only goes to 255 — overflows</a:t>
-            </a:r>
-          </a:p>
-          <a:p>
-            <a:pPr>
-              <a:spcBef>
-                <a:spcPts val="400"/>
-              </a:spcBef>
-            </a:pPr>
-            <a:r>
-              <a:rPr sz="1500">
-                <a:solidFill>
-                  <a:srgbClr val="444444"/>
-                </a:solidFill>
-              </a:rPr>
-              <a:t>• 10-bit is the minimum that covers 508</a:t>
-            </a:r>
-          </a:p>
-          <a:p>
-            <a:pPr>
-              <a:spcBef>
-                <a:spcPts val="400"/>
-              </a:spcBef>
-            </a:pPr>
-            <a:r>
-              <a:rPr sz="1500">
-                <a:solidFill>
-                  <a:srgbClr val="444444"/>
-                </a:solidFill>
-              </a:rPr>
-              <a:t>• No wasted bits, no overflow</a:t>
-            </a:r>
-          </a:p>
-        </p:txBody>
-      </p:sp>
+        </p:spPr>
+      </p:pic>
     </p:spTree>
   </p:cSld>
   <p:clrMapOvr>
@@ -5039,7 +4671,7 @@
             <a:avLst/>
           </a:prstGeom>
           <a:solidFill>
-            <a:srgbClr val="F2F2F2"/>
+            <a:srgbClr val="F4F4F4"/>
           </a:solidFill>
           <a:ln>
             <a:noFill/>
@@ -5076,7 +4708,7 @@
         <p:spPr>
           <a:xfrm>
             <a:off x="0" y="0"/>
-            <a:ext cx="12188952" cy="1005840"/>
+            <a:ext cx="12188952" cy="502920"/>
           </a:xfrm>
           <a:prstGeom prst="rect">
             <a:avLst/>
@@ -5112,47 +4744,13 @@
       </p:sp>
       <p:sp>
         <p:nvSpPr>
-          <p:cNvPr id="4" name="TextBox 3"/>
-          <p:cNvSpPr txBox="1"/>
-          <p:nvPr/>
-        </p:nvSpPr>
-        <p:spPr>
-          <a:xfrm>
-            <a:off x="274320" y="91440"/>
-            <a:ext cx="11612880" cy="822960"/>
-          </a:xfrm>
-          <a:prstGeom prst="rect">
-            <a:avLst/>
-          </a:prstGeom>
-          <a:noFill/>
-        </p:spPr>
-        <p:txBody>
-          <a:bodyPr wrap="square">
-            <a:spAutoFit/>
-          </a:bodyPr>
-          <a:lstStyle/>
-          <a:p>
-            <a:pPr algn="l"/>
-            <a:r>
-              <a:rPr sz="3200" b="1">
-                <a:solidFill>
-                  <a:srgbClr val="FFFFFF"/>
-                </a:solidFill>
-              </a:rPr>
-              <a:t>Testbench — Setup &amp; Hand Calculation</a:t>
-            </a:r>
-          </a:p>
-        </p:txBody>
-      </p:sp>
-      <p:sp>
-        <p:nvSpPr>
-          <p:cNvPr id="5" name="Rectangle 4"/>
+          <p:cNvPr id="4" name="Rectangle 3"/>
           <p:cNvSpPr/>
           <p:nvPr/>
         </p:nvSpPr>
         <p:spPr>
           <a:xfrm>
-            <a:off x="0" y="1005840"/>
+            <a:off x="0" y="502920"/>
             <a:ext cx="12188952" cy="54864"/>
           </a:xfrm>
           <a:prstGeom prst="rect">
@@ -5189,14 +4787,14 @@
       </p:sp>
       <p:sp>
         <p:nvSpPr>
-          <p:cNvPr id="6" name="TextBox 5"/>
+          <p:cNvPr id="5" name="TextBox 4"/>
           <p:cNvSpPr txBox="1"/>
           <p:nvPr/>
         </p:nvSpPr>
         <p:spPr>
           <a:xfrm>
-            <a:off x="365760" y="1188720"/>
-            <a:ext cx="5029200" cy="411480"/>
+            <a:off x="228600" y="54864"/>
+            <a:ext cx="11887200" cy="438912"/>
           </a:xfrm>
           <a:prstGeom prst="rect">
             <a:avLst/>
@@ -5204,78 +4802,33 @@
           <a:noFill/>
         </p:spPr>
         <p:txBody>
-          <a:bodyPr wrap="square">
+          <a:bodyPr wrap="none">
             <a:spAutoFit/>
           </a:bodyPr>
           <a:lstStyle/>
           <a:p>
             <a:pPr algn="l"/>
             <a:r>
-              <a:rPr sz="1500" b="1">
-                <a:solidFill>
-                  <a:srgbClr val="1F4E79"/>
+              <a:rPr sz="2200" b="1">
+                <a:solidFill>
+                  <a:srgbClr val="FFFFFF"/>
                 </a:solidFill>
               </a:rPr>
-              <a:t>Weight Matrix (from spec)</a:t>
-            </a:r>
-          </a:p>
-        </p:txBody>
-      </p:sp>
-      <p:sp>
-        <p:nvSpPr>
-          <p:cNvPr id="7" name="Rectangle 6"/>
-          <p:cNvSpPr/>
-          <p:nvPr/>
-        </p:nvSpPr>
-        <p:spPr>
-          <a:xfrm>
-            <a:off x="457200" y="1645920"/>
-            <a:ext cx="777240" cy="457200"/>
-          </a:xfrm>
-          <a:prstGeom prst="rect">
-            <a:avLst/>
-          </a:prstGeom>
-          <a:solidFill>
-            <a:srgbClr val="E2EFDA"/>
-          </a:solidFill>
-          <a:ln w="12700">
-            <a:solidFill>
-              <a:srgbClr val="1F4E79"/>
-            </a:solidFill>
-          </a:ln>
-        </p:spPr>
-        <p:style>
-          <a:lnRef idx="1">
-            <a:schemeClr val="accent1"/>
-          </a:lnRef>
-          <a:fillRef idx="3">
-            <a:schemeClr val="accent1"/>
-          </a:fillRef>
-          <a:effectRef idx="2">
-            <a:schemeClr val="accent1"/>
-          </a:effectRef>
-          <a:fontRef idx="minor">
-            <a:schemeClr val="lt1"/>
-          </a:fontRef>
-        </p:style>
-        <p:txBody>
-          <a:bodyPr rtlCol="0" anchor="ctr"/>
-          <a:lstStyle/>
-          <a:p>
-            <a:pPr algn="ctr"/>
-          </a:p>
-        </p:txBody>
-      </p:sp>
-      <p:sp>
-        <p:nvSpPr>
-          <p:cNvPr id="8" name="TextBox 7"/>
+              <a:t>The Testbench — 2-Cycle Timing</a:t>
+            </a:r>
+          </a:p>
+        </p:txBody>
+      </p:sp>
+      <p:sp>
+        <p:nvSpPr>
+          <p:cNvPr id="6" name="TextBox 5"/>
           <p:cNvSpPr txBox="1"/>
           <p:nvPr/>
         </p:nvSpPr>
         <p:spPr>
           <a:xfrm>
-            <a:off x="457200" y="1719072"/>
-            <a:ext cx="777240" cy="411480"/>
+            <a:off x="274320" y="685800"/>
+            <a:ext cx="6858000" cy="4114800"/>
           </a:xfrm>
           <a:prstGeom prst="rect">
             <a:avLst/>
@@ -5288,1859 +4841,130 @@
           </a:bodyPr>
           <a:lstStyle/>
           <a:p>
-            <a:pPr algn="ctr"/>
-            <a:r>
-              <a:rPr sz="1400" b="1">
-                <a:solidFill>
-                  <a:srgbClr val="1A7A4A"/>
+            <a:pPr>
+              <a:spcBef>
+                <a:spcPts val="500"/>
+              </a:spcBef>
+            </a:pPr>
+            <a:r>
+              <a:rPr sz="1900">
+                <a:solidFill>
+                  <a:srgbClr val="222222"/>
                 </a:solidFill>
               </a:rPr>
-              <a:t>+1</a:t>
-            </a:r>
-          </a:p>
-        </p:txBody>
-      </p:sp>
-      <p:sp>
-        <p:nvSpPr>
-          <p:cNvPr id="9" name="Rectangle 8"/>
-          <p:cNvSpPr/>
+              <a:t>One thing about the timing Claude had to get right, and the output shows up two cycles after</a:t>
+            </a:r>
+          </a:p>
+          <a:p>
+            <a:pPr>
+              <a:spcBef>
+                <a:spcPts val="500"/>
+              </a:spcBef>
+            </a:pPr>
+            <a:r>
+              <a:rPr sz="1900">
+                <a:solidFill>
+                  <a:srgbClr val="222222"/>
+                </a:solidFill>
+              </a:rPr>
+              <a:t>you assert weight_load, not one. Basically here's why, so on the first rising edge after</a:t>
+            </a:r>
+          </a:p>
+          <a:p>
+            <a:pPr>
+              <a:spcBef>
+                <a:spcPts val="500"/>
+              </a:spcBef>
+            </a:pPr>
+            <a:r>
+              <a:rPr sz="1900">
+                <a:solidFill>
+                  <a:srgbClr val="222222"/>
+                </a:solidFill>
+              </a:rPr>
+              <a:t>weight_load, the weight register latches the new weights, but the output register clocks on</a:t>
+            </a:r>
+          </a:p>
+          <a:p>
+            <a:pPr>
+              <a:spcBef>
+                <a:spcPts val="500"/>
+              </a:spcBef>
+            </a:pPr>
+            <a:r>
+              <a:rPr sz="1900">
+                <a:solidFill>
+                  <a:srgbClr val="222222"/>
+                </a:solidFill>
+              </a:rPr>
+              <a:t>that same edge and it's still using the old weights. And so the correct output only appears</a:t>
+            </a:r>
+          </a:p>
+          <a:p>
+            <a:pPr>
+              <a:spcBef>
+                <a:spcPts val="500"/>
+              </a:spcBef>
+            </a:pPr>
+            <a:r>
+              <a:rPr sz="1900">
+                <a:solidFill>
+                  <a:srgbClr val="222222"/>
+                </a:solidFill>
+              </a:rPr>
+              <a:t>one cycle later. The testbench explicitly waits two cycles before reading the outputs.</a:t>
+            </a:r>
+          </a:p>
+        </p:txBody>
+      </p:sp>
+      <p:pic>
+        <p:nvPicPr>
+          <p:cNvPr id="7" name="Picture 6" descr="timing.png"/>
+          <p:cNvPicPr>
+            <a:picLocks noChangeAspect="1"/>
+          </p:cNvPicPr>
           <p:nvPr/>
-        </p:nvSpPr>
-        <p:spPr>
-          <a:xfrm>
-            <a:off x="1280160" y="1645920"/>
-            <a:ext cx="777240" cy="457200"/>
+        </p:nvPicPr>
+        <p:blipFill>
+          <a:blip r:embed="rId2"/>
+          <a:stretch>
+            <a:fillRect/>
+          </a:stretch>
+        </p:blipFill>
+        <p:spPr>
+          <a:xfrm>
+            <a:off x="274320" y="4754880"/>
+            <a:ext cx="6858000" cy="3218704"/>
           </a:xfrm>
           <a:prstGeom prst="rect">
             <a:avLst/>
           </a:prstGeom>
-          <a:solidFill>
-            <a:srgbClr val="FFE0E0"/>
-          </a:solidFill>
-          <a:ln w="12700">
-            <a:solidFill>
-              <a:srgbClr val="1F4E79"/>
-            </a:solidFill>
-          </a:ln>
-        </p:spPr>
-        <p:style>
-          <a:lnRef idx="1">
-            <a:schemeClr val="accent1"/>
-          </a:lnRef>
-          <a:fillRef idx="3">
-            <a:schemeClr val="accent1"/>
-          </a:fillRef>
-          <a:effectRef idx="2">
-            <a:schemeClr val="accent1"/>
-          </a:effectRef>
-          <a:fontRef idx="minor">
-            <a:schemeClr val="lt1"/>
-          </a:fontRef>
-        </p:style>
-        <p:txBody>
-          <a:bodyPr rtlCol="0" anchor="ctr"/>
-          <a:lstStyle/>
-          <a:p>
-            <a:pPr algn="ctr"/>
-          </a:p>
-        </p:txBody>
-      </p:sp>
-      <p:sp>
-        <p:nvSpPr>
-          <p:cNvPr id="10" name="TextBox 9"/>
-          <p:cNvSpPr txBox="1"/>
+        </p:spPr>
+      </p:pic>
+      <p:pic>
+        <p:nvPicPr>
+          <p:cNvPr id="8" name="Picture 7" descr="pipeline.png"/>
+          <p:cNvPicPr>
+            <a:picLocks noChangeAspect="1"/>
+          </p:cNvPicPr>
           <p:nvPr/>
-        </p:nvSpPr>
-        <p:spPr>
-          <a:xfrm>
-            <a:off x="1280160" y="1719072"/>
-            <a:ext cx="777240" cy="411480"/>
+        </p:nvPicPr>
+        <p:blipFill>
+          <a:blip r:embed="rId3"/>
+          <a:stretch>
+            <a:fillRect/>
+          </a:stretch>
+        </p:blipFill>
+        <p:spPr>
+          <a:xfrm>
+            <a:off x="7223760" y="685800"/>
+            <a:ext cx="4754880" cy="1755834"/>
           </a:xfrm>
           <a:prstGeom prst="rect">
             <a:avLst/>
           </a:prstGeom>
-          <a:noFill/>
-        </p:spPr>
-        <p:txBody>
-          <a:bodyPr wrap="square">
-            <a:spAutoFit/>
-          </a:bodyPr>
-          <a:lstStyle/>
-          <a:p>
-            <a:pPr algn="ctr"/>
-            <a:r>
-              <a:rPr sz="1400" b="1">
-                <a:solidFill>
-                  <a:srgbClr val="C00000"/>
-                </a:solidFill>
-              </a:rPr>
-              <a:t>−1</a:t>
-            </a:r>
-          </a:p>
-        </p:txBody>
-      </p:sp>
-      <p:sp>
-        <p:nvSpPr>
-          <p:cNvPr id="11" name="Rectangle 10"/>
-          <p:cNvSpPr/>
-          <p:nvPr/>
-        </p:nvSpPr>
-        <p:spPr>
-          <a:xfrm>
-            <a:off x="2103120" y="1645920"/>
-            <a:ext cx="777240" cy="457200"/>
-          </a:xfrm>
-          <a:prstGeom prst="rect">
-            <a:avLst/>
-          </a:prstGeom>
-          <a:solidFill>
-            <a:srgbClr val="E2EFDA"/>
-          </a:solidFill>
-          <a:ln w="12700">
-            <a:solidFill>
-              <a:srgbClr val="1F4E79"/>
-            </a:solidFill>
-          </a:ln>
-        </p:spPr>
-        <p:style>
-          <a:lnRef idx="1">
-            <a:schemeClr val="accent1"/>
-          </a:lnRef>
-          <a:fillRef idx="3">
-            <a:schemeClr val="accent1"/>
-          </a:fillRef>
-          <a:effectRef idx="2">
-            <a:schemeClr val="accent1"/>
-          </a:effectRef>
-          <a:fontRef idx="minor">
-            <a:schemeClr val="lt1"/>
-          </a:fontRef>
-        </p:style>
-        <p:txBody>
-          <a:bodyPr rtlCol="0" anchor="ctr"/>
-          <a:lstStyle/>
-          <a:p>
-            <a:pPr algn="ctr"/>
-          </a:p>
-        </p:txBody>
-      </p:sp>
-      <p:sp>
-        <p:nvSpPr>
-          <p:cNvPr id="12" name="TextBox 11"/>
-          <p:cNvSpPr txBox="1"/>
-          <p:nvPr/>
-        </p:nvSpPr>
-        <p:spPr>
-          <a:xfrm>
-            <a:off x="2103120" y="1719072"/>
-            <a:ext cx="777240" cy="411480"/>
-          </a:xfrm>
-          <a:prstGeom prst="rect">
-            <a:avLst/>
-          </a:prstGeom>
-          <a:noFill/>
-        </p:spPr>
-        <p:txBody>
-          <a:bodyPr wrap="square">
-            <a:spAutoFit/>
-          </a:bodyPr>
-          <a:lstStyle/>
-          <a:p>
-            <a:pPr algn="ctr"/>
-            <a:r>
-              <a:rPr sz="1400" b="1">
-                <a:solidFill>
-                  <a:srgbClr val="1A7A4A"/>
-                </a:solidFill>
-              </a:rPr>
-              <a:t>+1</a:t>
-            </a:r>
-          </a:p>
-        </p:txBody>
-      </p:sp>
-      <p:sp>
-        <p:nvSpPr>
-          <p:cNvPr id="13" name="Rectangle 12"/>
-          <p:cNvSpPr/>
-          <p:nvPr/>
-        </p:nvSpPr>
-        <p:spPr>
-          <a:xfrm>
-            <a:off x="2926080" y="1645920"/>
-            <a:ext cx="777240" cy="457200"/>
-          </a:xfrm>
-          <a:prstGeom prst="rect">
-            <a:avLst/>
-          </a:prstGeom>
-          <a:solidFill>
-            <a:srgbClr val="FFE0E0"/>
-          </a:solidFill>
-          <a:ln w="12700">
-            <a:solidFill>
-              <a:srgbClr val="1F4E79"/>
-            </a:solidFill>
-          </a:ln>
-        </p:spPr>
-        <p:style>
-          <a:lnRef idx="1">
-            <a:schemeClr val="accent1"/>
-          </a:lnRef>
-          <a:fillRef idx="3">
-            <a:schemeClr val="accent1"/>
-          </a:fillRef>
-          <a:effectRef idx="2">
-            <a:schemeClr val="accent1"/>
-          </a:effectRef>
-          <a:fontRef idx="minor">
-            <a:schemeClr val="lt1"/>
-          </a:fontRef>
-        </p:style>
-        <p:txBody>
-          <a:bodyPr rtlCol="0" anchor="ctr"/>
-          <a:lstStyle/>
-          <a:p>
-            <a:pPr algn="ctr"/>
-          </a:p>
-        </p:txBody>
-      </p:sp>
-      <p:sp>
-        <p:nvSpPr>
-          <p:cNvPr id="14" name="TextBox 13"/>
-          <p:cNvSpPr txBox="1"/>
-          <p:nvPr/>
-        </p:nvSpPr>
-        <p:spPr>
-          <a:xfrm>
-            <a:off x="2926080" y="1719072"/>
-            <a:ext cx="777240" cy="411480"/>
-          </a:xfrm>
-          <a:prstGeom prst="rect">
-            <a:avLst/>
-          </a:prstGeom>
-          <a:noFill/>
-        </p:spPr>
-        <p:txBody>
-          <a:bodyPr wrap="square">
-            <a:spAutoFit/>
-          </a:bodyPr>
-          <a:lstStyle/>
-          <a:p>
-            <a:pPr algn="ctr"/>
-            <a:r>
-              <a:rPr sz="1400" b="1">
-                <a:solidFill>
-                  <a:srgbClr val="C00000"/>
-                </a:solidFill>
-              </a:rPr>
-              <a:t>−1</a:t>
-            </a:r>
-          </a:p>
-        </p:txBody>
-      </p:sp>
-      <p:sp>
-        <p:nvSpPr>
-          <p:cNvPr id="15" name="Rectangle 14"/>
-          <p:cNvSpPr/>
-          <p:nvPr/>
-        </p:nvSpPr>
-        <p:spPr>
-          <a:xfrm>
-            <a:off x="457200" y="2148840"/>
-            <a:ext cx="777240" cy="457200"/>
-          </a:xfrm>
-          <a:prstGeom prst="rect">
-            <a:avLst/>
-          </a:prstGeom>
-          <a:solidFill>
-            <a:srgbClr val="E2EFDA"/>
-          </a:solidFill>
-          <a:ln w="12700">
-            <a:solidFill>
-              <a:srgbClr val="1F4E79"/>
-            </a:solidFill>
-          </a:ln>
-        </p:spPr>
-        <p:style>
-          <a:lnRef idx="1">
-            <a:schemeClr val="accent1"/>
-          </a:lnRef>
-          <a:fillRef idx="3">
-            <a:schemeClr val="accent1"/>
-          </a:fillRef>
-          <a:effectRef idx="2">
-            <a:schemeClr val="accent1"/>
-          </a:effectRef>
-          <a:fontRef idx="minor">
-            <a:schemeClr val="lt1"/>
-          </a:fontRef>
-        </p:style>
-        <p:txBody>
-          <a:bodyPr rtlCol="0" anchor="ctr"/>
-          <a:lstStyle/>
-          <a:p>
-            <a:pPr algn="ctr"/>
-          </a:p>
-        </p:txBody>
-      </p:sp>
-      <p:sp>
-        <p:nvSpPr>
-          <p:cNvPr id="16" name="TextBox 15"/>
-          <p:cNvSpPr txBox="1"/>
-          <p:nvPr/>
-        </p:nvSpPr>
-        <p:spPr>
-          <a:xfrm>
-            <a:off x="457200" y="2221992"/>
-            <a:ext cx="777240" cy="411480"/>
-          </a:xfrm>
-          <a:prstGeom prst="rect">
-            <a:avLst/>
-          </a:prstGeom>
-          <a:noFill/>
-        </p:spPr>
-        <p:txBody>
-          <a:bodyPr wrap="square">
-            <a:spAutoFit/>
-          </a:bodyPr>
-          <a:lstStyle/>
-          <a:p>
-            <a:pPr algn="ctr"/>
-            <a:r>
-              <a:rPr sz="1400" b="1">
-                <a:solidFill>
-                  <a:srgbClr val="1A7A4A"/>
-                </a:solidFill>
-              </a:rPr>
-              <a:t>+1</a:t>
-            </a:r>
-          </a:p>
-        </p:txBody>
-      </p:sp>
-      <p:sp>
-        <p:nvSpPr>
-          <p:cNvPr id="17" name="Rectangle 16"/>
-          <p:cNvSpPr/>
-          <p:nvPr/>
-        </p:nvSpPr>
-        <p:spPr>
-          <a:xfrm>
-            <a:off x="1280160" y="2148840"/>
-            <a:ext cx="777240" cy="457200"/>
-          </a:xfrm>
-          <a:prstGeom prst="rect">
-            <a:avLst/>
-          </a:prstGeom>
-          <a:solidFill>
-            <a:srgbClr val="E2EFDA"/>
-          </a:solidFill>
-          <a:ln w="12700">
-            <a:solidFill>
-              <a:srgbClr val="1F4E79"/>
-            </a:solidFill>
-          </a:ln>
-        </p:spPr>
-        <p:style>
-          <a:lnRef idx="1">
-            <a:schemeClr val="accent1"/>
-          </a:lnRef>
-          <a:fillRef idx="3">
-            <a:schemeClr val="accent1"/>
-          </a:fillRef>
-          <a:effectRef idx="2">
-            <a:schemeClr val="accent1"/>
-          </a:effectRef>
-          <a:fontRef idx="minor">
-            <a:schemeClr val="lt1"/>
-          </a:fontRef>
-        </p:style>
-        <p:txBody>
-          <a:bodyPr rtlCol="0" anchor="ctr"/>
-          <a:lstStyle/>
-          <a:p>
-            <a:pPr algn="ctr"/>
-          </a:p>
-        </p:txBody>
-      </p:sp>
-      <p:sp>
-        <p:nvSpPr>
-          <p:cNvPr id="18" name="TextBox 17"/>
-          <p:cNvSpPr txBox="1"/>
-          <p:nvPr/>
-        </p:nvSpPr>
-        <p:spPr>
-          <a:xfrm>
-            <a:off x="1280160" y="2221992"/>
-            <a:ext cx="777240" cy="411480"/>
-          </a:xfrm>
-          <a:prstGeom prst="rect">
-            <a:avLst/>
-          </a:prstGeom>
-          <a:noFill/>
-        </p:spPr>
-        <p:txBody>
-          <a:bodyPr wrap="square">
-            <a:spAutoFit/>
-          </a:bodyPr>
-          <a:lstStyle/>
-          <a:p>
-            <a:pPr algn="ctr"/>
-            <a:r>
-              <a:rPr sz="1400" b="1">
-                <a:solidFill>
-                  <a:srgbClr val="1A7A4A"/>
-                </a:solidFill>
-              </a:rPr>
-              <a:t>+1</a:t>
-            </a:r>
-          </a:p>
-        </p:txBody>
-      </p:sp>
-      <p:sp>
-        <p:nvSpPr>
-          <p:cNvPr id="19" name="Rectangle 18"/>
-          <p:cNvSpPr/>
-          <p:nvPr/>
-        </p:nvSpPr>
-        <p:spPr>
-          <a:xfrm>
-            <a:off x="2103120" y="2148840"/>
-            <a:ext cx="777240" cy="457200"/>
-          </a:xfrm>
-          <a:prstGeom prst="rect">
-            <a:avLst/>
-          </a:prstGeom>
-          <a:solidFill>
-            <a:srgbClr val="FFE0E0"/>
-          </a:solidFill>
-          <a:ln w="12700">
-            <a:solidFill>
-              <a:srgbClr val="1F4E79"/>
-            </a:solidFill>
-          </a:ln>
-        </p:spPr>
-        <p:style>
-          <a:lnRef idx="1">
-            <a:schemeClr val="accent1"/>
-          </a:lnRef>
-          <a:fillRef idx="3">
-            <a:schemeClr val="accent1"/>
-          </a:fillRef>
-          <a:effectRef idx="2">
-            <a:schemeClr val="accent1"/>
-          </a:effectRef>
-          <a:fontRef idx="minor">
-            <a:schemeClr val="lt1"/>
-          </a:fontRef>
-        </p:style>
-        <p:txBody>
-          <a:bodyPr rtlCol="0" anchor="ctr"/>
-          <a:lstStyle/>
-          <a:p>
-            <a:pPr algn="ctr"/>
-          </a:p>
-        </p:txBody>
-      </p:sp>
-      <p:sp>
-        <p:nvSpPr>
-          <p:cNvPr id="20" name="TextBox 19"/>
-          <p:cNvSpPr txBox="1"/>
-          <p:nvPr/>
-        </p:nvSpPr>
-        <p:spPr>
-          <a:xfrm>
-            <a:off x="2103120" y="2221992"/>
-            <a:ext cx="777240" cy="411480"/>
-          </a:xfrm>
-          <a:prstGeom prst="rect">
-            <a:avLst/>
-          </a:prstGeom>
-          <a:noFill/>
-        </p:spPr>
-        <p:txBody>
-          <a:bodyPr wrap="square">
-            <a:spAutoFit/>
-          </a:bodyPr>
-          <a:lstStyle/>
-          <a:p>
-            <a:pPr algn="ctr"/>
-            <a:r>
-              <a:rPr sz="1400" b="1">
-                <a:solidFill>
-                  <a:srgbClr val="C00000"/>
-                </a:solidFill>
-              </a:rPr>
-              <a:t>−1</a:t>
-            </a:r>
-          </a:p>
-        </p:txBody>
-      </p:sp>
-      <p:sp>
-        <p:nvSpPr>
-          <p:cNvPr id="21" name="Rectangle 20"/>
-          <p:cNvSpPr/>
-          <p:nvPr/>
-        </p:nvSpPr>
-        <p:spPr>
-          <a:xfrm>
-            <a:off x="2926080" y="2148840"/>
-            <a:ext cx="777240" cy="457200"/>
-          </a:xfrm>
-          <a:prstGeom prst="rect">
-            <a:avLst/>
-          </a:prstGeom>
-          <a:solidFill>
-            <a:srgbClr val="FFE0E0"/>
-          </a:solidFill>
-          <a:ln w="12700">
-            <a:solidFill>
-              <a:srgbClr val="1F4E79"/>
-            </a:solidFill>
-          </a:ln>
-        </p:spPr>
-        <p:style>
-          <a:lnRef idx="1">
-            <a:schemeClr val="accent1"/>
-          </a:lnRef>
-          <a:fillRef idx="3">
-            <a:schemeClr val="accent1"/>
-          </a:fillRef>
-          <a:effectRef idx="2">
-            <a:schemeClr val="accent1"/>
-          </a:effectRef>
-          <a:fontRef idx="minor">
-            <a:schemeClr val="lt1"/>
-          </a:fontRef>
-        </p:style>
-        <p:txBody>
-          <a:bodyPr rtlCol="0" anchor="ctr"/>
-          <a:lstStyle/>
-          <a:p>
-            <a:pPr algn="ctr"/>
-          </a:p>
-        </p:txBody>
-      </p:sp>
-      <p:sp>
-        <p:nvSpPr>
-          <p:cNvPr id="22" name="TextBox 21"/>
-          <p:cNvSpPr txBox="1"/>
-          <p:nvPr/>
-        </p:nvSpPr>
-        <p:spPr>
-          <a:xfrm>
-            <a:off x="2926080" y="2221992"/>
-            <a:ext cx="777240" cy="411480"/>
-          </a:xfrm>
-          <a:prstGeom prst="rect">
-            <a:avLst/>
-          </a:prstGeom>
-          <a:noFill/>
-        </p:spPr>
-        <p:txBody>
-          <a:bodyPr wrap="square">
-            <a:spAutoFit/>
-          </a:bodyPr>
-          <a:lstStyle/>
-          <a:p>
-            <a:pPr algn="ctr"/>
-            <a:r>
-              <a:rPr sz="1400" b="1">
-                <a:solidFill>
-                  <a:srgbClr val="C00000"/>
-                </a:solidFill>
-              </a:rPr>
-              <a:t>−1</a:t>
-            </a:r>
-          </a:p>
-        </p:txBody>
-      </p:sp>
-      <p:sp>
-        <p:nvSpPr>
-          <p:cNvPr id="23" name="Rectangle 22"/>
-          <p:cNvSpPr/>
-          <p:nvPr/>
-        </p:nvSpPr>
-        <p:spPr>
-          <a:xfrm>
-            <a:off x="457200" y="2651760"/>
-            <a:ext cx="777240" cy="457200"/>
-          </a:xfrm>
-          <a:prstGeom prst="rect">
-            <a:avLst/>
-          </a:prstGeom>
-          <a:solidFill>
-            <a:srgbClr val="FFE0E0"/>
-          </a:solidFill>
-          <a:ln w="12700">
-            <a:solidFill>
-              <a:srgbClr val="1F4E79"/>
-            </a:solidFill>
-          </a:ln>
-        </p:spPr>
-        <p:style>
-          <a:lnRef idx="1">
-            <a:schemeClr val="accent1"/>
-          </a:lnRef>
-          <a:fillRef idx="3">
-            <a:schemeClr val="accent1"/>
-          </a:fillRef>
-          <a:effectRef idx="2">
-            <a:schemeClr val="accent1"/>
-          </a:effectRef>
-          <a:fontRef idx="minor">
-            <a:schemeClr val="lt1"/>
-          </a:fontRef>
-        </p:style>
-        <p:txBody>
-          <a:bodyPr rtlCol="0" anchor="ctr"/>
-          <a:lstStyle/>
-          <a:p>
-            <a:pPr algn="ctr"/>
-          </a:p>
-        </p:txBody>
-      </p:sp>
-      <p:sp>
-        <p:nvSpPr>
-          <p:cNvPr id="24" name="TextBox 23"/>
-          <p:cNvSpPr txBox="1"/>
-          <p:nvPr/>
-        </p:nvSpPr>
-        <p:spPr>
-          <a:xfrm>
-            <a:off x="457200" y="2724912"/>
-            <a:ext cx="777240" cy="411480"/>
-          </a:xfrm>
-          <a:prstGeom prst="rect">
-            <a:avLst/>
-          </a:prstGeom>
-          <a:noFill/>
-        </p:spPr>
-        <p:txBody>
-          <a:bodyPr wrap="square">
-            <a:spAutoFit/>
-          </a:bodyPr>
-          <a:lstStyle/>
-          <a:p>
-            <a:pPr algn="ctr"/>
-            <a:r>
-              <a:rPr sz="1400" b="1">
-                <a:solidFill>
-                  <a:srgbClr val="C00000"/>
-                </a:solidFill>
-              </a:rPr>
-              <a:t>−1</a:t>
-            </a:r>
-          </a:p>
-        </p:txBody>
-      </p:sp>
-      <p:sp>
-        <p:nvSpPr>
-          <p:cNvPr id="25" name="Rectangle 24"/>
-          <p:cNvSpPr/>
-          <p:nvPr/>
-        </p:nvSpPr>
-        <p:spPr>
-          <a:xfrm>
-            <a:off x="1280160" y="2651760"/>
-            <a:ext cx="777240" cy="457200"/>
-          </a:xfrm>
-          <a:prstGeom prst="rect">
-            <a:avLst/>
-          </a:prstGeom>
-          <a:solidFill>
-            <a:srgbClr val="E2EFDA"/>
-          </a:solidFill>
-          <a:ln w="12700">
-            <a:solidFill>
-              <a:srgbClr val="1F4E79"/>
-            </a:solidFill>
-          </a:ln>
-        </p:spPr>
-        <p:style>
-          <a:lnRef idx="1">
-            <a:schemeClr val="accent1"/>
-          </a:lnRef>
-          <a:fillRef idx="3">
-            <a:schemeClr val="accent1"/>
-          </a:fillRef>
-          <a:effectRef idx="2">
-            <a:schemeClr val="accent1"/>
-          </a:effectRef>
-          <a:fontRef idx="minor">
-            <a:schemeClr val="lt1"/>
-          </a:fontRef>
-        </p:style>
-        <p:txBody>
-          <a:bodyPr rtlCol="0" anchor="ctr"/>
-          <a:lstStyle/>
-          <a:p>
-            <a:pPr algn="ctr"/>
-          </a:p>
-        </p:txBody>
-      </p:sp>
-      <p:sp>
-        <p:nvSpPr>
-          <p:cNvPr id="26" name="TextBox 25"/>
-          <p:cNvSpPr txBox="1"/>
-          <p:nvPr/>
-        </p:nvSpPr>
-        <p:spPr>
-          <a:xfrm>
-            <a:off x="1280160" y="2724912"/>
-            <a:ext cx="777240" cy="411480"/>
-          </a:xfrm>
-          <a:prstGeom prst="rect">
-            <a:avLst/>
-          </a:prstGeom>
-          <a:noFill/>
-        </p:spPr>
-        <p:txBody>
-          <a:bodyPr wrap="square">
-            <a:spAutoFit/>
-          </a:bodyPr>
-          <a:lstStyle/>
-          <a:p>
-            <a:pPr algn="ctr"/>
-            <a:r>
-              <a:rPr sz="1400" b="1">
-                <a:solidFill>
-                  <a:srgbClr val="1A7A4A"/>
-                </a:solidFill>
-              </a:rPr>
-              <a:t>+1</a:t>
-            </a:r>
-          </a:p>
-        </p:txBody>
-      </p:sp>
-      <p:sp>
-        <p:nvSpPr>
-          <p:cNvPr id="27" name="Rectangle 26"/>
-          <p:cNvSpPr/>
-          <p:nvPr/>
-        </p:nvSpPr>
-        <p:spPr>
-          <a:xfrm>
-            <a:off x="2103120" y="2651760"/>
-            <a:ext cx="777240" cy="457200"/>
-          </a:xfrm>
-          <a:prstGeom prst="rect">
-            <a:avLst/>
-          </a:prstGeom>
-          <a:solidFill>
-            <a:srgbClr val="E2EFDA"/>
-          </a:solidFill>
-          <a:ln w="12700">
-            <a:solidFill>
-              <a:srgbClr val="1F4E79"/>
-            </a:solidFill>
-          </a:ln>
-        </p:spPr>
-        <p:style>
-          <a:lnRef idx="1">
-            <a:schemeClr val="accent1"/>
-          </a:lnRef>
-          <a:fillRef idx="3">
-            <a:schemeClr val="accent1"/>
-          </a:fillRef>
-          <a:effectRef idx="2">
-            <a:schemeClr val="accent1"/>
-          </a:effectRef>
-          <a:fontRef idx="minor">
-            <a:schemeClr val="lt1"/>
-          </a:fontRef>
-        </p:style>
-        <p:txBody>
-          <a:bodyPr rtlCol="0" anchor="ctr"/>
-          <a:lstStyle/>
-          <a:p>
-            <a:pPr algn="ctr"/>
-          </a:p>
-        </p:txBody>
-      </p:sp>
-      <p:sp>
-        <p:nvSpPr>
-          <p:cNvPr id="28" name="TextBox 27"/>
-          <p:cNvSpPr txBox="1"/>
-          <p:nvPr/>
-        </p:nvSpPr>
-        <p:spPr>
-          <a:xfrm>
-            <a:off x="2103120" y="2724912"/>
-            <a:ext cx="777240" cy="411480"/>
-          </a:xfrm>
-          <a:prstGeom prst="rect">
-            <a:avLst/>
-          </a:prstGeom>
-          <a:noFill/>
-        </p:spPr>
-        <p:txBody>
-          <a:bodyPr wrap="square">
-            <a:spAutoFit/>
-          </a:bodyPr>
-          <a:lstStyle/>
-          <a:p>
-            <a:pPr algn="ctr"/>
-            <a:r>
-              <a:rPr sz="1400" b="1">
-                <a:solidFill>
-                  <a:srgbClr val="1A7A4A"/>
-                </a:solidFill>
-              </a:rPr>
-              <a:t>+1</a:t>
-            </a:r>
-          </a:p>
-        </p:txBody>
-      </p:sp>
-      <p:sp>
-        <p:nvSpPr>
-          <p:cNvPr id="29" name="Rectangle 28"/>
-          <p:cNvSpPr/>
-          <p:nvPr/>
-        </p:nvSpPr>
-        <p:spPr>
-          <a:xfrm>
-            <a:off x="2926080" y="2651760"/>
-            <a:ext cx="777240" cy="457200"/>
-          </a:xfrm>
-          <a:prstGeom prst="rect">
-            <a:avLst/>
-          </a:prstGeom>
-          <a:solidFill>
-            <a:srgbClr val="FFE0E0"/>
-          </a:solidFill>
-          <a:ln w="12700">
-            <a:solidFill>
-              <a:srgbClr val="1F4E79"/>
-            </a:solidFill>
-          </a:ln>
-        </p:spPr>
-        <p:style>
-          <a:lnRef idx="1">
-            <a:schemeClr val="accent1"/>
-          </a:lnRef>
-          <a:fillRef idx="3">
-            <a:schemeClr val="accent1"/>
-          </a:fillRef>
-          <a:effectRef idx="2">
-            <a:schemeClr val="accent1"/>
-          </a:effectRef>
-          <a:fontRef idx="minor">
-            <a:schemeClr val="lt1"/>
-          </a:fontRef>
-        </p:style>
-        <p:txBody>
-          <a:bodyPr rtlCol="0" anchor="ctr"/>
-          <a:lstStyle/>
-          <a:p>
-            <a:pPr algn="ctr"/>
-          </a:p>
-        </p:txBody>
-      </p:sp>
-      <p:sp>
-        <p:nvSpPr>
-          <p:cNvPr id="30" name="TextBox 29"/>
-          <p:cNvSpPr txBox="1"/>
-          <p:nvPr/>
-        </p:nvSpPr>
-        <p:spPr>
-          <a:xfrm>
-            <a:off x="2926080" y="2724912"/>
-            <a:ext cx="777240" cy="411480"/>
-          </a:xfrm>
-          <a:prstGeom prst="rect">
-            <a:avLst/>
-          </a:prstGeom>
-          <a:noFill/>
-        </p:spPr>
-        <p:txBody>
-          <a:bodyPr wrap="square">
-            <a:spAutoFit/>
-          </a:bodyPr>
-          <a:lstStyle/>
-          <a:p>
-            <a:pPr algn="ctr"/>
-            <a:r>
-              <a:rPr sz="1400" b="1">
-                <a:solidFill>
-                  <a:srgbClr val="C00000"/>
-                </a:solidFill>
-              </a:rPr>
-              <a:t>−1</a:t>
-            </a:r>
-          </a:p>
-        </p:txBody>
-      </p:sp>
-      <p:sp>
-        <p:nvSpPr>
-          <p:cNvPr id="31" name="Rectangle 30"/>
-          <p:cNvSpPr/>
-          <p:nvPr/>
-        </p:nvSpPr>
-        <p:spPr>
-          <a:xfrm>
-            <a:off x="457200" y="3154680"/>
-            <a:ext cx="777240" cy="457200"/>
-          </a:xfrm>
-          <a:prstGeom prst="rect">
-            <a:avLst/>
-          </a:prstGeom>
-          <a:solidFill>
-            <a:srgbClr val="FFE0E0"/>
-          </a:solidFill>
-          <a:ln w="12700">
-            <a:solidFill>
-              <a:srgbClr val="1F4E79"/>
-            </a:solidFill>
-          </a:ln>
-        </p:spPr>
-        <p:style>
-          <a:lnRef idx="1">
-            <a:schemeClr val="accent1"/>
-          </a:lnRef>
-          <a:fillRef idx="3">
-            <a:schemeClr val="accent1"/>
-          </a:fillRef>
-          <a:effectRef idx="2">
-            <a:schemeClr val="accent1"/>
-          </a:effectRef>
-          <a:fontRef idx="minor">
-            <a:schemeClr val="lt1"/>
-          </a:fontRef>
-        </p:style>
-        <p:txBody>
-          <a:bodyPr rtlCol="0" anchor="ctr"/>
-          <a:lstStyle/>
-          <a:p>
-            <a:pPr algn="ctr"/>
-          </a:p>
-        </p:txBody>
-      </p:sp>
-      <p:sp>
-        <p:nvSpPr>
-          <p:cNvPr id="32" name="TextBox 31"/>
-          <p:cNvSpPr txBox="1"/>
-          <p:nvPr/>
-        </p:nvSpPr>
-        <p:spPr>
-          <a:xfrm>
-            <a:off x="457200" y="3227832"/>
-            <a:ext cx="777240" cy="411480"/>
-          </a:xfrm>
-          <a:prstGeom prst="rect">
-            <a:avLst/>
-          </a:prstGeom>
-          <a:noFill/>
-        </p:spPr>
-        <p:txBody>
-          <a:bodyPr wrap="square">
-            <a:spAutoFit/>
-          </a:bodyPr>
-          <a:lstStyle/>
-          <a:p>
-            <a:pPr algn="ctr"/>
-            <a:r>
-              <a:rPr sz="1400" b="1">
-                <a:solidFill>
-                  <a:srgbClr val="C00000"/>
-                </a:solidFill>
-              </a:rPr>
-              <a:t>−1</a:t>
-            </a:r>
-          </a:p>
-        </p:txBody>
-      </p:sp>
-      <p:sp>
-        <p:nvSpPr>
-          <p:cNvPr id="33" name="Rectangle 32"/>
-          <p:cNvSpPr/>
-          <p:nvPr/>
-        </p:nvSpPr>
-        <p:spPr>
-          <a:xfrm>
-            <a:off x="1280160" y="3154680"/>
-            <a:ext cx="777240" cy="457200"/>
-          </a:xfrm>
-          <a:prstGeom prst="rect">
-            <a:avLst/>
-          </a:prstGeom>
-          <a:solidFill>
-            <a:srgbClr val="FFE0E0"/>
-          </a:solidFill>
-          <a:ln w="12700">
-            <a:solidFill>
-              <a:srgbClr val="1F4E79"/>
-            </a:solidFill>
-          </a:ln>
-        </p:spPr>
-        <p:style>
-          <a:lnRef idx="1">
-            <a:schemeClr val="accent1"/>
-          </a:lnRef>
-          <a:fillRef idx="3">
-            <a:schemeClr val="accent1"/>
-          </a:fillRef>
-          <a:effectRef idx="2">
-            <a:schemeClr val="accent1"/>
-          </a:effectRef>
-          <a:fontRef idx="minor">
-            <a:schemeClr val="lt1"/>
-          </a:fontRef>
-        </p:style>
-        <p:txBody>
-          <a:bodyPr rtlCol="0" anchor="ctr"/>
-          <a:lstStyle/>
-          <a:p>
-            <a:pPr algn="ctr"/>
-          </a:p>
-        </p:txBody>
-      </p:sp>
-      <p:sp>
-        <p:nvSpPr>
-          <p:cNvPr id="34" name="TextBox 33"/>
-          <p:cNvSpPr txBox="1"/>
-          <p:nvPr/>
-        </p:nvSpPr>
-        <p:spPr>
-          <a:xfrm>
-            <a:off x="1280160" y="3227832"/>
-            <a:ext cx="777240" cy="411480"/>
-          </a:xfrm>
-          <a:prstGeom prst="rect">
-            <a:avLst/>
-          </a:prstGeom>
-          <a:noFill/>
-        </p:spPr>
-        <p:txBody>
-          <a:bodyPr wrap="square">
-            <a:spAutoFit/>
-          </a:bodyPr>
-          <a:lstStyle/>
-          <a:p>
-            <a:pPr algn="ctr"/>
-            <a:r>
-              <a:rPr sz="1400" b="1">
-                <a:solidFill>
-                  <a:srgbClr val="C00000"/>
-                </a:solidFill>
-              </a:rPr>
-              <a:t>−1</a:t>
-            </a:r>
-          </a:p>
-        </p:txBody>
-      </p:sp>
-      <p:sp>
-        <p:nvSpPr>
-          <p:cNvPr id="35" name="Rectangle 34"/>
-          <p:cNvSpPr/>
-          <p:nvPr/>
-        </p:nvSpPr>
-        <p:spPr>
-          <a:xfrm>
-            <a:off x="2103120" y="3154680"/>
-            <a:ext cx="777240" cy="457200"/>
-          </a:xfrm>
-          <a:prstGeom prst="rect">
-            <a:avLst/>
-          </a:prstGeom>
-          <a:solidFill>
-            <a:srgbClr val="FFE0E0"/>
-          </a:solidFill>
-          <a:ln w="12700">
-            <a:solidFill>
-              <a:srgbClr val="1F4E79"/>
-            </a:solidFill>
-          </a:ln>
-        </p:spPr>
-        <p:style>
-          <a:lnRef idx="1">
-            <a:schemeClr val="accent1"/>
-          </a:lnRef>
-          <a:fillRef idx="3">
-            <a:schemeClr val="accent1"/>
-          </a:fillRef>
-          <a:effectRef idx="2">
-            <a:schemeClr val="accent1"/>
-          </a:effectRef>
-          <a:fontRef idx="minor">
-            <a:schemeClr val="lt1"/>
-          </a:fontRef>
-        </p:style>
-        <p:txBody>
-          <a:bodyPr rtlCol="0" anchor="ctr"/>
-          <a:lstStyle/>
-          <a:p>
-            <a:pPr algn="ctr"/>
-          </a:p>
-        </p:txBody>
-      </p:sp>
-      <p:sp>
-        <p:nvSpPr>
-          <p:cNvPr id="36" name="TextBox 35"/>
-          <p:cNvSpPr txBox="1"/>
-          <p:nvPr/>
-        </p:nvSpPr>
-        <p:spPr>
-          <a:xfrm>
-            <a:off x="2103120" y="3227832"/>
-            <a:ext cx="777240" cy="411480"/>
-          </a:xfrm>
-          <a:prstGeom prst="rect">
-            <a:avLst/>
-          </a:prstGeom>
-          <a:noFill/>
-        </p:spPr>
-        <p:txBody>
-          <a:bodyPr wrap="square">
-            <a:spAutoFit/>
-          </a:bodyPr>
-          <a:lstStyle/>
-          <a:p>
-            <a:pPr algn="ctr"/>
-            <a:r>
-              <a:rPr sz="1400" b="1">
-                <a:solidFill>
-                  <a:srgbClr val="C00000"/>
-                </a:solidFill>
-              </a:rPr>
-              <a:t>−1</a:t>
-            </a:r>
-          </a:p>
-        </p:txBody>
-      </p:sp>
-      <p:sp>
-        <p:nvSpPr>
-          <p:cNvPr id="37" name="Rectangle 36"/>
-          <p:cNvSpPr/>
-          <p:nvPr/>
-        </p:nvSpPr>
-        <p:spPr>
-          <a:xfrm>
-            <a:off x="2926080" y="3154680"/>
-            <a:ext cx="777240" cy="457200"/>
-          </a:xfrm>
-          <a:prstGeom prst="rect">
-            <a:avLst/>
-          </a:prstGeom>
-          <a:solidFill>
-            <a:srgbClr val="E2EFDA"/>
-          </a:solidFill>
-          <a:ln w="12700">
-            <a:solidFill>
-              <a:srgbClr val="1F4E79"/>
-            </a:solidFill>
-          </a:ln>
-        </p:spPr>
-        <p:style>
-          <a:lnRef idx="1">
-            <a:schemeClr val="accent1"/>
-          </a:lnRef>
-          <a:fillRef idx="3">
-            <a:schemeClr val="accent1"/>
-          </a:fillRef>
-          <a:effectRef idx="2">
-            <a:schemeClr val="accent1"/>
-          </a:effectRef>
-          <a:fontRef idx="minor">
-            <a:schemeClr val="lt1"/>
-          </a:fontRef>
-        </p:style>
-        <p:txBody>
-          <a:bodyPr rtlCol="0" anchor="ctr"/>
-          <a:lstStyle/>
-          <a:p>
-            <a:pPr algn="ctr"/>
-          </a:p>
-        </p:txBody>
-      </p:sp>
-      <p:sp>
-        <p:nvSpPr>
-          <p:cNvPr id="38" name="TextBox 37"/>
-          <p:cNvSpPr txBox="1"/>
-          <p:nvPr/>
-        </p:nvSpPr>
-        <p:spPr>
-          <a:xfrm>
-            <a:off x="2926080" y="3227832"/>
-            <a:ext cx="777240" cy="411480"/>
-          </a:xfrm>
-          <a:prstGeom prst="rect">
-            <a:avLst/>
-          </a:prstGeom>
-          <a:noFill/>
-        </p:spPr>
-        <p:txBody>
-          <a:bodyPr wrap="square">
-            <a:spAutoFit/>
-          </a:bodyPr>
-          <a:lstStyle/>
-          <a:p>
-            <a:pPr algn="ctr"/>
-            <a:r>
-              <a:rPr sz="1400" b="1">
-                <a:solidFill>
-                  <a:srgbClr val="1A7A4A"/>
-                </a:solidFill>
-              </a:rPr>
-              <a:t>+1</a:t>
-            </a:r>
-          </a:p>
-        </p:txBody>
-      </p:sp>
-      <p:sp>
-        <p:nvSpPr>
-          <p:cNvPr id="39" name="TextBox 38"/>
-          <p:cNvSpPr txBox="1"/>
-          <p:nvPr/>
-        </p:nvSpPr>
-        <p:spPr>
-          <a:xfrm>
-            <a:off x="365760" y="3840480"/>
-            <a:ext cx="5029200" cy="457200"/>
-          </a:xfrm>
-          <a:prstGeom prst="rect">
-            <a:avLst/>
-          </a:prstGeom>
-          <a:noFill/>
-        </p:spPr>
-        <p:txBody>
-          <a:bodyPr wrap="square">
-            <a:spAutoFit/>
-          </a:bodyPr>
-          <a:lstStyle/>
-          <a:p>
-            <a:pPr algn="l"/>
-            <a:r>
-              <a:rPr sz="1500" b="1">
-                <a:solidFill>
-                  <a:srgbClr val="1F4E79"/>
-                </a:solidFill>
-              </a:rPr>
-              <a:t>Inputs: x = [10, 20, 30, 40]</a:t>
-            </a:r>
-          </a:p>
-        </p:txBody>
-      </p:sp>
-      <p:sp>
-        <p:nvSpPr>
-          <p:cNvPr id="40" name="TextBox 39"/>
-          <p:cNvSpPr txBox="1"/>
-          <p:nvPr/>
-        </p:nvSpPr>
-        <p:spPr>
-          <a:xfrm>
-            <a:off x="5669280" y="1188720"/>
-            <a:ext cx="6217920" cy="411480"/>
-          </a:xfrm>
-          <a:prstGeom prst="rect">
-            <a:avLst/>
-          </a:prstGeom>
-          <a:noFill/>
-        </p:spPr>
-        <p:txBody>
-          <a:bodyPr wrap="square">
-            <a:spAutoFit/>
-          </a:bodyPr>
-          <a:lstStyle/>
-          <a:p>
-            <a:pPr algn="l"/>
-            <a:r>
-              <a:rPr sz="1500" b="1">
-                <a:solidFill>
-                  <a:srgbClr val="1F4E79"/>
-                </a:solidFill>
-              </a:rPr>
-              <a:t>Hand-calculated expected outputs</a:t>
-            </a:r>
-          </a:p>
-        </p:txBody>
-      </p:sp>
-      <p:sp>
-        <p:nvSpPr>
-          <p:cNvPr id="41" name="Rectangle 40"/>
-          <p:cNvSpPr/>
-          <p:nvPr/>
-        </p:nvSpPr>
-        <p:spPr>
-          <a:xfrm>
-            <a:off x="5669280" y="1645920"/>
-            <a:ext cx="6217920" cy="914400"/>
-          </a:xfrm>
-          <a:prstGeom prst="rect">
-            <a:avLst/>
-          </a:prstGeom>
-          <a:solidFill>
-            <a:srgbClr val="FFFFFF"/>
-          </a:solidFill>
-          <a:ln w="12700">
-            <a:solidFill>
-              <a:srgbClr val="1F4E79"/>
-            </a:solidFill>
-          </a:ln>
-        </p:spPr>
-        <p:style>
-          <a:lnRef idx="1">
-            <a:schemeClr val="accent1"/>
-          </a:lnRef>
-          <a:fillRef idx="3">
-            <a:schemeClr val="accent1"/>
-          </a:fillRef>
-          <a:effectRef idx="2">
-            <a:schemeClr val="accent1"/>
-          </a:effectRef>
-          <a:fontRef idx="minor">
-            <a:schemeClr val="lt1"/>
-          </a:fontRef>
-        </p:style>
-        <p:txBody>
-          <a:bodyPr rtlCol="0" anchor="ctr"/>
-          <a:lstStyle/>
-          <a:p>
-            <a:pPr algn="ctr"/>
-          </a:p>
-        </p:txBody>
-      </p:sp>
-      <p:sp>
-        <p:nvSpPr>
-          <p:cNvPr id="42" name="TextBox 41"/>
-          <p:cNvSpPr txBox="1"/>
-          <p:nvPr/>
-        </p:nvSpPr>
-        <p:spPr>
-          <a:xfrm>
-            <a:off x="5760720" y="1691640"/>
-            <a:ext cx="731520" cy="365760"/>
-          </a:xfrm>
-          <a:prstGeom prst="rect">
-            <a:avLst/>
-          </a:prstGeom>
-          <a:noFill/>
-        </p:spPr>
-        <p:txBody>
-          <a:bodyPr wrap="square">
-            <a:spAutoFit/>
-          </a:bodyPr>
-          <a:lstStyle/>
-          <a:p>
-            <a:pPr algn="l"/>
-            <a:r>
-              <a:rPr sz="1300" b="1">
-                <a:solidFill>
-                  <a:srgbClr val="1F4E79"/>
-                </a:solidFill>
-              </a:rPr>
-              <a:t>y[0]</a:t>
-            </a:r>
-          </a:p>
-        </p:txBody>
-      </p:sp>
-      <p:sp>
-        <p:nvSpPr>
-          <p:cNvPr id="43" name="TextBox 42"/>
-          <p:cNvSpPr txBox="1"/>
-          <p:nvPr/>
-        </p:nvSpPr>
-        <p:spPr>
-          <a:xfrm>
-            <a:off x="6492240" y="1691640"/>
-            <a:ext cx="3657600" cy="365760"/>
-          </a:xfrm>
-          <a:prstGeom prst="rect">
-            <a:avLst/>
-          </a:prstGeom>
-          <a:noFill/>
-        </p:spPr>
-        <p:txBody>
-          <a:bodyPr wrap="square">
-            <a:spAutoFit/>
-          </a:bodyPr>
-          <a:lstStyle/>
-          <a:p>
-            <a:pPr algn="l"/>
-            <a:r>
-              <a:rPr sz="1300" b="0">
-                <a:solidFill>
-                  <a:srgbClr val="444444"/>
-                </a:solidFill>
-              </a:rPr>
-              <a:t>+10 + 20 − 30 − 40</a:t>
-            </a:r>
-          </a:p>
-        </p:txBody>
-      </p:sp>
-      <p:sp>
-        <p:nvSpPr>
-          <p:cNvPr id="44" name="TextBox 43"/>
-          <p:cNvSpPr txBox="1"/>
-          <p:nvPr/>
-        </p:nvSpPr>
-        <p:spPr>
-          <a:xfrm>
-            <a:off x="10241280" y="1691640"/>
-            <a:ext cx="1554480" cy="365760"/>
-          </a:xfrm>
-          <a:prstGeom prst="rect">
-            <a:avLst/>
-          </a:prstGeom>
-          <a:noFill/>
-        </p:spPr>
-        <p:txBody>
-          <a:bodyPr wrap="square">
-            <a:spAutoFit/>
-          </a:bodyPr>
-          <a:lstStyle/>
-          <a:p>
-            <a:pPr algn="l"/>
-            <a:r>
-              <a:rPr sz="1300" b="1">
-                <a:solidFill>
-                  <a:srgbClr val="1A7A4A"/>
-                </a:solidFill>
-              </a:rPr>
-              <a:t>= −40</a:t>
-            </a:r>
-          </a:p>
-        </p:txBody>
-      </p:sp>
-      <p:sp>
-        <p:nvSpPr>
-          <p:cNvPr id="45" name="Rectangle 44"/>
-          <p:cNvSpPr/>
-          <p:nvPr/>
-        </p:nvSpPr>
-        <p:spPr>
-          <a:xfrm>
-            <a:off x="5669280" y="2743200"/>
-            <a:ext cx="6217920" cy="914400"/>
-          </a:xfrm>
-          <a:prstGeom prst="rect">
-            <a:avLst/>
-          </a:prstGeom>
-          <a:solidFill>
-            <a:srgbClr val="FFFFFF"/>
-          </a:solidFill>
-          <a:ln w="12700">
-            <a:solidFill>
-              <a:srgbClr val="1F4E79"/>
-            </a:solidFill>
-          </a:ln>
-        </p:spPr>
-        <p:style>
-          <a:lnRef idx="1">
-            <a:schemeClr val="accent1"/>
-          </a:lnRef>
-          <a:fillRef idx="3">
-            <a:schemeClr val="accent1"/>
-          </a:fillRef>
-          <a:effectRef idx="2">
-            <a:schemeClr val="accent1"/>
-          </a:effectRef>
-          <a:fontRef idx="minor">
-            <a:schemeClr val="lt1"/>
-          </a:fontRef>
-        </p:style>
-        <p:txBody>
-          <a:bodyPr rtlCol="0" anchor="ctr"/>
-          <a:lstStyle/>
-          <a:p>
-            <a:pPr algn="ctr"/>
-          </a:p>
-        </p:txBody>
-      </p:sp>
-      <p:sp>
-        <p:nvSpPr>
-          <p:cNvPr id="46" name="TextBox 45"/>
-          <p:cNvSpPr txBox="1"/>
-          <p:nvPr/>
-        </p:nvSpPr>
-        <p:spPr>
-          <a:xfrm>
-            <a:off x="5760720" y="2788920"/>
-            <a:ext cx="731520" cy="365760"/>
-          </a:xfrm>
-          <a:prstGeom prst="rect">
-            <a:avLst/>
-          </a:prstGeom>
-          <a:noFill/>
-        </p:spPr>
-        <p:txBody>
-          <a:bodyPr wrap="square">
-            <a:spAutoFit/>
-          </a:bodyPr>
-          <a:lstStyle/>
-          <a:p>
-            <a:pPr algn="l"/>
-            <a:r>
-              <a:rPr sz="1300" b="1">
-                <a:solidFill>
-                  <a:srgbClr val="1F4E79"/>
-                </a:solidFill>
-              </a:rPr>
-              <a:t>y[1]</a:t>
-            </a:r>
-          </a:p>
-        </p:txBody>
-      </p:sp>
-      <p:sp>
-        <p:nvSpPr>
-          <p:cNvPr id="47" name="TextBox 46"/>
-          <p:cNvSpPr txBox="1"/>
-          <p:nvPr/>
-        </p:nvSpPr>
-        <p:spPr>
-          <a:xfrm>
-            <a:off x="6492240" y="2788920"/>
-            <a:ext cx="3657600" cy="365760"/>
-          </a:xfrm>
-          <a:prstGeom prst="rect">
-            <a:avLst/>
-          </a:prstGeom>
-          <a:noFill/>
-        </p:spPr>
-        <p:txBody>
-          <a:bodyPr wrap="square">
-            <a:spAutoFit/>
-          </a:bodyPr>
-          <a:lstStyle/>
-          <a:p>
-            <a:pPr algn="l"/>
-            <a:r>
-              <a:rPr sz="1300" b="0">
-                <a:solidFill>
-                  <a:srgbClr val="444444"/>
-                </a:solidFill>
-              </a:rPr>
-              <a:t>−10 + 20 + 30 − 40</a:t>
-            </a:r>
-          </a:p>
-        </p:txBody>
-      </p:sp>
-      <p:sp>
-        <p:nvSpPr>
-          <p:cNvPr id="48" name="TextBox 47"/>
-          <p:cNvSpPr txBox="1"/>
-          <p:nvPr/>
-        </p:nvSpPr>
-        <p:spPr>
-          <a:xfrm>
-            <a:off x="10241280" y="2788920"/>
-            <a:ext cx="1554480" cy="365760"/>
-          </a:xfrm>
-          <a:prstGeom prst="rect">
-            <a:avLst/>
-          </a:prstGeom>
-          <a:noFill/>
-        </p:spPr>
-        <p:txBody>
-          <a:bodyPr wrap="square">
-            <a:spAutoFit/>
-          </a:bodyPr>
-          <a:lstStyle/>
-          <a:p>
-            <a:pPr algn="l"/>
-            <a:r>
-              <a:rPr sz="1300" b="1">
-                <a:solidFill>
-                  <a:srgbClr val="1A7A4A"/>
-                </a:solidFill>
-              </a:rPr>
-              <a:t>=    0</a:t>
-            </a:r>
-          </a:p>
-        </p:txBody>
-      </p:sp>
-      <p:sp>
-        <p:nvSpPr>
-          <p:cNvPr id="49" name="Rectangle 48"/>
-          <p:cNvSpPr/>
-          <p:nvPr/>
-        </p:nvSpPr>
-        <p:spPr>
-          <a:xfrm>
-            <a:off x="5669280" y="3840480"/>
-            <a:ext cx="6217920" cy="914400"/>
-          </a:xfrm>
-          <a:prstGeom prst="rect">
-            <a:avLst/>
-          </a:prstGeom>
-          <a:solidFill>
-            <a:srgbClr val="FFFFFF"/>
-          </a:solidFill>
-          <a:ln w="12700">
-            <a:solidFill>
-              <a:srgbClr val="1F4E79"/>
-            </a:solidFill>
-          </a:ln>
-        </p:spPr>
-        <p:style>
-          <a:lnRef idx="1">
-            <a:schemeClr val="accent1"/>
-          </a:lnRef>
-          <a:fillRef idx="3">
-            <a:schemeClr val="accent1"/>
-          </a:fillRef>
-          <a:effectRef idx="2">
-            <a:schemeClr val="accent1"/>
-          </a:effectRef>
-          <a:fontRef idx="minor">
-            <a:schemeClr val="lt1"/>
-          </a:fontRef>
-        </p:style>
-        <p:txBody>
-          <a:bodyPr rtlCol="0" anchor="ctr"/>
-          <a:lstStyle/>
-          <a:p>
-            <a:pPr algn="ctr"/>
-          </a:p>
-        </p:txBody>
-      </p:sp>
-      <p:sp>
-        <p:nvSpPr>
-          <p:cNvPr id="50" name="TextBox 49"/>
-          <p:cNvSpPr txBox="1"/>
-          <p:nvPr/>
-        </p:nvSpPr>
-        <p:spPr>
-          <a:xfrm>
-            <a:off x="5760720" y="3886200"/>
-            <a:ext cx="731520" cy="365760"/>
-          </a:xfrm>
-          <a:prstGeom prst="rect">
-            <a:avLst/>
-          </a:prstGeom>
-          <a:noFill/>
-        </p:spPr>
-        <p:txBody>
-          <a:bodyPr wrap="square">
-            <a:spAutoFit/>
-          </a:bodyPr>
-          <a:lstStyle/>
-          <a:p>
-            <a:pPr algn="l"/>
-            <a:r>
-              <a:rPr sz="1300" b="1">
-                <a:solidFill>
-                  <a:srgbClr val="1F4E79"/>
-                </a:solidFill>
-              </a:rPr>
-              <a:t>y[2]</a:t>
-            </a:r>
-          </a:p>
-        </p:txBody>
-      </p:sp>
-      <p:sp>
-        <p:nvSpPr>
-          <p:cNvPr id="51" name="TextBox 50"/>
-          <p:cNvSpPr txBox="1"/>
-          <p:nvPr/>
-        </p:nvSpPr>
-        <p:spPr>
-          <a:xfrm>
-            <a:off x="6492240" y="3886200"/>
-            <a:ext cx="3657600" cy="365760"/>
-          </a:xfrm>
-          <a:prstGeom prst="rect">
-            <a:avLst/>
-          </a:prstGeom>
-          <a:noFill/>
-        </p:spPr>
-        <p:txBody>
-          <a:bodyPr wrap="square">
-            <a:spAutoFit/>
-          </a:bodyPr>
-          <a:lstStyle/>
-          <a:p>
-            <a:pPr algn="l"/>
-            <a:r>
-              <a:rPr sz="1300" b="0">
-                <a:solidFill>
-                  <a:srgbClr val="444444"/>
-                </a:solidFill>
-              </a:rPr>
-              <a:t>+10 − 20 + 30 − 40</a:t>
-            </a:r>
-          </a:p>
-        </p:txBody>
-      </p:sp>
-      <p:sp>
-        <p:nvSpPr>
-          <p:cNvPr id="52" name="TextBox 51"/>
-          <p:cNvSpPr txBox="1"/>
-          <p:nvPr/>
-        </p:nvSpPr>
-        <p:spPr>
-          <a:xfrm>
-            <a:off x="10241280" y="3886200"/>
-            <a:ext cx="1554480" cy="365760"/>
-          </a:xfrm>
-          <a:prstGeom prst="rect">
-            <a:avLst/>
-          </a:prstGeom>
-          <a:noFill/>
-        </p:spPr>
-        <p:txBody>
-          <a:bodyPr wrap="square">
-            <a:spAutoFit/>
-          </a:bodyPr>
-          <a:lstStyle/>
-          <a:p>
-            <a:pPr algn="l"/>
-            <a:r>
-              <a:rPr sz="1300" b="1">
-                <a:solidFill>
-                  <a:srgbClr val="1A7A4A"/>
-                </a:solidFill>
-              </a:rPr>
-              <a:t>= −20</a:t>
-            </a:r>
-          </a:p>
-        </p:txBody>
-      </p:sp>
-      <p:sp>
-        <p:nvSpPr>
-          <p:cNvPr id="53" name="Rectangle 52"/>
-          <p:cNvSpPr/>
-          <p:nvPr/>
-        </p:nvSpPr>
-        <p:spPr>
-          <a:xfrm>
-            <a:off x="5669280" y="4937759"/>
-            <a:ext cx="6217920" cy="914400"/>
-          </a:xfrm>
-          <a:prstGeom prst="rect">
-            <a:avLst/>
-          </a:prstGeom>
-          <a:solidFill>
-            <a:srgbClr val="FFFFFF"/>
-          </a:solidFill>
-          <a:ln w="12700">
-            <a:solidFill>
-              <a:srgbClr val="1F4E79"/>
-            </a:solidFill>
-          </a:ln>
-        </p:spPr>
-        <p:style>
-          <a:lnRef idx="1">
-            <a:schemeClr val="accent1"/>
-          </a:lnRef>
-          <a:fillRef idx="3">
-            <a:schemeClr val="accent1"/>
-          </a:fillRef>
-          <a:effectRef idx="2">
-            <a:schemeClr val="accent1"/>
-          </a:effectRef>
-          <a:fontRef idx="minor">
-            <a:schemeClr val="lt1"/>
-          </a:fontRef>
-        </p:style>
-        <p:txBody>
-          <a:bodyPr rtlCol="0" anchor="ctr"/>
-          <a:lstStyle/>
-          <a:p>
-            <a:pPr algn="ctr"/>
-          </a:p>
-        </p:txBody>
-      </p:sp>
-      <p:sp>
-        <p:nvSpPr>
-          <p:cNvPr id="54" name="TextBox 53"/>
-          <p:cNvSpPr txBox="1"/>
-          <p:nvPr/>
-        </p:nvSpPr>
-        <p:spPr>
-          <a:xfrm>
-            <a:off x="5760720" y="4983479"/>
-            <a:ext cx="731520" cy="365760"/>
-          </a:xfrm>
-          <a:prstGeom prst="rect">
-            <a:avLst/>
-          </a:prstGeom>
-          <a:noFill/>
-        </p:spPr>
-        <p:txBody>
-          <a:bodyPr wrap="square">
-            <a:spAutoFit/>
-          </a:bodyPr>
-          <a:lstStyle/>
-          <a:p>
-            <a:pPr algn="l"/>
-            <a:r>
-              <a:rPr sz="1300" b="1">
-                <a:solidFill>
-                  <a:srgbClr val="1F4E79"/>
-                </a:solidFill>
-              </a:rPr>
-              <a:t>y[3]</a:t>
-            </a:r>
-          </a:p>
-        </p:txBody>
-      </p:sp>
-      <p:sp>
-        <p:nvSpPr>
-          <p:cNvPr id="55" name="TextBox 54"/>
-          <p:cNvSpPr txBox="1"/>
-          <p:nvPr/>
-        </p:nvSpPr>
-        <p:spPr>
-          <a:xfrm>
-            <a:off x="6492240" y="4983479"/>
-            <a:ext cx="3657600" cy="365760"/>
-          </a:xfrm>
-          <a:prstGeom prst="rect">
-            <a:avLst/>
-          </a:prstGeom>
-          <a:noFill/>
-        </p:spPr>
-        <p:txBody>
-          <a:bodyPr wrap="square">
-            <a:spAutoFit/>
-          </a:bodyPr>
-          <a:lstStyle/>
-          <a:p>
-            <a:pPr algn="l"/>
-            <a:r>
-              <a:rPr sz="1300" b="0">
-                <a:solidFill>
-                  <a:srgbClr val="444444"/>
-                </a:solidFill>
-              </a:rPr>
-              <a:t>−10 − 20 − 30 + 40</a:t>
-            </a:r>
-          </a:p>
-        </p:txBody>
-      </p:sp>
-      <p:sp>
-        <p:nvSpPr>
-          <p:cNvPr id="56" name="TextBox 55"/>
-          <p:cNvSpPr txBox="1"/>
-          <p:nvPr/>
-        </p:nvSpPr>
-        <p:spPr>
-          <a:xfrm>
-            <a:off x="10241280" y="4983479"/>
-            <a:ext cx="1554480" cy="365760"/>
-          </a:xfrm>
-          <a:prstGeom prst="rect">
-            <a:avLst/>
-          </a:prstGeom>
-          <a:noFill/>
-        </p:spPr>
-        <p:txBody>
-          <a:bodyPr wrap="square">
-            <a:spAutoFit/>
-          </a:bodyPr>
-          <a:lstStyle/>
-          <a:p>
-            <a:pPr algn="l"/>
-            <a:r>
-              <a:rPr sz="1300" b="1">
-                <a:solidFill>
-                  <a:srgbClr val="1A7A4A"/>
-                </a:solidFill>
-              </a:rPr>
-              <a:t>= −20</a:t>
-            </a:r>
-          </a:p>
-        </p:txBody>
-      </p:sp>
+        </p:spPr>
+      </p:pic>
     </p:spTree>
   </p:cSld>
   <p:clrMapOvr>
@@ -7174,7 +4998,7 @@
             <a:avLst/>
           </a:prstGeom>
           <a:solidFill>
-            <a:srgbClr val="F2F2F2"/>
+            <a:srgbClr val="F4F4F4"/>
           </a:solidFill>
           <a:ln>
             <a:noFill/>
@@ -7211,7 +5035,7 @@
         <p:spPr>
           <a:xfrm>
             <a:off x="0" y="0"/>
-            <a:ext cx="12188952" cy="1005840"/>
+            <a:ext cx="12188952" cy="502920"/>
           </a:xfrm>
           <a:prstGeom prst="rect">
             <a:avLst/>
@@ -7247,47 +5071,13 @@
       </p:sp>
       <p:sp>
         <p:nvSpPr>
-          <p:cNvPr id="4" name="TextBox 3"/>
-          <p:cNvSpPr txBox="1"/>
-          <p:nvPr/>
-        </p:nvSpPr>
-        <p:spPr>
-          <a:xfrm>
-            <a:off x="274320" y="91440"/>
-            <a:ext cx="11612880" cy="822960"/>
-          </a:xfrm>
-          <a:prstGeom prst="rect">
-            <a:avLst/>
-          </a:prstGeom>
-          <a:noFill/>
-        </p:spPr>
-        <p:txBody>
-          <a:bodyPr wrap="square">
-            <a:spAutoFit/>
-          </a:bodyPr>
-          <a:lstStyle/>
-          <a:p>
-            <a:pPr algn="l"/>
-            <a:r>
-              <a:rPr sz="3200" b="1">
-                <a:solidFill>
-                  <a:srgbClr val="FFFFFF"/>
-                </a:solidFill>
-              </a:rPr>
-              <a:t>Testbench — 2-Cycle Output Latency</a:t>
-            </a:r>
-          </a:p>
-        </p:txBody>
-      </p:sp>
-      <p:sp>
-        <p:nvSpPr>
-          <p:cNvPr id="5" name="Rectangle 4"/>
+          <p:cNvPr id="4" name="Rectangle 3"/>
           <p:cNvSpPr/>
           <p:nvPr/>
         </p:nvSpPr>
         <p:spPr>
           <a:xfrm>
-            <a:off x="0" y="1005840"/>
+            <a:off x="0" y="502920"/>
             <a:ext cx="12188952" cy="54864"/>
           </a:xfrm>
           <a:prstGeom prst="rect">
@@ -7322,9 +5112,111 @@
           </a:p>
         </p:txBody>
       </p:sp>
+      <p:sp>
+        <p:nvSpPr>
+          <p:cNvPr id="5" name="TextBox 4"/>
+          <p:cNvSpPr txBox="1"/>
+          <p:nvPr/>
+        </p:nvSpPr>
+        <p:spPr>
+          <a:xfrm>
+            <a:off x="228600" y="54864"/>
+            <a:ext cx="11887200" cy="438912"/>
+          </a:xfrm>
+          <a:prstGeom prst="rect">
+            <a:avLst/>
+          </a:prstGeom>
+          <a:noFill/>
+        </p:spPr>
+        <p:txBody>
+          <a:bodyPr wrap="none">
+            <a:spAutoFit/>
+          </a:bodyPr>
+          <a:lstStyle/>
+          <a:p>
+            <a:pPr algn="l"/>
+            <a:r>
+              <a:rPr sz="2200" b="1">
+                <a:solidFill>
+                  <a:srgbClr val="FFFFFF"/>
+                </a:solidFill>
+              </a:rPr>
+              <a:t>The Simulation Results</a:t>
+            </a:r>
+          </a:p>
+        </p:txBody>
+      </p:sp>
+      <p:sp>
+        <p:nvSpPr>
+          <p:cNvPr id="6" name="TextBox 5"/>
+          <p:cNvSpPr txBox="1"/>
+          <p:nvPr/>
+        </p:nvSpPr>
+        <p:spPr>
+          <a:xfrm>
+            <a:off x="274320" y="685800"/>
+            <a:ext cx="6858000" cy="2743200"/>
+          </a:xfrm>
+          <a:prstGeom prst="rect">
+            <a:avLst/>
+          </a:prstGeom>
+          <a:noFill/>
+        </p:spPr>
+        <p:txBody>
+          <a:bodyPr wrap="square">
+            <a:spAutoFit/>
+          </a:bodyPr>
+          <a:lstStyle/>
+          <a:p>
+            <a:pPr>
+              <a:spcBef>
+                <a:spcPts val="500"/>
+              </a:spcBef>
+            </a:pPr>
+            <a:r>
+              <a:rPr sz="1900">
+                <a:solidFill>
+                  <a:srgbClr val="222222"/>
+                </a:solidFill>
+              </a:rPr>
+              <a:t>All four outputs match what I expected. Out-zero is minus-40, out-one is zero,</a:t>
+            </a:r>
+          </a:p>
+          <a:p>
+            <a:pPr>
+              <a:spcBef>
+                <a:spcPts val="500"/>
+              </a:spcBef>
+            </a:pPr>
+            <a:r>
+              <a:rPr sz="1900">
+                <a:solidFill>
+                  <a:srgbClr val="222222"/>
+                </a:solidFill>
+              </a:rPr>
+              <a:t>out-two and out-three are both minus-20, exactly what my hand calculation said.</a:t>
+            </a:r>
+          </a:p>
+          <a:p>
+            <a:pPr>
+              <a:spcBef>
+                <a:spcPts val="500"/>
+              </a:spcBef>
+            </a:pPr>
+            <a:r>
+              <a:rPr sz="1900">
+                <a:solidFill>
+                  <a:srgbClr val="222222"/>
+                </a:solidFill>
+              </a:rPr>
+              <a:t>So 4 out of 4, that's pretty good. Thanks.</a:t>
+            </a:r>
+          </a:p>
+        </p:txBody>
+      </p:sp>
       <p:pic>
         <p:nvPicPr>
-          <p:cNvPr id="6" name="Picture 5" descr="timing.png"/>
+          <p:cNvPr id="7" name="Picture 6" descr="results.png"/>
           <p:cNvPicPr>
             <a:picLocks noChangeAspect="1"/>
           </p:cNvPicPr>
@@ -7338,400 +5230,38 @@
         </p:blipFill>
         <p:spPr>
           <a:xfrm>
-            <a:off x="274320" y="1188720"/>
-            <a:ext cx="7772400" cy="3647864"/>
+            <a:off x="274320" y="3474720"/>
+            <a:ext cx="6858000" cy="3314153"/>
           </a:xfrm>
           <a:prstGeom prst="rect">
             <a:avLst/>
           </a:prstGeom>
         </p:spPr>
       </p:pic>
-      <p:sp>
-        <p:nvSpPr>
-          <p:cNvPr id="7" name="TextBox 6"/>
-          <p:cNvSpPr txBox="1"/>
-          <p:nvPr/>
-        </p:nvSpPr>
-        <p:spPr>
-          <a:xfrm>
-            <a:off x="8229600" y="1371600"/>
-            <a:ext cx="3657600" cy="5029200"/>
-          </a:xfrm>
-          <a:prstGeom prst="rect">
-            <a:avLst/>
-          </a:prstGeom>
-          <a:noFill/>
-        </p:spPr>
-        <p:txBody>
-          <a:bodyPr wrap="square">
-            <a:spAutoFit/>
-          </a:bodyPr>
-          <a:lstStyle/>
-          <a:p>
-            <a:pPr>
-              <a:spcBef>
-                <a:spcPts val="400"/>
-              </a:spcBef>
-            </a:pPr>
-            <a:r>
-              <a:rPr sz="1500">
-                <a:solidFill>
-                  <a:srgbClr val="444444"/>
-                </a:solidFill>
-              </a:rPr>
-              <a:t>• Output shows up 2 cycles after weight_load, not 1</a:t>
-            </a:r>
-          </a:p>
-          <a:p>
-            <a:pPr>
-              <a:spcBef>
-                <a:spcPts val="400"/>
-              </a:spcBef>
-            </a:pPr>
-            <a:r>
-              <a:rPr sz="1500">
-                <a:solidFill>
-                  <a:srgbClr val="444444"/>
-                </a:solidFill>
-              </a:rPr>
-              <a:t>• Why:</a:t>
-            </a:r>
-          </a:p>
-          <a:p>
-            <a:pPr lvl="1">
-              <a:spcBef>
-                <a:spcPts val="400"/>
-              </a:spcBef>
-            </a:pPr>
-            <a:r>
-              <a:rPr sz="1500">
-                <a:solidFill>
-                  <a:srgbClr val="444444"/>
-                </a:solidFill>
-              </a:rPr>
-              <a:t>  – Cycle 1 rising edge → weight register latches new weights</a:t>
-            </a:r>
-          </a:p>
-          <a:p>
-            <a:pPr lvl="1">
-              <a:spcBef>
-                <a:spcPts val="400"/>
-              </a:spcBef>
-            </a:pPr>
-            <a:r>
-              <a:rPr sz="1500">
-                <a:solidFill>
-                  <a:srgbClr val="444444"/>
-                </a:solidFill>
-              </a:rPr>
-              <a:t>  – BUT output register clocks on same edge with old weights</a:t>
-            </a:r>
-          </a:p>
-          <a:p>
-            <a:pPr lvl="1">
-              <a:spcBef>
-                <a:spcPts val="400"/>
-              </a:spcBef>
-            </a:pPr>
-            <a:r>
-              <a:rPr sz="1500">
-                <a:solidFill>
-                  <a:srgbClr val="444444"/>
-                </a:solidFill>
-              </a:rPr>
-              <a:t>  – Cycle 2 rising edge → output register latches correct result</a:t>
-            </a:r>
-          </a:p>
-          <a:p>
-            <a:pPr>
-              <a:spcBef>
-                <a:spcPts val="400"/>
-              </a:spcBef>
-            </a:pPr>
-            <a:r>
-              <a:rPr sz="1500">
-                <a:solidFill>
-                  <a:srgbClr val="444444"/>
-                </a:solidFill>
-              </a:rPr>
-              <a:t>• Testbench waits 2 cycles before reading outputs</a:t>
-            </a:r>
-          </a:p>
-        </p:txBody>
-      </p:sp>
-    </p:spTree>
-  </p:cSld>
-  <p:clrMapOvr>
-    <a:masterClrMapping/>
-  </p:clrMapOvr>
-</p:sld>
-</file>
-
-<file path=ppt/slides/slide8.xml><?xml version="1.0" encoding="utf-8"?>
-<p:sld xmlns:a="http://schemas.openxmlformats.org/drawingml/2006/main" xmlns:p="http://schemas.openxmlformats.org/presentationml/2006/main" xmlns:r="http://schemas.openxmlformats.org/officeDocument/2006/relationships">
-  <p:cSld>
-    <p:spTree>
-      <p:nvGrpSpPr>
-        <p:cNvPr id="1" name=""/>
-        <p:cNvGrpSpPr/>
-        <p:nvPr/>
-      </p:nvGrpSpPr>
-      <p:grpSpPr/>
-      <p:sp>
-        <p:nvSpPr>
-          <p:cNvPr id="2" name="Rectangle 1"/>
-          <p:cNvSpPr/>
-          <p:nvPr/>
-        </p:nvSpPr>
-        <p:spPr>
-          <a:xfrm>
-            <a:off x="0" y="0"/>
-            <a:ext cx="12188952" cy="6858000"/>
-          </a:xfrm>
-          <a:prstGeom prst="rect">
-            <a:avLst/>
-          </a:prstGeom>
-          <a:solidFill>
-            <a:srgbClr val="F2F2F2"/>
-          </a:solidFill>
-          <a:ln>
-            <a:noFill/>
-          </a:ln>
-        </p:spPr>
-        <p:style>
-          <a:lnRef idx="1">
-            <a:schemeClr val="accent1"/>
-          </a:lnRef>
-          <a:fillRef idx="3">
-            <a:schemeClr val="accent1"/>
-          </a:fillRef>
-          <a:effectRef idx="2">
-            <a:schemeClr val="accent1"/>
-          </a:effectRef>
-          <a:fontRef idx="minor">
-            <a:schemeClr val="lt1"/>
-          </a:fontRef>
-        </p:style>
-        <p:txBody>
-          <a:bodyPr rtlCol="0" anchor="ctr"/>
-          <a:lstStyle/>
-          <a:p>
-            <a:pPr algn="ctr"/>
-          </a:p>
-        </p:txBody>
-      </p:sp>
-      <p:sp>
-        <p:nvSpPr>
-          <p:cNvPr id="3" name="Rectangle 2"/>
-          <p:cNvSpPr/>
-          <p:nvPr/>
-        </p:nvSpPr>
-        <p:spPr>
-          <a:xfrm>
-            <a:off x="0" y="0"/>
-            <a:ext cx="12188952" cy="1005840"/>
-          </a:xfrm>
-          <a:prstGeom prst="rect">
-            <a:avLst/>
-          </a:prstGeom>
-          <a:solidFill>
-            <a:srgbClr val="1F4E79"/>
-          </a:solidFill>
-          <a:ln>
-            <a:noFill/>
-          </a:ln>
-        </p:spPr>
-        <p:style>
-          <a:lnRef idx="1">
-            <a:schemeClr val="accent1"/>
-          </a:lnRef>
-          <a:fillRef idx="3">
-            <a:schemeClr val="accent1"/>
-          </a:fillRef>
-          <a:effectRef idx="2">
-            <a:schemeClr val="accent1"/>
-          </a:effectRef>
-          <a:fontRef idx="minor">
-            <a:schemeClr val="lt1"/>
-          </a:fontRef>
-        </p:style>
-        <p:txBody>
-          <a:bodyPr rtlCol="0" anchor="ctr"/>
-          <a:lstStyle/>
-          <a:p>
-            <a:pPr algn="ctr"/>
-          </a:p>
-        </p:txBody>
-      </p:sp>
-      <p:sp>
-        <p:nvSpPr>
-          <p:cNvPr id="4" name="TextBox 3"/>
-          <p:cNvSpPr txBox="1"/>
-          <p:nvPr/>
-        </p:nvSpPr>
-        <p:spPr>
-          <a:xfrm>
-            <a:off x="274320" y="91440"/>
-            <a:ext cx="11612880" cy="822960"/>
-          </a:xfrm>
-          <a:prstGeom prst="rect">
-            <a:avLst/>
-          </a:prstGeom>
-          <a:noFill/>
-        </p:spPr>
-        <p:txBody>
-          <a:bodyPr wrap="square">
-            <a:spAutoFit/>
-          </a:bodyPr>
-          <a:lstStyle/>
-          <a:p>
-            <a:pPr algn="l"/>
-            <a:r>
-              <a:rPr sz="3200" b="1">
-                <a:solidFill>
-                  <a:srgbClr val="FFFFFF"/>
-                </a:solidFill>
-              </a:rPr>
-              <a:t>Simulation Results</a:t>
-            </a:r>
-          </a:p>
-        </p:txBody>
-      </p:sp>
-      <p:sp>
-        <p:nvSpPr>
-          <p:cNvPr id="5" name="Rectangle 4"/>
-          <p:cNvSpPr/>
-          <p:nvPr/>
-        </p:nvSpPr>
-        <p:spPr>
-          <a:xfrm>
-            <a:off x="0" y="1005840"/>
-            <a:ext cx="12188952" cy="54864"/>
-          </a:xfrm>
-          <a:prstGeom prst="rect">
-            <a:avLst/>
-          </a:prstGeom>
-          <a:solidFill>
-            <a:srgbClr val="1A7A4A"/>
-          </a:solidFill>
-          <a:ln>
-            <a:noFill/>
-          </a:ln>
-        </p:spPr>
-        <p:style>
-          <a:lnRef idx="1">
-            <a:schemeClr val="accent1"/>
-          </a:lnRef>
-          <a:fillRef idx="3">
-            <a:schemeClr val="accent1"/>
-          </a:fillRef>
-          <a:effectRef idx="2">
-            <a:schemeClr val="accent1"/>
-          </a:effectRef>
-          <a:fontRef idx="minor">
-            <a:schemeClr val="lt1"/>
-          </a:fontRef>
-        </p:style>
-        <p:txBody>
-          <a:bodyPr rtlCol="0" anchor="ctr"/>
-          <a:lstStyle/>
-          <a:p>
-            <a:pPr algn="ctr"/>
-          </a:p>
-        </p:txBody>
-      </p:sp>
       <p:pic>
         <p:nvPicPr>
-          <p:cNvPr id="6" name="Picture 5" descr="results.png"/>
+          <p:cNvPr id="8" name="Picture 7" descr="crossbar.png"/>
           <p:cNvPicPr>
             <a:picLocks noChangeAspect="1"/>
           </p:cNvPicPr>
           <p:nvPr/>
         </p:nvPicPr>
         <p:blipFill>
-          <a:blip r:embed="rId2"/>
+          <a:blip r:embed="rId3"/>
           <a:stretch>
             <a:fillRect/>
           </a:stretch>
         </p:blipFill>
         <p:spPr>
           <a:xfrm>
-            <a:off x="914400" y="1280160"/>
-            <a:ext cx="6400800" cy="3093210"/>
+            <a:off x="7223760" y="685800"/>
+            <a:ext cx="5583438" cy="5486400"/>
           </a:xfrm>
           <a:prstGeom prst="rect">
             <a:avLst/>
           </a:prstGeom>
         </p:spPr>
       </p:pic>
-      <p:sp>
-        <p:nvSpPr>
-          <p:cNvPr id="7" name="TextBox 6"/>
-          <p:cNvSpPr txBox="1"/>
-          <p:nvPr/>
-        </p:nvSpPr>
-        <p:spPr>
-          <a:xfrm>
-            <a:off x="7772400" y="1828800"/>
-            <a:ext cx="4114800" cy="2743200"/>
-          </a:xfrm>
-          <a:prstGeom prst="rect">
-            <a:avLst/>
-          </a:prstGeom>
-          <a:noFill/>
-        </p:spPr>
-        <p:txBody>
-          <a:bodyPr wrap="square">
-            <a:spAutoFit/>
-          </a:bodyPr>
-          <a:lstStyle/>
-          <a:p>
-            <a:pPr>
-              <a:spcBef>
-                <a:spcPts val="400"/>
-              </a:spcBef>
-            </a:pPr>
-            <a:r>
-              <a:rPr sz="1800">
-                <a:solidFill>
-                  <a:srgbClr val="1F4E79"/>
-                </a:solidFill>
-              </a:rPr>
-              <a:t>• All four outputs match what I expected</a:t>
-            </a:r>
-          </a:p>
-          <a:p>
-            <a:pPr>
-              <a:spcBef>
-                <a:spcPts val="400"/>
-              </a:spcBef>
-            </a:pPr>
-            <a:r>
-              <a:rPr sz="1800">
-                <a:solidFill>
-                  <a:srgbClr val="1F4E79"/>
-                </a:solidFill>
-              </a:rPr>
-              <a:t>• Exactly what the hand calculation said</a:t>
-            </a:r>
-          </a:p>
-          <a:p>
-            <a:pPr>
-              <a:spcBef>
-                <a:spcPts val="400"/>
-              </a:spcBef>
-            </a:pPr>
-            <a:r>
-              <a:rPr sz="1800">
-                <a:solidFill>
-                  <a:srgbClr val="1F4E79"/>
-                </a:solidFill>
-              </a:rPr>
-              <a:t>• 4 out of 4 — pretty good</a:t>
-            </a:r>
-          </a:p>
-        </p:txBody>
-      </p:sp>
     </p:spTree>
   </p:cSld>
   <p:clrMapOvr>

</xml_diff>

<commit_message>
CF06: rebuild slides as plain teleprompter — full text, no images
Co-Authored-By: Claude Sonnet 4.6 <noreply@anthropic.com>
</commit_message>
<xml_diff>
--- a/codefest/cf06/presentation/cf06_cllm_slides.pptx
+++ b/codefest/cf06/presentation/cf06_cllm_slides.pptx
@@ -3139,57 +3139,14 @@
       </p:sp>
       <p:sp>
         <p:nvSpPr>
-          <p:cNvPr id="3" name="Rectangle 2"/>
-          <p:cNvSpPr/>
+          <p:cNvPr id="3" name="TextBox 2"/>
+          <p:cNvSpPr txBox="1"/>
           <p:nvPr/>
         </p:nvSpPr>
         <p:spPr>
           <a:xfrm>
-            <a:off x="0" y="2834640"/>
-            <a:ext cx="12188952" cy="73152"/>
-          </a:xfrm>
-          <a:prstGeom prst="rect">
-            <a:avLst/>
-          </a:prstGeom>
-          <a:solidFill>
-            <a:srgbClr val="1A7A4A"/>
-          </a:solidFill>
-          <a:ln>
-            <a:noFill/>
-          </a:ln>
-        </p:spPr>
-        <p:style>
-          <a:lnRef idx="1">
-            <a:schemeClr val="accent1"/>
-          </a:lnRef>
-          <a:fillRef idx="3">
-            <a:schemeClr val="accent1"/>
-          </a:fillRef>
-          <a:effectRef idx="2">
-            <a:schemeClr val="accent1"/>
-          </a:effectRef>
-          <a:fontRef idx="minor">
-            <a:schemeClr val="lt1"/>
-          </a:fontRef>
-        </p:style>
-        <p:txBody>
-          <a:bodyPr rtlCol="0" anchor="ctr"/>
-          <a:lstStyle/>
-          <a:p>
-            <a:pPr algn="ctr"/>
-          </a:p>
-        </p:txBody>
-      </p:sp>
-      <p:sp>
-        <p:nvSpPr>
-          <p:cNvPr id="4" name="TextBox 3"/>
-          <p:cNvSpPr txBox="1"/>
-          <p:nvPr/>
-        </p:nvSpPr>
-        <p:spPr>
-          <a:xfrm>
-            <a:off x="457200" y="1005840"/>
-            <a:ext cx="11247120" cy="1463040"/>
+            <a:off x="457200" y="1828800"/>
+            <a:ext cx="11247120" cy="1645920"/>
           </a:xfrm>
           <a:prstGeom prst="rect">
             <a:avLst/>
@@ -3204,7 +3161,7 @@
           <a:p>
             <a:pPr algn="ctr"/>
             <a:r>
-              <a:rPr sz="5600" b="1">
+              <a:rPr sz="6000" b="1">
                 <a:solidFill>
                   <a:srgbClr val="FFFFFF"/>
                 </a:solidFill>
@@ -3216,14 +3173,14 @@
       </p:sp>
       <p:sp>
         <p:nvSpPr>
-          <p:cNvPr id="5" name="TextBox 4"/>
+          <p:cNvPr id="4" name="TextBox 3"/>
           <p:cNvSpPr txBox="1"/>
           <p:nvPr/>
         </p:nvSpPr>
         <p:spPr>
           <a:xfrm>
-            <a:off x="457200" y="2606040"/>
-            <a:ext cx="11247120" cy="640080"/>
+            <a:off x="457200" y="3566160"/>
+            <a:ext cx="11247120" cy="731520"/>
           </a:xfrm>
           <a:prstGeom prst="rect">
             <a:avLst/>
@@ -3238,46 +3195,12 @@
           <a:p>
             <a:pPr algn="ctr"/>
             <a:r>
-              <a:rPr sz="2600">
+              <a:rPr sz="2400">
                 <a:solidFill>
                   <a:srgbClr val="BFD7ED"/>
                 </a:solidFill>
               </a:rPr>
-              <a:t>4×4 Binary-Weight Crossbar MAC</a:t>
-            </a:r>
-          </a:p>
-        </p:txBody>
-      </p:sp>
-      <p:sp>
-        <p:nvSpPr>
-          <p:cNvPr id="6" name="TextBox 5"/>
-          <p:cNvSpPr txBox="1"/>
-          <p:nvPr/>
-        </p:nvSpPr>
-        <p:spPr>
-          <a:xfrm>
-            <a:off x="457200" y="5943600"/>
-            <a:ext cx="11247120" cy="548640"/>
-          </a:xfrm>
-          <a:prstGeom prst="rect">
-            <a:avLst/>
-          </a:prstGeom>
-          <a:noFill/>
-        </p:spPr>
-        <p:txBody>
-          <a:bodyPr wrap="none">
-            <a:spAutoFit/>
-          </a:bodyPr>
-          <a:lstStyle/>
-          <a:p>
-            <a:pPr algn="ctr"/>
-            <a:r>
-              <a:rPr sz="1500">
-                <a:solidFill>
-                  <a:srgbClr val="9DC3E6"/>
-                </a:solidFill>
-              </a:rPr>
-              <a:t>Generated by Claude Sonnet 4.6  ·  ECE 410/510 Spring 2026  ·  Bao Nguyen</a:t>
+              <a:t>4×4 Binary-Weight Crossbar MAC  ·  Claude Sonnet 4.6</a:t>
             </a:r>
           </a:p>
         </p:txBody>
@@ -3302,143 +3225,14 @@
       <p:grpSpPr/>
       <p:sp>
         <p:nvSpPr>
-          <p:cNvPr id="2" name="Rectangle 1"/>
-          <p:cNvSpPr/>
+          <p:cNvPr id="2" name="TextBox 1"/>
+          <p:cNvSpPr txBox="1"/>
           <p:nvPr/>
         </p:nvSpPr>
         <p:spPr>
           <a:xfrm>
-            <a:off x="0" y="0"/>
-            <a:ext cx="12188952" cy="6858000"/>
-          </a:xfrm>
-          <a:prstGeom prst="rect">
-            <a:avLst/>
-          </a:prstGeom>
-          <a:solidFill>
-            <a:srgbClr val="F4F4F4"/>
-          </a:solidFill>
-          <a:ln>
-            <a:noFill/>
-          </a:ln>
-        </p:spPr>
-        <p:style>
-          <a:lnRef idx="1">
-            <a:schemeClr val="accent1"/>
-          </a:lnRef>
-          <a:fillRef idx="3">
-            <a:schemeClr val="accent1"/>
-          </a:fillRef>
-          <a:effectRef idx="2">
-            <a:schemeClr val="accent1"/>
-          </a:effectRef>
-          <a:fontRef idx="minor">
-            <a:schemeClr val="lt1"/>
-          </a:fontRef>
-        </p:style>
-        <p:txBody>
-          <a:bodyPr rtlCol="0" anchor="ctr"/>
-          <a:lstStyle/>
-          <a:p>
-            <a:pPr algn="ctr"/>
-          </a:p>
-        </p:txBody>
-      </p:sp>
-      <p:sp>
-        <p:nvSpPr>
-          <p:cNvPr id="3" name="Rectangle 2"/>
-          <p:cNvSpPr/>
-          <p:nvPr/>
-        </p:nvSpPr>
-        <p:spPr>
-          <a:xfrm>
-            <a:off x="0" y="0"/>
-            <a:ext cx="12188952" cy="502920"/>
-          </a:xfrm>
-          <a:prstGeom prst="rect">
-            <a:avLst/>
-          </a:prstGeom>
-          <a:solidFill>
-            <a:srgbClr val="1F4E79"/>
-          </a:solidFill>
-          <a:ln>
-            <a:noFill/>
-          </a:ln>
-        </p:spPr>
-        <p:style>
-          <a:lnRef idx="1">
-            <a:schemeClr val="accent1"/>
-          </a:lnRef>
-          <a:fillRef idx="3">
-            <a:schemeClr val="accent1"/>
-          </a:fillRef>
-          <a:effectRef idx="2">
-            <a:schemeClr val="accent1"/>
-          </a:effectRef>
-          <a:fontRef idx="minor">
-            <a:schemeClr val="lt1"/>
-          </a:fontRef>
-        </p:style>
-        <p:txBody>
-          <a:bodyPr rtlCol="0" anchor="ctr"/>
-          <a:lstStyle/>
-          <a:p>
-            <a:pPr algn="ctr"/>
-          </a:p>
-        </p:txBody>
-      </p:sp>
-      <p:sp>
-        <p:nvSpPr>
-          <p:cNvPr id="4" name="Rectangle 3"/>
-          <p:cNvSpPr/>
-          <p:nvPr/>
-        </p:nvSpPr>
-        <p:spPr>
-          <a:xfrm>
-            <a:off x="0" y="502920"/>
-            <a:ext cx="12188952" cy="54864"/>
-          </a:xfrm>
-          <a:prstGeom prst="rect">
-            <a:avLst/>
-          </a:prstGeom>
-          <a:solidFill>
-            <a:srgbClr val="1A7A4A"/>
-          </a:solidFill>
-          <a:ln>
-            <a:noFill/>
-          </a:ln>
-        </p:spPr>
-        <p:style>
-          <a:lnRef idx="1">
-            <a:schemeClr val="accent1"/>
-          </a:lnRef>
-          <a:fillRef idx="3">
-            <a:schemeClr val="accent1"/>
-          </a:fillRef>
-          <a:effectRef idx="2">
-            <a:schemeClr val="accent1"/>
-          </a:effectRef>
-          <a:fontRef idx="minor">
-            <a:schemeClr val="lt1"/>
-          </a:fontRef>
-        </p:style>
-        <p:txBody>
-          <a:bodyPr rtlCol="0" anchor="ctr"/>
-          <a:lstStyle/>
-          <a:p>
-            <a:pPr algn="ctr"/>
-          </a:p>
-        </p:txBody>
-      </p:sp>
-      <p:sp>
-        <p:nvSpPr>
-          <p:cNvPr id="5" name="TextBox 4"/>
-          <p:cNvSpPr txBox="1"/>
-          <p:nvPr/>
-        </p:nvSpPr>
-        <p:spPr>
-          <a:xfrm>
-            <a:off x="228600" y="54864"/>
-            <a:ext cx="11887200" cy="438912"/>
+            <a:off x="274320" y="91440"/>
+            <a:ext cx="10972800" cy="411480"/>
           </a:xfrm>
           <a:prstGeom prst="rect">
             <a:avLst/>
@@ -3451,11 +3245,10 @@
           </a:bodyPr>
           <a:lstStyle/>
           <a:p>
-            <a:pPr algn="l"/>
-            <a:r>
-              <a:rPr sz="2200" b="1">
-                <a:solidFill>
-                  <a:srgbClr val="FFFFFF"/>
+            <a:r>
+              <a:rPr sz="1600" b="1">
+                <a:solidFill>
+                  <a:srgbClr val="1A7A4A"/>
                 </a:solidFill>
               </a:rPr>
               <a:t>The Design</a:t>
@@ -3465,14 +3258,14 @@
       </p:sp>
       <p:sp>
         <p:nvSpPr>
-          <p:cNvPr id="6" name="TextBox 5"/>
+          <p:cNvPr id="3" name="TextBox 2"/>
           <p:cNvSpPr txBox="1"/>
           <p:nvPr/>
         </p:nvSpPr>
         <p:spPr>
           <a:xfrm>
-            <a:off x="274320" y="685800"/>
-            <a:ext cx="6858000" cy="5943600"/>
+            <a:off x="365760" y="594360"/>
+            <a:ext cx="11430000" cy="6126480"/>
           </a:xfrm>
           <a:prstGeom prst="rect">
             <a:avLst/>
@@ -3487,13 +3280,13 @@
           <a:p>
             <a:pPr>
               <a:spcBef>
-                <a:spcPts val="500"/>
+                <a:spcPts val="0"/>
               </a:spcBef>
             </a:pPr>
             <a:r>
-              <a:rPr sz="1900">
-                <a:solidFill>
-                  <a:srgbClr val="222222"/>
+              <a:rPr sz="2600">
+                <a:solidFill>
+                  <a:srgbClr val="111111"/>
                 </a:solidFill>
               </a:rPr>
               <a:t>For CF06 CLLM I had Claude Sonnet 4.6 generate a 4-by-4 binary-weight crossbar MAC unit in SystemVerilog.</a:t>
@@ -3502,13 +3295,13 @@
           <a:p>
             <a:pPr>
               <a:spcBef>
-                <a:spcPts val="500"/>
+                <a:spcPts val="1000"/>
               </a:spcBef>
             </a:pPr>
             <a:r>
-              <a:rPr sz="1900">
-                <a:solidFill>
-                  <a:srgbClr val="222222"/>
+              <a:rPr sz="2600">
+                <a:solidFill>
+                  <a:srgbClr val="111111"/>
                 </a:solidFill>
               </a:rPr>
               <a:t/>
@@ -3517,104 +3310,80 @@
           <a:p>
             <a:pPr>
               <a:spcBef>
-                <a:spcPts val="500"/>
+                <a:spcPts val="0"/>
               </a:spcBef>
             </a:pPr>
             <a:r>
-              <a:rPr sz="1900">
-                <a:solidFill>
-                  <a:srgbClr val="222222"/>
+              <a:rPr sz="2600">
+                <a:solidFill>
+                  <a:srgbClr val="111111"/>
                 </a:solidFill>
               </a:rPr>
-              <a:t>So about the design. The module takes four 8-bit signed inputs, a 4-by-4 weight matrix</a:t>
+              <a:t>So about the design. The module takes four 8-bit signed inputs, a 4-by-4 weight matrix where each weight is either plus-one or minus-one, and produces four 10-bit signed outputs.</a:t>
             </a:r>
           </a:p>
           <a:p>
             <a:pPr>
               <a:spcBef>
-                <a:spcPts val="500"/>
+                <a:spcPts val="1000"/>
               </a:spcBef>
             </a:pPr>
             <a:r>
-              <a:rPr sz="1900">
-                <a:solidFill>
-                  <a:srgbClr val="222222"/>
+              <a:rPr sz="2600">
+                <a:solidFill>
+                  <a:srgbClr val="111111"/>
                 </a:solidFill>
               </a:rPr>
-              <a:t>where each weight is either plus-one or minus-one, and produces four 10-bit signed outputs.</a:t>
+              <a:t/>
             </a:r>
           </a:p>
           <a:p>
             <a:pPr>
               <a:spcBef>
-                <a:spcPts val="500"/>
+                <a:spcPts val="0"/>
               </a:spcBef>
             </a:pPr>
             <a:r>
-              <a:rPr sz="1900">
-                <a:solidFill>
-                  <a:srgbClr val="222222"/>
+              <a:rPr sz="2600">
+                <a:solidFill>
+                  <a:srgbClr val="111111"/>
                 </a:solidFill>
               </a:rPr>
-              <a:t>Each clock cycle, every output computes a dot product, so basically you multiply each input</a:t>
+              <a:t>Each clock cycle, every output computes a dot product, so basically you multiply each input by its weight at that row-column intersection and add them up.</a:t>
             </a:r>
           </a:p>
           <a:p>
             <a:pPr>
               <a:spcBef>
-                <a:spcPts val="500"/>
+                <a:spcPts val="1000"/>
               </a:spcBef>
             </a:pPr>
             <a:r>
-              <a:rPr sz="1900">
-                <a:solidFill>
-                  <a:srgbClr val="222222"/>
+              <a:rPr sz="2600">
+                <a:solidFill>
+                  <a:srgbClr val="111111"/>
                 </a:solidFill>
               </a:rPr>
-              <a:t>by its weight at that row-column intersection and add them up. That's what the crossbar does,</a:t>
+              <a:t/>
             </a:r>
           </a:p>
           <a:p>
             <a:pPr>
               <a:spcBef>
-                <a:spcPts val="500"/>
+                <a:spcPts val="0"/>
               </a:spcBef>
             </a:pPr>
             <a:r>
-              <a:rPr sz="1900">
-                <a:solidFill>
-                  <a:srgbClr val="222222"/>
+              <a:rPr sz="2600">
+                <a:solidFill>
+                  <a:srgbClr val="111111"/>
                 </a:solidFill>
               </a:rPr>
-              <a:t>a grid of wires where rows carry inputs, columns carry outputs, and the weights sit at the intersections.</a:t>
-            </a:r>
-          </a:p>
-        </p:txBody>
-      </p:sp>
-      <p:pic>
-        <p:nvPicPr>
-          <p:cNvPr id="7" name="Picture 6" descr="crossbar.png"/>
-          <p:cNvPicPr>
-            <a:picLocks noChangeAspect="1"/>
-          </p:cNvPicPr>
-          <p:nvPr/>
-        </p:nvPicPr>
-        <p:blipFill>
-          <a:blip r:embed="rId2"/>
-          <a:stretch>
-            <a:fillRect/>
-          </a:stretch>
-        </p:blipFill>
-        <p:spPr>
-          <a:xfrm>
-            <a:off x="7223760" y="731520"/>
-            <a:ext cx="5583438" cy="5486400"/>
-          </a:xfrm>
-          <a:prstGeom prst="rect">
-            <a:avLst/>
-          </a:prstGeom>
-        </p:spPr>
-      </p:pic>
+              <a:t>That's what the crossbar does, a grid of wires where rows carry inputs, columns carry outputs, and the weights sit at the intersections.</a:t>
+            </a:r>
+          </a:p>
+        </p:txBody>
+      </p:sp>
     </p:spTree>
   </p:cSld>
   <p:clrMapOvr>
@@ -3635,143 +3404,14 @@
       <p:grpSpPr/>
       <p:sp>
         <p:nvSpPr>
-          <p:cNvPr id="2" name="Rectangle 1"/>
-          <p:cNvSpPr/>
+          <p:cNvPr id="2" name="TextBox 1"/>
+          <p:cNvSpPr txBox="1"/>
           <p:nvPr/>
         </p:nvSpPr>
         <p:spPr>
           <a:xfrm>
-            <a:off x="0" y="0"/>
-            <a:ext cx="12188952" cy="6858000"/>
-          </a:xfrm>
-          <a:prstGeom prst="rect">
-            <a:avLst/>
-          </a:prstGeom>
-          <a:solidFill>
-            <a:srgbClr val="F4F4F4"/>
-          </a:solidFill>
-          <a:ln>
-            <a:noFill/>
-          </a:ln>
-        </p:spPr>
-        <p:style>
-          <a:lnRef idx="1">
-            <a:schemeClr val="accent1"/>
-          </a:lnRef>
-          <a:fillRef idx="3">
-            <a:schemeClr val="accent1"/>
-          </a:fillRef>
-          <a:effectRef idx="2">
-            <a:schemeClr val="accent1"/>
-          </a:effectRef>
-          <a:fontRef idx="minor">
-            <a:schemeClr val="lt1"/>
-          </a:fontRef>
-        </p:style>
-        <p:txBody>
-          <a:bodyPr rtlCol="0" anchor="ctr"/>
-          <a:lstStyle/>
-          <a:p>
-            <a:pPr algn="ctr"/>
-          </a:p>
-        </p:txBody>
-      </p:sp>
-      <p:sp>
-        <p:nvSpPr>
-          <p:cNvPr id="3" name="Rectangle 2"/>
-          <p:cNvSpPr/>
-          <p:nvPr/>
-        </p:nvSpPr>
-        <p:spPr>
-          <a:xfrm>
-            <a:off x="0" y="0"/>
-            <a:ext cx="12188952" cy="502920"/>
-          </a:xfrm>
-          <a:prstGeom prst="rect">
-            <a:avLst/>
-          </a:prstGeom>
-          <a:solidFill>
-            <a:srgbClr val="1F4E79"/>
-          </a:solidFill>
-          <a:ln>
-            <a:noFill/>
-          </a:ln>
-        </p:spPr>
-        <p:style>
-          <a:lnRef idx="1">
-            <a:schemeClr val="accent1"/>
-          </a:lnRef>
-          <a:fillRef idx="3">
-            <a:schemeClr val="accent1"/>
-          </a:fillRef>
-          <a:effectRef idx="2">
-            <a:schemeClr val="accent1"/>
-          </a:effectRef>
-          <a:fontRef idx="minor">
-            <a:schemeClr val="lt1"/>
-          </a:fontRef>
-        </p:style>
-        <p:txBody>
-          <a:bodyPr rtlCol="0" anchor="ctr"/>
-          <a:lstStyle/>
-          <a:p>
-            <a:pPr algn="ctr"/>
-          </a:p>
-        </p:txBody>
-      </p:sp>
-      <p:sp>
-        <p:nvSpPr>
-          <p:cNvPr id="4" name="Rectangle 3"/>
-          <p:cNvSpPr/>
-          <p:nvPr/>
-        </p:nvSpPr>
-        <p:spPr>
-          <a:xfrm>
-            <a:off x="0" y="502920"/>
-            <a:ext cx="12188952" cy="54864"/>
-          </a:xfrm>
-          <a:prstGeom prst="rect">
-            <a:avLst/>
-          </a:prstGeom>
-          <a:solidFill>
-            <a:srgbClr val="1A7A4A"/>
-          </a:solidFill>
-          <a:ln>
-            <a:noFill/>
-          </a:ln>
-        </p:spPr>
-        <p:style>
-          <a:lnRef idx="1">
-            <a:schemeClr val="accent1"/>
-          </a:lnRef>
-          <a:fillRef idx="3">
-            <a:schemeClr val="accent1"/>
-          </a:fillRef>
-          <a:effectRef idx="2">
-            <a:schemeClr val="accent1"/>
-          </a:effectRef>
-          <a:fontRef idx="minor">
-            <a:schemeClr val="lt1"/>
-          </a:fontRef>
-        </p:style>
-        <p:txBody>
-          <a:bodyPr rtlCol="0" anchor="ctr"/>
-          <a:lstStyle/>
-          <a:p>
-            <a:pPr algn="ctr"/>
-          </a:p>
-        </p:txBody>
-      </p:sp>
-      <p:sp>
-        <p:nvSpPr>
-          <p:cNvPr id="5" name="TextBox 4"/>
-          <p:cNvSpPr txBox="1"/>
-          <p:nvPr/>
-        </p:nvSpPr>
-        <p:spPr>
-          <a:xfrm>
-            <a:off x="228600" y="54864"/>
-            <a:ext cx="11887200" cy="438912"/>
+            <a:off x="274320" y="91440"/>
+            <a:ext cx="10972800" cy="411480"/>
           </a:xfrm>
           <a:prstGeom prst="rect">
             <a:avLst/>
@@ -3784,11 +3424,10 @@
           </a:bodyPr>
           <a:lstStyle/>
           <a:p>
-            <a:pPr algn="l"/>
-            <a:r>
-              <a:rPr sz="2200" b="1">
-                <a:solidFill>
-                  <a:srgbClr val="FFFFFF"/>
+            <a:r>
+              <a:rPr sz="1600" b="1">
+                <a:solidFill>
+                  <a:srgbClr val="1A7A4A"/>
                 </a:solidFill>
               </a:rPr>
               <a:t>The Design — 3 Stages</a:t>
@@ -3798,14 +3437,14 @@
       </p:sp>
       <p:sp>
         <p:nvSpPr>
-          <p:cNvPr id="6" name="TextBox 5"/>
+          <p:cNvPr id="3" name="TextBox 2"/>
           <p:cNvSpPr txBox="1"/>
           <p:nvPr/>
         </p:nvSpPr>
         <p:spPr>
           <a:xfrm>
-            <a:off x="274320" y="685800"/>
-            <a:ext cx="6858000" cy="4572000"/>
+            <a:off x="365760" y="594360"/>
+            <a:ext cx="11430000" cy="6126480"/>
           </a:xfrm>
           <a:prstGeom prst="rect">
             <a:avLst/>
@@ -3820,158 +3459,80 @@
           <a:p>
             <a:pPr>
               <a:spcBef>
-                <a:spcPts val="500"/>
+                <a:spcPts val="0"/>
               </a:spcBef>
             </a:pPr>
             <a:r>
-              <a:rPr sz="1900">
-                <a:solidFill>
-                  <a:srgbClr val="222222"/>
+              <a:rPr sz="2600">
+                <a:solidFill>
+                  <a:srgbClr val="111111"/>
                 </a:solidFill>
               </a:rPr>
-              <a:t>The module has three stages. First stage is the weight register, it's a flip-flop that latches</a:t>
+              <a:t>The module has three stages. First stage is the weight register, it's a flip-flop that latches the full weight matrix when you pulse weight_load high.</a:t>
             </a:r>
           </a:p>
           <a:p>
             <a:pPr>
               <a:spcBef>
-                <a:spcPts val="500"/>
+                <a:spcPts val="1000"/>
               </a:spcBef>
             </a:pPr>
             <a:r>
-              <a:rPr sz="1900">
-                <a:solidFill>
-                  <a:srgbClr val="222222"/>
+              <a:rPr sz="2600">
+                <a:solidFill>
+                  <a:srgbClr val="111111"/>
                 </a:solidFill>
               </a:rPr>
-              <a:t>the full weight matrix when you pulse weight_load high. Claude packed the entire 4-by-4 matrix</a:t>
+              <a:t/>
             </a:r>
           </a:p>
           <a:p>
             <a:pPr>
               <a:spcBef>
-                <a:spcPts val="500"/>
+                <a:spcPts val="0"/>
               </a:spcBef>
             </a:pPr>
             <a:r>
-              <a:rPr sz="1900">
-                <a:solidFill>
-                  <a:srgbClr val="222222"/>
+              <a:rPr sz="2600">
+                <a:solidFill>
+                  <a:srgbClr val="111111"/>
                 </a:solidFill>
               </a:rPr>
-              <a:t>into a single 16-bit flat register, where bit 4i plus j holds weight[i][j]. For an example,</a:t>
+              <a:t>Claude packed the entire 4-by-4 matrix into a single 16-bit flat register, where bit 4i plus j holds weight[i][j]. For an example, bit zero is weight[0][0], bit four would be weight[1][0], and so on.</a:t>
             </a:r>
           </a:p>
           <a:p>
             <a:pPr>
               <a:spcBef>
-                <a:spcPts val="500"/>
+                <a:spcPts val="1000"/>
               </a:spcBef>
             </a:pPr>
             <a:r>
-              <a:rPr sz="1900">
-                <a:solidFill>
-                  <a:srgbClr val="222222"/>
+              <a:rPr sz="2600">
+                <a:solidFill>
+                  <a:srgbClr val="111111"/>
                 </a:solidFill>
               </a:rPr>
-              <a:t>bit zero is weight[0][0], bit four would be weight[1][0], and so on. I asked Claude why it</a:t>
+              <a:t/>
             </a:r>
           </a:p>
           <a:p>
             <a:pPr>
               <a:spcBef>
-                <a:spcPts val="500"/>
+                <a:spcPts val="0"/>
               </a:spcBef>
             </a:pPr>
             <a:r>
-              <a:rPr sz="1900">
-                <a:solidFill>
-                  <a:srgbClr val="222222"/>
+              <a:rPr sz="2600">
+                <a:solidFill>
+                  <a:srgbClr val="111111"/>
                 </a:solidFill>
               </a:rPr>
-              <a:t>went with a flat register and it said it actually loads the entire matrix in exactly one clock</a:t>
-            </a:r>
-          </a:p>
-          <a:p>
-            <a:pPr>
-              <a:spcBef>
-                <a:spcPts val="500"/>
-              </a:spcBef>
-            </a:pPr>
-            <a:r>
-              <a:rPr sz="1900">
-                <a:solidFill>
-                  <a:srgbClr val="222222"/>
-                </a:solidFill>
-              </a:rPr>
-              <a:t>cycle. Like if you loaded row by row, that would've taken four cycles and you'd need an address</a:t>
-            </a:r>
-          </a:p>
-          <a:p>
-            <a:pPr>
-              <a:spcBef>
-                <a:spcPts val="500"/>
-              </a:spcBef>
-            </a:pPr>
-            <a:r>
-              <a:rPr sz="1900">
-                <a:solidFill>
-                  <a:srgbClr val="222222"/>
-                </a:solidFill>
-              </a:rPr>
-              <a:t>counter to track which row you're on, so the flat register just keeps it simple.</a:t>
-            </a:r>
-          </a:p>
-        </p:txBody>
-      </p:sp>
-      <p:pic>
-        <p:nvPicPr>
-          <p:cNvPr id="7" name="Picture 6" descr="pipeline.png"/>
-          <p:cNvPicPr>
-            <a:picLocks noChangeAspect="1"/>
-          </p:cNvPicPr>
-          <p:nvPr/>
-        </p:nvPicPr>
-        <p:blipFill>
-          <a:blip r:embed="rId2"/>
-          <a:stretch>
-            <a:fillRect/>
-          </a:stretch>
-        </p:blipFill>
-        <p:spPr>
-          <a:xfrm>
-            <a:off x="274320" y="5303520"/>
-            <a:ext cx="6858000" cy="2532453"/>
-          </a:xfrm>
-          <a:prstGeom prst="rect">
-            <a:avLst/>
-          </a:prstGeom>
-        </p:spPr>
-      </p:pic>
-      <p:pic>
-        <p:nvPicPr>
-          <p:cNvPr id="8" name="Picture 7" descr="encoding.png"/>
-          <p:cNvPicPr>
-            <a:picLocks noChangeAspect="1"/>
-          </p:cNvPicPr>
-          <p:nvPr/>
-        </p:nvPicPr>
-        <p:blipFill>
-          <a:blip r:embed="rId3"/>
-          <a:stretch>
-            <a:fillRect/>
-          </a:stretch>
-        </p:blipFill>
-        <p:spPr>
-          <a:xfrm>
-            <a:off x="7223760" y="685800"/>
-            <a:ext cx="4754880" cy="1621073"/>
-          </a:xfrm>
-          <a:prstGeom prst="rect">
-            <a:avLst/>
-          </a:prstGeom>
-        </p:spPr>
-      </p:pic>
+              <a:t>I asked Claude why it went with a flat register and it said it actually loads the entire matrix in exactly one clock cycle. Like if you loaded row by row, that would've taken four cycles and you'd need an address counter to track which row you're on, so the flat register just keeps it simple.</a:t>
+            </a:r>
+          </a:p>
+        </p:txBody>
+      </p:sp>
     </p:spTree>
   </p:cSld>
   <p:clrMapOvr>
@@ -3992,143 +3553,14 @@
       <p:grpSpPr/>
       <p:sp>
         <p:nvSpPr>
-          <p:cNvPr id="2" name="Rectangle 1"/>
-          <p:cNvSpPr/>
+          <p:cNvPr id="2" name="TextBox 1"/>
+          <p:cNvSpPr txBox="1"/>
           <p:nvPr/>
         </p:nvSpPr>
         <p:spPr>
           <a:xfrm>
-            <a:off x="0" y="0"/>
-            <a:ext cx="12188952" cy="6858000"/>
-          </a:xfrm>
-          <a:prstGeom prst="rect">
-            <a:avLst/>
-          </a:prstGeom>
-          <a:solidFill>
-            <a:srgbClr val="F4F4F4"/>
-          </a:solidFill>
-          <a:ln>
-            <a:noFill/>
-          </a:ln>
-        </p:spPr>
-        <p:style>
-          <a:lnRef idx="1">
-            <a:schemeClr val="accent1"/>
-          </a:lnRef>
-          <a:fillRef idx="3">
-            <a:schemeClr val="accent1"/>
-          </a:fillRef>
-          <a:effectRef idx="2">
-            <a:schemeClr val="accent1"/>
-          </a:effectRef>
-          <a:fontRef idx="minor">
-            <a:schemeClr val="lt1"/>
-          </a:fontRef>
-        </p:style>
-        <p:txBody>
-          <a:bodyPr rtlCol="0" anchor="ctr"/>
-          <a:lstStyle/>
-          <a:p>
-            <a:pPr algn="ctr"/>
-          </a:p>
-        </p:txBody>
-      </p:sp>
-      <p:sp>
-        <p:nvSpPr>
-          <p:cNvPr id="3" name="Rectangle 2"/>
-          <p:cNvSpPr/>
-          <p:nvPr/>
-        </p:nvSpPr>
-        <p:spPr>
-          <a:xfrm>
-            <a:off x="0" y="0"/>
-            <a:ext cx="12188952" cy="502920"/>
-          </a:xfrm>
-          <a:prstGeom prst="rect">
-            <a:avLst/>
-          </a:prstGeom>
-          <a:solidFill>
-            <a:srgbClr val="1F4E79"/>
-          </a:solidFill>
-          <a:ln>
-            <a:noFill/>
-          </a:ln>
-        </p:spPr>
-        <p:style>
-          <a:lnRef idx="1">
-            <a:schemeClr val="accent1"/>
-          </a:lnRef>
-          <a:fillRef idx="3">
-            <a:schemeClr val="accent1"/>
-          </a:fillRef>
-          <a:effectRef idx="2">
-            <a:schemeClr val="accent1"/>
-          </a:effectRef>
-          <a:fontRef idx="minor">
-            <a:schemeClr val="lt1"/>
-          </a:fontRef>
-        </p:style>
-        <p:txBody>
-          <a:bodyPr rtlCol="0" anchor="ctr"/>
-          <a:lstStyle/>
-          <a:p>
-            <a:pPr algn="ctr"/>
-          </a:p>
-        </p:txBody>
-      </p:sp>
-      <p:sp>
-        <p:nvSpPr>
-          <p:cNvPr id="4" name="Rectangle 3"/>
-          <p:cNvSpPr/>
-          <p:nvPr/>
-        </p:nvSpPr>
-        <p:spPr>
-          <a:xfrm>
-            <a:off x="0" y="502920"/>
-            <a:ext cx="12188952" cy="54864"/>
-          </a:xfrm>
-          <a:prstGeom prst="rect">
-            <a:avLst/>
-          </a:prstGeom>
-          <a:solidFill>
-            <a:srgbClr val="1A7A4A"/>
-          </a:solidFill>
-          <a:ln>
-            <a:noFill/>
-          </a:ln>
-        </p:spPr>
-        <p:style>
-          <a:lnRef idx="1">
-            <a:schemeClr val="accent1"/>
-          </a:lnRef>
-          <a:fillRef idx="3">
-            <a:schemeClr val="accent1"/>
-          </a:fillRef>
-          <a:effectRef idx="2">
-            <a:schemeClr val="accent1"/>
-          </a:effectRef>
-          <a:fontRef idx="minor">
-            <a:schemeClr val="lt1"/>
-          </a:fontRef>
-        </p:style>
-        <p:txBody>
-          <a:bodyPr rtlCol="0" anchor="ctr"/>
-          <a:lstStyle/>
-          <a:p>
-            <a:pPr algn="ctr"/>
-          </a:p>
-        </p:txBody>
-      </p:sp>
-      <p:sp>
-        <p:nvSpPr>
-          <p:cNvPr id="5" name="TextBox 4"/>
-          <p:cNvSpPr txBox="1"/>
-          <p:nvPr/>
-        </p:nvSpPr>
-        <p:spPr>
-          <a:xfrm>
-            <a:off x="228600" y="54864"/>
-            <a:ext cx="11887200" cy="438912"/>
+            <a:off x="274320" y="91440"/>
+            <a:ext cx="10972800" cy="411480"/>
           </a:xfrm>
           <a:prstGeom prst="rect">
             <a:avLst/>
@@ -4141,28 +3573,27 @@
           </a:bodyPr>
           <a:lstStyle/>
           <a:p>
-            <a:pPr algn="l"/>
-            <a:r>
-              <a:rPr sz="2200" b="1">
-                <a:solidFill>
-                  <a:srgbClr val="FFFFFF"/>
+            <a:r>
+              <a:rPr sz="1600" b="1">
+                <a:solidFill>
+                  <a:srgbClr val="1A7A4A"/>
                 </a:solidFill>
               </a:rPr>
-              <a:t>The Design — MAC &amp; Output Bit Width</a:t>
-            </a:r>
-          </a:p>
-        </p:txBody>
-      </p:sp>
-      <p:sp>
-        <p:nvSpPr>
-          <p:cNvPr id="6" name="TextBox 5"/>
+              <a:t>The Design — MAC &amp; Bit Width</a:t>
+            </a:r>
+          </a:p>
+        </p:txBody>
+      </p:sp>
+      <p:sp>
+        <p:nvSpPr>
+          <p:cNvPr id="3" name="TextBox 2"/>
           <p:cNvSpPr txBox="1"/>
           <p:nvPr/>
         </p:nvSpPr>
         <p:spPr>
           <a:xfrm>
-            <a:off x="274320" y="685800"/>
-            <a:ext cx="6858000" cy="5029200"/>
+            <a:off x="365760" y="594360"/>
+            <a:ext cx="11430000" cy="6126480"/>
           </a:xfrm>
           <a:prstGeom prst="rect">
             <a:avLst/>
@@ -4177,58 +3608,58 @@
           <a:p>
             <a:pPr>
               <a:spcBef>
-                <a:spcPts val="500"/>
+                <a:spcPts val="0"/>
               </a:spcBef>
             </a:pPr>
             <a:r>
-              <a:rPr sz="1900">
-                <a:solidFill>
-                  <a:srgbClr val="222222"/>
+              <a:rPr sz="2600">
+                <a:solidFill>
+                  <a:srgbClr val="111111"/>
                 </a:solidFill>
               </a:rPr>
-              <a:t>The second stage is the combinational MAC, those are just wires, no clock, which sign-extends</a:t>
+              <a:t>The second stage is the combinational MAC, those are just wires, no clock, which sign-extends the inputs to 10 bits and computes all four dot products at the same time.</a:t>
             </a:r>
           </a:p>
           <a:p>
             <a:pPr>
               <a:spcBef>
-                <a:spcPts val="500"/>
+                <a:spcPts val="1000"/>
               </a:spcBef>
             </a:pPr>
             <a:r>
-              <a:rPr sz="1900">
-                <a:solidFill>
-                  <a:srgbClr val="222222"/>
+              <a:rPr sz="2600">
+                <a:solidFill>
+                  <a:srgbClr val="111111"/>
                 </a:solidFill>
               </a:rPr>
-              <a:t>the inputs to 10 bits and computes all four dot products at the same time. Then the third stage</a:t>
+              <a:t/>
             </a:r>
           </a:p>
           <a:p>
             <a:pPr>
               <a:spcBef>
-                <a:spcPts val="500"/>
+                <a:spcPts val="0"/>
               </a:spcBef>
             </a:pPr>
             <a:r>
-              <a:rPr sz="1900">
-                <a:solidFill>
-                  <a:srgbClr val="222222"/>
+              <a:rPr sz="2600">
+                <a:solidFill>
+                  <a:srgbClr val="111111"/>
                 </a:solidFill>
               </a:rPr>
-              <a:t>is the output register, which latches the results on the next rising edge.</a:t>
+              <a:t>Then the third stage is the output register, which latches the results on the next rising edge.</a:t>
             </a:r>
           </a:p>
           <a:p>
             <a:pPr>
               <a:spcBef>
-                <a:spcPts val="500"/>
+                <a:spcPts val="1000"/>
               </a:spcBef>
             </a:pPr>
             <a:r>
-              <a:rPr sz="1900">
-                <a:solidFill>
-                  <a:srgbClr val="222222"/>
+              <a:rPr sz="2600">
+                <a:solidFill>
+                  <a:srgbClr val="111111"/>
                 </a:solidFill>
               </a:rPr>
               <a:t/>
@@ -4237,59 +3668,20 @@
           <a:p>
             <a:pPr>
               <a:spcBef>
-                <a:spcPts val="500"/>
+                <a:spcPts val="0"/>
               </a:spcBef>
             </a:pPr>
             <a:r>
-              <a:rPr sz="1900">
-                <a:solidFill>
-                  <a:srgbClr val="222222"/>
+              <a:rPr sz="2600">
+                <a:solidFill>
+                  <a:srgbClr val="111111"/>
                 </a:solidFill>
               </a:rPr>
-              <a:t>As for the output bit width, worst case is four inputs at plus or minus 127, so 4 times 127</a:t>
-            </a:r>
-          </a:p>
-          <a:p>
-            <a:pPr>
-              <a:spcBef>
-                <a:spcPts val="500"/>
-              </a:spcBef>
-            </a:pPr>
-            <a:r>
-              <a:rPr sz="1900">
-                <a:solidFill>
-                  <a:srgbClr val="222222"/>
-                </a:solidFill>
-              </a:rPr>
-              <a:t>is 508. And 10-bit signed goes up to 511, which clears the threshold we need.</a:t>
-            </a:r>
-          </a:p>
-        </p:txBody>
-      </p:sp>
-      <p:pic>
-        <p:nvPicPr>
-          <p:cNvPr id="7" name="Picture 6" descr="pipeline.png"/>
-          <p:cNvPicPr>
-            <a:picLocks noChangeAspect="1"/>
-          </p:cNvPicPr>
-          <p:nvPr/>
-        </p:nvPicPr>
-        <p:blipFill>
-          <a:blip r:embed="rId2"/>
-          <a:stretch>
-            <a:fillRect/>
-          </a:stretch>
-        </p:blipFill>
-        <p:spPr>
-          <a:xfrm>
-            <a:off x="7223760" y="685800"/>
-            <a:ext cx="4754880" cy="1755834"/>
-          </a:xfrm>
-          <a:prstGeom prst="rect">
-            <a:avLst/>
-          </a:prstGeom>
-        </p:spPr>
-      </p:pic>
+              <a:t>As for the output bit width, worst case is four inputs at plus or minus 127, so 4 times 127 is 508. And 10-bit signed goes up to 511, which clears the threshold we need.</a:t>
+            </a:r>
+          </a:p>
+        </p:txBody>
+      </p:sp>
     </p:spTree>
   </p:cSld>
   <p:clrMapOvr>
@@ -4310,143 +3702,14 @@
       <p:grpSpPr/>
       <p:sp>
         <p:nvSpPr>
-          <p:cNvPr id="2" name="Rectangle 1"/>
-          <p:cNvSpPr/>
+          <p:cNvPr id="2" name="TextBox 1"/>
+          <p:cNvSpPr txBox="1"/>
           <p:nvPr/>
         </p:nvSpPr>
         <p:spPr>
           <a:xfrm>
-            <a:off x="0" y="0"/>
-            <a:ext cx="12188952" cy="6858000"/>
-          </a:xfrm>
-          <a:prstGeom prst="rect">
-            <a:avLst/>
-          </a:prstGeom>
-          <a:solidFill>
-            <a:srgbClr val="F4F4F4"/>
-          </a:solidFill>
-          <a:ln>
-            <a:noFill/>
-          </a:ln>
-        </p:spPr>
-        <p:style>
-          <a:lnRef idx="1">
-            <a:schemeClr val="accent1"/>
-          </a:lnRef>
-          <a:fillRef idx="3">
-            <a:schemeClr val="accent1"/>
-          </a:fillRef>
-          <a:effectRef idx="2">
-            <a:schemeClr val="accent1"/>
-          </a:effectRef>
-          <a:fontRef idx="minor">
-            <a:schemeClr val="lt1"/>
-          </a:fontRef>
-        </p:style>
-        <p:txBody>
-          <a:bodyPr rtlCol="0" anchor="ctr"/>
-          <a:lstStyle/>
-          <a:p>
-            <a:pPr algn="ctr"/>
-          </a:p>
-        </p:txBody>
-      </p:sp>
-      <p:sp>
-        <p:nvSpPr>
-          <p:cNvPr id="3" name="Rectangle 2"/>
-          <p:cNvSpPr/>
-          <p:nvPr/>
-        </p:nvSpPr>
-        <p:spPr>
-          <a:xfrm>
-            <a:off x="0" y="0"/>
-            <a:ext cx="12188952" cy="502920"/>
-          </a:xfrm>
-          <a:prstGeom prst="rect">
-            <a:avLst/>
-          </a:prstGeom>
-          <a:solidFill>
-            <a:srgbClr val="1F4E79"/>
-          </a:solidFill>
-          <a:ln>
-            <a:noFill/>
-          </a:ln>
-        </p:spPr>
-        <p:style>
-          <a:lnRef idx="1">
-            <a:schemeClr val="accent1"/>
-          </a:lnRef>
-          <a:fillRef idx="3">
-            <a:schemeClr val="accent1"/>
-          </a:fillRef>
-          <a:effectRef idx="2">
-            <a:schemeClr val="accent1"/>
-          </a:effectRef>
-          <a:fontRef idx="minor">
-            <a:schemeClr val="lt1"/>
-          </a:fontRef>
-        </p:style>
-        <p:txBody>
-          <a:bodyPr rtlCol="0" anchor="ctr"/>
-          <a:lstStyle/>
-          <a:p>
-            <a:pPr algn="ctr"/>
-          </a:p>
-        </p:txBody>
-      </p:sp>
-      <p:sp>
-        <p:nvSpPr>
-          <p:cNvPr id="4" name="Rectangle 3"/>
-          <p:cNvSpPr/>
-          <p:nvPr/>
-        </p:nvSpPr>
-        <p:spPr>
-          <a:xfrm>
-            <a:off x="0" y="502920"/>
-            <a:ext cx="12188952" cy="54864"/>
-          </a:xfrm>
-          <a:prstGeom prst="rect">
-            <a:avLst/>
-          </a:prstGeom>
-          <a:solidFill>
-            <a:srgbClr val="1A7A4A"/>
-          </a:solidFill>
-          <a:ln>
-            <a:noFill/>
-          </a:ln>
-        </p:spPr>
-        <p:style>
-          <a:lnRef idx="1">
-            <a:schemeClr val="accent1"/>
-          </a:lnRef>
-          <a:fillRef idx="3">
-            <a:schemeClr val="accent1"/>
-          </a:fillRef>
-          <a:effectRef idx="2">
-            <a:schemeClr val="accent1"/>
-          </a:effectRef>
-          <a:fontRef idx="minor">
-            <a:schemeClr val="lt1"/>
-          </a:fontRef>
-        </p:style>
-        <p:txBody>
-          <a:bodyPr rtlCol="0" anchor="ctr"/>
-          <a:lstStyle/>
-          <a:p>
-            <a:pPr algn="ctr"/>
-          </a:p>
-        </p:txBody>
-      </p:sp>
-      <p:sp>
-        <p:nvSpPr>
-          <p:cNvPr id="5" name="TextBox 4"/>
-          <p:cNvSpPr txBox="1"/>
-          <p:nvPr/>
-        </p:nvSpPr>
-        <p:spPr>
-          <a:xfrm>
-            <a:off x="228600" y="54864"/>
-            <a:ext cx="11887200" cy="438912"/>
+            <a:off x="274320" y="91440"/>
+            <a:ext cx="10972800" cy="411480"/>
           </a:xfrm>
           <a:prstGeom prst="rect">
             <a:avLst/>
@@ -4459,28 +3722,27 @@
           </a:bodyPr>
           <a:lstStyle/>
           <a:p>
-            <a:pPr algn="l"/>
-            <a:r>
-              <a:rPr sz="2200" b="1">
-                <a:solidFill>
-                  <a:srgbClr val="FFFFFF"/>
+            <a:r>
+              <a:rPr sz="1600" b="1">
+                <a:solidFill>
+                  <a:srgbClr val="1A7A4A"/>
                 </a:solidFill>
               </a:rPr>
-              <a:t>The Testbench — Setup</a:t>
-            </a:r>
-          </a:p>
-        </p:txBody>
-      </p:sp>
-      <p:sp>
-        <p:nvSpPr>
-          <p:cNvPr id="6" name="TextBox 5"/>
+              <a:t>The Testbench</a:t>
+            </a:r>
+          </a:p>
+        </p:txBody>
+      </p:sp>
+      <p:sp>
+        <p:nvSpPr>
+          <p:cNvPr id="3" name="TextBox 2"/>
           <p:cNvSpPr txBox="1"/>
           <p:nvPr/>
         </p:nvSpPr>
         <p:spPr>
           <a:xfrm>
-            <a:off x="274320" y="685800"/>
-            <a:ext cx="6858000" cy="5943600"/>
+            <a:off x="365760" y="594360"/>
+            <a:ext cx="11430000" cy="6126480"/>
           </a:xfrm>
           <a:prstGeom prst="rect">
             <a:avLst/>
@@ -4495,58 +3757,58 @@
           <a:p>
             <a:pPr>
               <a:spcBef>
-                <a:spcPts val="500"/>
+                <a:spcPts val="0"/>
               </a:spcBef>
             </a:pPr>
             <a:r>
-              <a:rPr sz="1900">
-                <a:solidFill>
-                  <a:srgbClr val="222222"/>
+              <a:rPr sz="2600">
+                <a:solidFill>
+                  <a:srgbClr val="111111"/>
                 </a:solidFill>
               </a:rPr>
-              <a:t>So about the testbench. Claude loaded the weight matrix from the assignment spec, which is</a:t>
+              <a:t>So about the testbench. Claude loaded the weight matrix from the assignment spec, which is plus-one, minus-one, plus-one, minus-one on row zero, plus-one, plus-one, minus-one, minus-one on row one, and so on, and then it applied inputs of 10, 20, 30, and 40.</a:t>
             </a:r>
           </a:p>
           <a:p>
             <a:pPr>
               <a:spcBef>
-                <a:spcPts val="500"/>
+                <a:spcPts val="1000"/>
               </a:spcBef>
             </a:pPr>
             <a:r>
-              <a:rPr sz="1900">
-                <a:solidFill>
-                  <a:srgbClr val="222222"/>
+              <a:rPr sz="2600">
+                <a:solidFill>
+                  <a:srgbClr val="111111"/>
                 </a:solidFill>
               </a:rPr>
-              <a:t>plus-one, minus-one, plus-one, minus-one on row zero, plus-one, plus-one, minus-one, minus-one</a:t>
+              <a:t/>
             </a:r>
           </a:p>
           <a:p>
             <a:pPr>
               <a:spcBef>
-                <a:spcPts val="500"/>
+                <a:spcPts val="0"/>
               </a:spcBef>
             </a:pPr>
             <a:r>
-              <a:rPr sz="1900">
-                <a:solidFill>
-                  <a:srgbClr val="222222"/>
+              <a:rPr sz="2600">
+                <a:solidFill>
+                  <a:srgbClr val="111111"/>
                 </a:solidFill>
               </a:rPr>
-              <a:t>on row one, and so on, and then it applied inputs of 10, 20, 30, and 40.</a:t>
+              <a:t>Before running the simulation I hand-calculated the expected outputs, so for example, column zero, you get plus-ten from row 0, plus-twenty from row 1, and then minus-thirty and minus-forty from rows 2 and 3, and so that adds up to minus-40.</a:t>
             </a:r>
           </a:p>
           <a:p>
             <a:pPr>
               <a:spcBef>
-                <a:spcPts val="500"/>
+                <a:spcPts val="1000"/>
               </a:spcBef>
             </a:pPr>
             <a:r>
-              <a:rPr sz="1900">
-                <a:solidFill>
-                  <a:srgbClr val="222222"/>
+              <a:rPr sz="2600">
+                <a:solidFill>
+                  <a:srgbClr val="111111"/>
                 </a:solidFill>
               </a:rPr>
               <a:t/>
@@ -4555,89 +3817,20 @@
           <a:p>
             <a:pPr>
               <a:spcBef>
-                <a:spcPts val="500"/>
+                <a:spcPts val="0"/>
               </a:spcBef>
             </a:pPr>
             <a:r>
-              <a:rPr sz="1900">
-                <a:solidFill>
-                  <a:srgbClr val="222222"/>
+              <a:rPr sz="2600">
+                <a:solidFill>
+                  <a:srgbClr val="111111"/>
                 </a:solidFill>
               </a:rPr>
-              <a:t>Before running the simulation I hand-calculated the expected outputs, so for example, column zero,</a:t>
-            </a:r>
-          </a:p>
-          <a:p>
-            <a:pPr>
-              <a:spcBef>
-                <a:spcPts val="500"/>
-              </a:spcBef>
-            </a:pPr>
-            <a:r>
-              <a:rPr sz="1900">
-                <a:solidFill>
-                  <a:srgbClr val="222222"/>
-                </a:solidFill>
-              </a:rPr>
-              <a:t>you get plus-ten from row 0, plus-twenty from row 1, and then minus-thirty and minus-forty from</a:t>
-            </a:r>
-          </a:p>
-          <a:p>
-            <a:pPr>
-              <a:spcBef>
-                <a:spcPts val="500"/>
-              </a:spcBef>
-            </a:pPr>
-            <a:r>
-              <a:rPr sz="1900">
-                <a:solidFill>
-                  <a:srgbClr val="222222"/>
-                </a:solidFill>
-              </a:rPr>
-              <a:t>rows 2 and 3, and so that adds up to minus-40. I did the same for all four columns and got</a:t>
-            </a:r>
-          </a:p>
-          <a:p>
-            <a:pPr>
-              <a:spcBef>
-                <a:spcPts val="500"/>
-              </a:spcBef>
-            </a:pPr>
-            <a:r>
-              <a:rPr sz="1900">
-                <a:solidFill>
-                  <a:srgbClr val="222222"/>
-                </a:solidFill>
-              </a:rPr>
-              <a:t>minus-40, zero, minus-20, and minus-20.</a:t>
-            </a:r>
-          </a:p>
-        </p:txBody>
-      </p:sp>
-      <p:pic>
-        <p:nvPicPr>
-          <p:cNvPr id="7" name="Picture 6" descr="crossbar.png"/>
-          <p:cNvPicPr>
-            <a:picLocks noChangeAspect="1"/>
-          </p:cNvPicPr>
-          <p:nvPr/>
-        </p:nvPicPr>
-        <p:blipFill>
-          <a:blip r:embed="rId2"/>
-          <a:stretch>
-            <a:fillRect/>
-          </a:stretch>
-        </p:blipFill>
-        <p:spPr>
-          <a:xfrm>
-            <a:off x="7223760" y="731520"/>
-            <a:ext cx="5583438" cy="5486400"/>
-          </a:xfrm>
-          <a:prstGeom prst="rect">
-            <a:avLst/>
-          </a:prstGeom>
-        </p:spPr>
-      </p:pic>
+              <a:t>I did the same for all four columns and got minus-40, zero, minus-20, and minus-20.</a:t>
+            </a:r>
+          </a:p>
+        </p:txBody>
+      </p:sp>
     </p:spTree>
   </p:cSld>
   <p:clrMapOvr>
@@ -4658,143 +3851,14 @@
       <p:grpSpPr/>
       <p:sp>
         <p:nvSpPr>
-          <p:cNvPr id="2" name="Rectangle 1"/>
-          <p:cNvSpPr/>
+          <p:cNvPr id="2" name="TextBox 1"/>
+          <p:cNvSpPr txBox="1"/>
           <p:nvPr/>
         </p:nvSpPr>
         <p:spPr>
           <a:xfrm>
-            <a:off x="0" y="0"/>
-            <a:ext cx="12188952" cy="6858000"/>
-          </a:xfrm>
-          <a:prstGeom prst="rect">
-            <a:avLst/>
-          </a:prstGeom>
-          <a:solidFill>
-            <a:srgbClr val="F4F4F4"/>
-          </a:solidFill>
-          <a:ln>
-            <a:noFill/>
-          </a:ln>
-        </p:spPr>
-        <p:style>
-          <a:lnRef idx="1">
-            <a:schemeClr val="accent1"/>
-          </a:lnRef>
-          <a:fillRef idx="3">
-            <a:schemeClr val="accent1"/>
-          </a:fillRef>
-          <a:effectRef idx="2">
-            <a:schemeClr val="accent1"/>
-          </a:effectRef>
-          <a:fontRef idx="minor">
-            <a:schemeClr val="lt1"/>
-          </a:fontRef>
-        </p:style>
-        <p:txBody>
-          <a:bodyPr rtlCol="0" anchor="ctr"/>
-          <a:lstStyle/>
-          <a:p>
-            <a:pPr algn="ctr"/>
-          </a:p>
-        </p:txBody>
-      </p:sp>
-      <p:sp>
-        <p:nvSpPr>
-          <p:cNvPr id="3" name="Rectangle 2"/>
-          <p:cNvSpPr/>
-          <p:nvPr/>
-        </p:nvSpPr>
-        <p:spPr>
-          <a:xfrm>
-            <a:off x="0" y="0"/>
-            <a:ext cx="12188952" cy="502920"/>
-          </a:xfrm>
-          <a:prstGeom prst="rect">
-            <a:avLst/>
-          </a:prstGeom>
-          <a:solidFill>
-            <a:srgbClr val="1F4E79"/>
-          </a:solidFill>
-          <a:ln>
-            <a:noFill/>
-          </a:ln>
-        </p:spPr>
-        <p:style>
-          <a:lnRef idx="1">
-            <a:schemeClr val="accent1"/>
-          </a:lnRef>
-          <a:fillRef idx="3">
-            <a:schemeClr val="accent1"/>
-          </a:fillRef>
-          <a:effectRef idx="2">
-            <a:schemeClr val="accent1"/>
-          </a:effectRef>
-          <a:fontRef idx="minor">
-            <a:schemeClr val="lt1"/>
-          </a:fontRef>
-        </p:style>
-        <p:txBody>
-          <a:bodyPr rtlCol="0" anchor="ctr"/>
-          <a:lstStyle/>
-          <a:p>
-            <a:pPr algn="ctr"/>
-          </a:p>
-        </p:txBody>
-      </p:sp>
-      <p:sp>
-        <p:nvSpPr>
-          <p:cNvPr id="4" name="Rectangle 3"/>
-          <p:cNvSpPr/>
-          <p:nvPr/>
-        </p:nvSpPr>
-        <p:spPr>
-          <a:xfrm>
-            <a:off x="0" y="502920"/>
-            <a:ext cx="12188952" cy="54864"/>
-          </a:xfrm>
-          <a:prstGeom prst="rect">
-            <a:avLst/>
-          </a:prstGeom>
-          <a:solidFill>
-            <a:srgbClr val="1A7A4A"/>
-          </a:solidFill>
-          <a:ln>
-            <a:noFill/>
-          </a:ln>
-        </p:spPr>
-        <p:style>
-          <a:lnRef idx="1">
-            <a:schemeClr val="accent1"/>
-          </a:lnRef>
-          <a:fillRef idx="3">
-            <a:schemeClr val="accent1"/>
-          </a:fillRef>
-          <a:effectRef idx="2">
-            <a:schemeClr val="accent1"/>
-          </a:effectRef>
-          <a:fontRef idx="minor">
-            <a:schemeClr val="lt1"/>
-          </a:fontRef>
-        </p:style>
-        <p:txBody>
-          <a:bodyPr rtlCol="0" anchor="ctr"/>
-          <a:lstStyle/>
-          <a:p>
-            <a:pPr algn="ctr"/>
-          </a:p>
-        </p:txBody>
-      </p:sp>
-      <p:sp>
-        <p:nvSpPr>
-          <p:cNvPr id="5" name="TextBox 4"/>
-          <p:cNvSpPr txBox="1"/>
-          <p:nvPr/>
-        </p:nvSpPr>
-        <p:spPr>
-          <a:xfrm>
-            <a:off x="228600" y="54864"/>
-            <a:ext cx="11887200" cy="438912"/>
+            <a:off x="274320" y="91440"/>
+            <a:ext cx="10972800" cy="411480"/>
           </a:xfrm>
           <a:prstGeom prst="rect">
             <a:avLst/>
@@ -4807,28 +3871,27 @@
           </a:bodyPr>
           <a:lstStyle/>
           <a:p>
-            <a:pPr algn="l"/>
-            <a:r>
-              <a:rPr sz="2200" b="1">
-                <a:solidFill>
-                  <a:srgbClr val="FFFFFF"/>
+            <a:r>
+              <a:rPr sz="1600" b="1">
+                <a:solidFill>
+                  <a:srgbClr val="1A7A4A"/>
                 </a:solidFill>
               </a:rPr>
-              <a:t>The Testbench — 2-Cycle Timing</a:t>
-            </a:r>
-          </a:p>
-        </p:txBody>
-      </p:sp>
-      <p:sp>
-        <p:nvSpPr>
-          <p:cNvPr id="6" name="TextBox 5"/>
+              <a:t>The Testbench — Timing</a:t>
+            </a:r>
+          </a:p>
+        </p:txBody>
+      </p:sp>
+      <p:sp>
+        <p:nvSpPr>
+          <p:cNvPr id="3" name="TextBox 2"/>
           <p:cNvSpPr txBox="1"/>
           <p:nvPr/>
         </p:nvSpPr>
         <p:spPr>
           <a:xfrm>
-            <a:off x="274320" y="685800"/>
-            <a:ext cx="6858000" cy="4114800"/>
+            <a:off x="365760" y="594360"/>
+            <a:ext cx="11430000" cy="6126480"/>
           </a:xfrm>
           <a:prstGeom prst="rect">
             <a:avLst/>
@@ -4843,128 +3906,80 @@
           <a:p>
             <a:pPr>
               <a:spcBef>
-                <a:spcPts val="500"/>
+                <a:spcPts val="0"/>
               </a:spcBef>
             </a:pPr>
             <a:r>
-              <a:rPr sz="1900">
-                <a:solidFill>
-                  <a:srgbClr val="222222"/>
+              <a:rPr sz="2600">
+                <a:solidFill>
+                  <a:srgbClr val="111111"/>
                 </a:solidFill>
               </a:rPr>
-              <a:t>One thing about the timing Claude had to get right, and the output shows up two cycles after</a:t>
+              <a:t>One thing about the timing Claude had to get right, and the output shows up two cycles after you assert weight_load, not one.</a:t>
             </a:r>
           </a:p>
           <a:p>
             <a:pPr>
               <a:spcBef>
-                <a:spcPts val="500"/>
+                <a:spcPts val="1000"/>
               </a:spcBef>
             </a:pPr>
             <a:r>
-              <a:rPr sz="1900">
-                <a:solidFill>
-                  <a:srgbClr val="222222"/>
+              <a:rPr sz="2600">
+                <a:solidFill>
+                  <a:srgbClr val="111111"/>
                 </a:solidFill>
               </a:rPr>
-              <a:t>you assert weight_load, not one. Basically here's why, so on the first rising edge after</a:t>
+              <a:t/>
             </a:r>
           </a:p>
           <a:p>
             <a:pPr>
               <a:spcBef>
-                <a:spcPts val="500"/>
+                <a:spcPts val="0"/>
               </a:spcBef>
             </a:pPr>
             <a:r>
-              <a:rPr sz="1900">
-                <a:solidFill>
-                  <a:srgbClr val="222222"/>
+              <a:rPr sz="2600">
+                <a:solidFill>
+                  <a:srgbClr val="111111"/>
                 </a:solidFill>
               </a:rPr>
-              <a:t>weight_load, the weight register latches the new weights, but the output register clocks on</a:t>
+              <a:t>Basically here's why, so on the first rising edge after weight_load, the weight register latches the new weights, but the output register clocks on that same edge and it's still using the old weights.</a:t>
             </a:r>
           </a:p>
           <a:p>
             <a:pPr>
               <a:spcBef>
-                <a:spcPts val="500"/>
+                <a:spcPts val="1000"/>
               </a:spcBef>
             </a:pPr>
             <a:r>
-              <a:rPr sz="1900">
-                <a:solidFill>
-                  <a:srgbClr val="222222"/>
+              <a:rPr sz="2600">
+                <a:solidFill>
+                  <a:srgbClr val="111111"/>
                 </a:solidFill>
               </a:rPr>
-              <a:t>that same edge and it's still using the old weights. And so the correct output only appears</a:t>
+              <a:t/>
             </a:r>
           </a:p>
           <a:p>
             <a:pPr>
               <a:spcBef>
-                <a:spcPts val="500"/>
+                <a:spcPts val="0"/>
               </a:spcBef>
             </a:pPr>
             <a:r>
-              <a:rPr sz="1900">
-                <a:solidFill>
-                  <a:srgbClr val="222222"/>
+              <a:rPr sz="2600">
+                <a:solidFill>
+                  <a:srgbClr val="111111"/>
                 </a:solidFill>
               </a:rPr>
-              <a:t>one cycle later. The testbench explicitly waits two cycles before reading the outputs.</a:t>
-            </a:r>
-          </a:p>
-        </p:txBody>
-      </p:sp>
-      <p:pic>
-        <p:nvPicPr>
-          <p:cNvPr id="7" name="Picture 6" descr="timing.png"/>
-          <p:cNvPicPr>
-            <a:picLocks noChangeAspect="1"/>
-          </p:cNvPicPr>
-          <p:nvPr/>
-        </p:nvPicPr>
-        <p:blipFill>
-          <a:blip r:embed="rId2"/>
-          <a:stretch>
-            <a:fillRect/>
-          </a:stretch>
-        </p:blipFill>
-        <p:spPr>
-          <a:xfrm>
-            <a:off x="274320" y="4754880"/>
-            <a:ext cx="6858000" cy="3218704"/>
-          </a:xfrm>
-          <a:prstGeom prst="rect">
-            <a:avLst/>
-          </a:prstGeom>
-        </p:spPr>
-      </p:pic>
-      <p:pic>
-        <p:nvPicPr>
-          <p:cNvPr id="8" name="Picture 7" descr="pipeline.png"/>
-          <p:cNvPicPr>
-            <a:picLocks noChangeAspect="1"/>
-          </p:cNvPicPr>
-          <p:nvPr/>
-        </p:nvPicPr>
-        <p:blipFill>
-          <a:blip r:embed="rId3"/>
-          <a:stretch>
-            <a:fillRect/>
-          </a:stretch>
-        </p:blipFill>
-        <p:spPr>
-          <a:xfrm>
-            <a:off x="7223760" y="685800"/>
-            <a:ext cx="4754880" cy="1755834"/>
-          </a:xfrm>
-          <a:prstGeom prst="rect">
-            <a:avLst/>
-          </a:prstGeom>
-        </p:spPr>
-      </p:pic>
+              <a:t>And so the correct output only appears one cycle later. The testbench explicitly waits two cycles before reading the outputs.</a:t>
+            </a:r>
+          </a:p>
+        </p:txBody>
+      </p:sp>
     </p:spTree>
   </p:cSld>
   <p:clrMapOvr>
@@ -4985,143 +4000,14 @@
       <p:grpSpPr/>
       <p:sp>
         <p:nvSpPr>
-          <p:cNvPr id="2" name="Rectangle 1"/>
-          <p:cNvSpPr/>
+          <p:cNvPr id="2" name="TextBox 1"/>
+          <p:cNvSpPr txBox="1"/>
           <p:nvPr/>
         </p:nvSpPr>
         <p:spPr>
           <a:xfrm>
-            <a:off x="0" y="0"/>
-            <a:ext cx="12188952" cy="6858000"/>
-          </a:xfrm>
-          <a:prstGeom prst="rect">
-            <a:avLst/>
-          </a:prstGeom>
-          <a:solidFill>
-            <a:srgbClr val="F4F4F4"/>
-          </a:solidFill>
-          <a:ln>
-            <a:noFill/>
-          </a:ln>
-        </p:spPr>
-        <p:style>
-          <a:lnRef idx="1">
-            <a:schemeClr val="accent1"/>
-          </a:lnRef>
-          <a:fillRef idx="3">
-            <a:schemeClr val="accent1"/>
-          </a:fillRef>
-          <a:effectRef idx="2">
-            <a:schemeClr val="accent1"/>
-          </a:effectRef>
-          <a:fontRef idx="minor">
-            <a:schemeClr val="lt1"/>
-          </a:fontRef>
-        </p:style>
-        <p:txBody>
-          <a:bodyPr rtlCol="0" anchor="ctr"/>
-          <a:lstStyle/>
-          <a:p>
-            <a:pPr algn="ctr"/>
-          </a:p>
-        </p:txBody>
-      </p:sp>
-      <p:sp>
-        <p:nvSpPr>
-          <p:cNvPr id="3" name="Rectangle 2"/>
-          <p:cNvSpPr/>
-          <p:nvPr/>
-        </p:nvSpPr>
-        <p:spPr>
-          <a:xfrm>
-            <a:off x="0" y="0"/>
-            <a:ext cx="12188952" cy="502920"/>
-          </a:xfrm>
-          <a:prstGeom prst="rect">
-            <a:avLst/>
-          </a:prstGeom>
-          <a:solidFill>
-            <a:srgbClr val="1F4E79"/>
-          </a:solidFill>
-          <a:ln>
-            <a:noFill/>
-          </a:ln>
-        </p:spPr>
-        <p:style>
-          <a:lnRef idx="1">
-            <a:schemeClr val="accent1"/>
-          </a:lnRef>
-          <a:fillRef idx="3">
-            <a:schemeClr val="accent1"/>
-          </a:fillRef>
-          <a:effectRef idx="2">
-            <a:schemeClr val="accent1"/>
-          </a:effectRef>
-          <a:fontRef idx="minor">
-            <a:schemeClr val="lt1"/>
-          </a:fontRef>
-        </p:style>
-        <p:txBody>
-          <a:bodyPr rtlCol="0" anchor="ctr"/>
-          <a:lstStyle/>
-          <a:p>
-            <a:pPr algn="ctr"/>
-          </a:p>
-        </p:txBody>
-      </p:sp>
-      <p:sp>
-        <p:nvSpPr>
-          <p:cNvPr id="4" name="Rectangle 3"/>
-          <p:cNvSpPr/>
-          <p:nvPr/>
-        </p:nvSpPr>
-        <p:spPr>
-          <a:xfrm>
-            <a:off x="0" y="502920"/>
-            <a:ext cx="12188952" cy="54864"/>
-          </a:xfrm>
-          <a:prstGeom prst="rect">
-            <a:avLst/>
-          </a:prstGeom>
-          <a:solidFill>
-            <a:srgbClr val="1A7A4A"/>
-          </a:solidFill>
-          <a:ln>
-            <a:noFill/>
-          </a:ln>
-        </p:spPr>
-        <p:style>
-          <a:lnRef idx="1">
-            <a:schemeClr val="accent1"/>
-          </a:lnRef>
-          <a:fillRef idx="3">
-            <a:schemeClr val="accent1"/>
-          </a:fillRef>
-          <a:effectRef idx="2">
-            <a:schemeClr val="accent1"/>
-          </a:effectRef>
-          <a:fontRef idx="minor">
-            <a:schemeClr val="lt1"/>
-          </a:fontRef>
-        </p:style>
-        <p:txBody>
-          <a:bodyPr rtlCol="0" anchor="ctr"/>
-          <a:lstStyle/>
-          <a:p>
-            <a:pPr algn="ctr"/>
-          </a:p>
-        </p:txBody>
-      </p:sp>
-      <p:sp>
-        <p:nvSpPr>
-          <p:cNvPr id="5" name="TextBox 4"/>
-          <p:cNvSpPr txBox="1"/>
-          <p:nvPr/>
-        </p:nvSpPr>
-        <p:spPr>
-          <a:xfrm>
-            <a:off x="228600" y="54864"/>
-            <a:ext cx="11887200" cy="438912"/>
+            <a:off x="274320" y="91440"/>
+            <a:ext cx="10972800" cy="411480"/>
           </a:xfrm>
           <a:prstGeom prst="rect">
             <a:avLst/>
@@ -5134,11 +4020,10 @@
           </a:bodyPr>
           <a:lstStyle/>
           <a:p>
-            <a:pPr algn="l"/>
-            <a:r>
-              <a:rPr sz="2200" b="1">
-                <a:solidFill>
-                  <a:srgbClr val="FFFFFF"/>
+            <a:r>
+              <a:rPr sz="1600" b="1">
+                <a:solidFill>
+                  <a:srgbClr val="1A7A4A"/>
                 </a:solidFill>
               </a:rPr>
               <a:t>The Simulation Results</a:t>
@@ -5148,14 +4033,14 @@
       </p:sp>
       <p:sp>
         <p:nvSpPr>
-          <p:cNvPr id="6" name="TextBox 5"/>
+          <p:cNvPr id="3" name="TextBox 2"/>
           <p:cNvSpPr txBox="1"/>
           <p:nvPr/>
         </p:nvSpPr>
         <p:spPr>
           <a:xfrm>
-            <a:off x="274320" y="685800"/>
-            <a:ext cx="6858000" cy="2743200"/>
+            <a:off x="365760" y="594360"/>
+            <a:ext cx="11430000" cy="6126480"/>
           </a:xfrm>
           <a:prstGeom prst="rect">
             <a:avLst/>
@@ -5170,43 +4055,73 @@
           <a:p>
             <a:pPr>
               <a:spcBef>
-                <a:spcPts val="500"/>
+                <a:spcPts val="0"/>
               </a:spcBef>
             </a:pPr>
             <a:r>
-              <a:rPr sz="1900">
-                <a:solidFill>
-                  <a:srgbClr val="222222"/>
+              <a:rPr sz="3200">
+                <a:solidFill>
+                  <a:srgbClr val="111111"/>
                 </a:solidFill>
               </a:rPr>
-              <a:t>All four outputs match what I expected. Out-zero is minus-40, out-one is zero,</a:t>
+              <a:t>All four outputs match what I expected.</a:t>
             </a:r>
           </a:p>
           <a:p>
             <a:pPr>
               <a:spcBef>
-                <a:spcPts val="500"/>
+                <a:spcPts val="1000"/>
               </a:spcBef>
             </a:pPr>
             <a:r>
-              <a:rPr sz="1900">
-                <a:solidFill>
-                  <a:srgbClr val="222222"/>
+              <a:rPr sz="3200">
+                <a:solidFill>
+                  <a:srgbClr val="111111"/>
                 </a:solidFill>
               </a:rPr>
-              <a:t>out-two and out-three are both minus-20, exactly what my hand calculation said.</a:t>
+              <a:t/>
             </a:r>
           </a:p>
           <a:p>
             <a:pPr>
               <a:spcBef>
-                <a:spcPts val="500"/>
+                <a:spcPts val="0"/>
               </a:spcBef>
             </a:pPr>
             <a:r>
-              <a:rPr sz="1900">
-                <a:solidFill>
-                  <a:srgbClr val="222222"/>
+              <a:rPr sz="3200">
+                <a:solidFill>
+                  <a:srgbClr val="111111"/>
+                </a:solidFill>
+              </a:rPr>
+              <a:t>Out-zero is minus-40, out-one is zero, out-two and out-three are both minus-20, exactly what my hand calculation said.</a:t>
+            </a:r>
+          </a:p>
+          <a:p>
+            <a:pPr>
+              <a:spcBef>
+                <a:spcPts val="1000"/>
+              </a:spcBef>
+            </a:pPr>
+            <a:r>
+              <a:rPr sz="3200">
+                <a:solidFill>
+                  <a:srgbClr val="111111"/>
+                </a:solidFill>
+              </a:rPr>
+              <a:t/>
+            </a:r>
+          </a:p>
+          <a:p>
+            <a:pPr>
+              <a:spcBef>
+                <a:spcPts val="0"/>
+              </a:spcBef>
+            </a:pPr>
+            <a:r>
+              <a:rPr sz="3200">
+                <a:solidFill>
+                  <a:srgbClr val="111111"/>
                 </a:solidFill>
               </a:rPr>
               <a:t>So 4 out of 4, that's pretty good. Thanks.</a:t>
@@ -5214,54 +4129,6 @@
           </a:p>
         </p:txBody>
       </p:sp>
-      <p:pic>
-        <p:nvPicPr>
-          <p:cNvPr id="7" name="Picture 6" descr="results.png"/>
-          <p:cNvPicPr>
-            <a:picLocks noChangeAspect="1"/>
-          </p:cNvPicPr>
-          <p:nvPr/>
-        </p:nvPicPr>
-        <p:blipFill>
-          <a:blip r:embed="rId2"/>
-          <a:stretch>
-            <a:fillRect/>
-          </a:stretch>
-        </p:blipFill>
-        <p:spPr>
-          <a:xfrm>
-            <a:off x="274320" y="3474720"/>
-            <a:ext cx="6858000" cy="3314153"/>
-          </a:xfrm>
-          <a:prstGeom prst="rect">
-            <a:avLst/>
-          </a:prstGeom>
-        </p:spPr>
-      </p:pic>
-      <p:pic>
-        <p:nvPicPr>
-          <p:cNvPr id="8" name="Picture 7" descr="crossbar.png"/>
-          <p:cNvPicPr>
-            <a:picLocks noChangeAspect="1"/>
-          </p:cNvPicPr>
-          <p:nvPr/>
-        </p:nvPicPr>
-        <p:blipFill>
-          <a:blip r:embed="rId3"/>
-          <a:stretch>
-            <a:fillRect/>
-          </a:stretch>
-        </p:blipFill>
-        <p:spPr>
-          <a:xfrm>
-            <a:off x="7223760" y="685800"/>
-            <a:ext cx="5583438" cy="5486400"/>
-          </a:xfrm>
-          <a:prstGeom prst="rect">
-            <a:avLst/>
-          </a:prstGeom>
-        </p:spPr>
-      </p:pic>
     </p:spTree>
   </p:cSld>
   <p:clrMapOvr>

</xml_diff>

<commit_message>
CF06: slides — exact script text left, diagram right
Co-Authored-By: Claude Sonnet 4.6 <noreply@anthropic.com>
</commit_message>
<xml_diff>
--- a/codefest/cf06/presentation/cf06_cllm_slides.pptx
+++ b/codefest/cf06/presentation/cf06_cllm_slides.pptx
@@ -3265,7 +3265,7 @@
         <p:spPr>
           <a:xfrm>
             <a:off x="365760" y="594360"/>
-            <a:ext cx="11430000" cy="6126480"/>
+            <a:ext cx="6858000" cy="6126480"/>
           </a:xfrm>
           <a:prstGeom prst="rect">
             <a:avLst/>
@@ -3284,7 +3284,7 @@
               </a:spcBef>
             </a:pPr>
             <a:r>
-              <a:rPr sz="2600">
+              <a:rPr sz="2200">
                 <a:solidFill>
                   <a:srgbClr val="111111"/>
                 </a:solidFill>
@@ -3299,7 +3299,7 @@
               </a:spcBef>
             </a:pPr>
             <a:r>
-              <a:rPr sz="2600">
+              <a:rPr sz="2200">
                 <a:solidFill>
                   <a:srgbClr val="111111"/>
                 </a:solidFill>
@@ -3314,7 +3314,7 @@
               </a:spcBef>
             </a:pPr>
             <a:r>
-              <a:rPr sz="2600">
+              <a:rPr sz="2200">
                 <a:solidFill>
                   <a:srgbClr val="111111"/>
                 </a:solidFill>
@@ -3329,7 +3329,7 @@
               </a:spcBef>
             </a:pPr>
             <a:r>
-              <a:rPr sz="2600">
+              <a:rPr sz="2200">
                 <a:solidFill>
                   <a:srgbClr val="111111"/>
                 </a:solidFill>
@@ -3344,7 +3344,7 @@
               </a:spcBef>
             </a:pPr>
             <a:r>
-              <a:rPr sz="2600">
+              <a:rPr sz="2200">
                 <a:solidFill>
                   <a:srgbClr val="111111"/>
                 </a:solidFill>
@@ -3359,7 +3359,7 @@
               </a:spcBef>
             </a:pPr>
             <a:r>
-              <a:rPr sz="2600">
+              <a:rPr sz="2200">
                 <a:solidFill>
                   <a:srgbClr val="111111"/>
                 </a:solidFill>
@@ -3374,7 +3374,7 @@
               </a:spcBef>
             </a:pPr>
             <a:r>
-              <a:rPr sz="2600">
+              <a:rPr sz="2200">
                 <a:solidFill>
                   <a:srgbClr val="111111"/>
                 </a:solidFill>
@@ -3384,6 +3384,30 @@
           </a:p>
         </p:txBody>
       </p:sp>
+      <p:pic>
+        <p:nvPicPr>
+          <p:cNvPr id="4" name="Picture 3" descr="crossbar.png"/>
+          <p:cNvPicPr>
+            <a:picLocks noChangeAspect="1"/>
+          </p:cNvPicPr>
+          <p:nvPr/>
+        </p:nvPicPr>
+        <p:blipFill>
+          <a:blip r:embed="rId2"/>
+          <a:stretch>
+            <a:fillRect/>
+          </a:stretch>
+        </p:blipFill>
+        <p:spPr>
+          <a:xfrm>
+            <a:off x="7406640" y="594360"/>
+            <a:ext cx="4572000" cy="4492540"/>
+          </a:xfrm>
+          <a:prstGeom prst="rect">
+            <a:avLst/>
+          </a:prstGeom>
+        </p:spPr>
+      </p:pic>
     </p:spTree>
   </p:cSld>
   <p:clrMapOvr>
@@ -3444,7 +3468,7 @@
         <p:spPr>
           <a:xfrm>
             <a:off x="365760" y="594360"/>
-            <a:ext cx="11430000" cy="6126480"/>
+            <a:ext cx="6858000" cy="6126480"/>
           </a:xfrm>
           <a:prstGeom prst="rect">
             <a:avLst/>
@@ -3463,7 +3487,7 @@
               </a:spcBef>
             </a:pPr>
             <a:r>
-              <a:rPr sz="2600">
+              <a:rPr sz="2200">
                 <a:solidFill>
                   <a:srgbClr val="111111"/>
                 </a:solidFill>
@@ -3478,7 +3502,7 @@
               </a:spcBef>
             </a:pPr>
             <a:r>
-              <a:rPr sz="2600">
+              <a:rPr sz="2200">
                 <a:solidFill>
                   <a:srgbClr val="111111"/>
                 </a:solidFill>
@@ -3493,7 +3517,7 @@
               </a:spcBef>
             </a:pPr>
             <a:r>
-              <a:rPr sz="2600">
+              <a:rPr sz="2200">
                 <a:solidFill>
                   <a:srgbClr val="111111"/>
                 </a:solidFill>
@@ -3508,7 +3532,7 @@
               </a:spcBef>
             </a:pPr>
             <a:r>
-              <a:rPr sz="2600">
+              <a:rPr sz="2200">
                 <a:solidFill>
                   <a:srgbClr val="111111"/>
                 </a:solidFill>
@@ -3523,7 +3547,7 @@
               </a:spcBef>
             </a:pPr>
             <a:r>
-              <a:rPr sz="2600">
+              <a:rPr sz="2200">
                 <a:solidFill>
                   <a:srgbClr val="111111"/>
                 </a:solidFill>
@@ -3533,6 +3557,30 @@
           </a:p>
         </p:txBody>
       </p:sp>
+      <p:pic>
+        <p:nvPicPr>
+          <p:cNvPr id="4" name="Picture 3" descr="encoding.png"/>
+          <p:cNvPicPr>
+            <a:picLocks noChangeAspect="1"/>
+          </p:cNvPicPr>
+          <p:nvPr/>
+        </p:nvPicPr>
+        <p:blipFill>
+          <a:blip r:embed="rId2"/>
+          <a:stretch>
+            <a:fillRect/>
+          </a:stretch>
+        </p:blipFill>
+        <p:spPr>
+          <a:xfrm>
+            <a:off x="7406640" y="594360"/>
+            <a:ext cx="4572000" cy="1558724"/>
+          </a:xfrm>
+          <a:prstGeom prst="rect">
+            <a:avLst/>
+          </a:prstGeom>
+        </p:spPr>
+      </p:pic>
     </p:spTree>
   </p:cSld>
   <p:clrMapOvr>
@@ -3593,7 +3641,7 @@
         <p:spPr>
           <a:xfrm>
             <a:off x="365760" y="594360"/>
-            <a:ext cx="11430000" cy="6126480"/>
+            <a:ext cx="6858000" cy="6126480"/>
           </a:xfrm>
           <a:prstGeom prst="rect">
             <a:avLst/>
@@ -3612,7 +3660,7 @@
               </a:spcBef>
             </a:pPr>
             <a:r>
-              <a:rPr sz="2600">
+              <a:rPr sz="2200">
                 <a:solidFill>
                   <a:srgbClr val="111111"/>
                 </a:solidFill>
@@ -3627,7 +3675,7 @@
               </a:spcBef>
             </a:pPr>
             <a:r>
-              <a:rPr sz="2600">
+              <a:rPr sz="2200">
                 <a:solidFill>
                   <a:srgbClr val="111111"/>
                 </a:solidFill>
@@ -3642,7 +3690,7 @@
               </a:spcBef>
             </a:pPr>
             <a:r>
-              <a:rPr sz="2600">
+              <a:rPr sz="2200">
                 <a:solidFill>
                   <a:srgbClr val="111111"/>
                 </a:solidFill>
@@ -3657,7 +3705,7 @@
               </a:spcBef>
             </a:pPr>
             <a:r>
-              <a:rPr sz="2600">
+              <a:rPr sz="2200">
                 <a:solidFill>
                   <a:srgbClr val="111111"/>
                 </a:solidFill>
@@ -3672,7 +3720,7 @@
               </a:spcBef>
             </a:pPr>
             <a:r>
-              <a:rPr sz="2600">
+              <a:rPr sz="2200">
                 <a:solidFill>
                   <a:srgbClr val="111111"/>
                 </a:solidFill>
@@ -3682,6 +3730,30 @@
           </a:p>
         </p:txBody>
       </p:sp>
+      <p:pic>
+        <p:nvPicPr>
+          <p:cNvPr id="4" name="Picture 3" descr="pipeline.png"/>
+          <p:cNvPicPr>
+            <a:picLocks noChangeAspect="1"/>
+          </p:cNvPicPr>
+          <p:nvPr/>
+        </p:nvPicPr>
+        <p:blipFill>
+          <a:blip r:embed="rId2"/>
+          <a:stretch>
+            <a:fillRect/>
+          </a:stretch>
+        </p:blipFill>
+        <p:spPr>
+          <a:xfrm>
+            <a:off x="7406640" y="594360"/>
+            <a:ext cx="4572000" cy="1688302"/>
+          </a:xfrm>
+          <a:prstGeom prst="rect">
+            <a:avLst/>
+          </a:prstGeom>
+        </p:spPr>
+      </p:pic>
     </p:spTree>
   </p:cSld>
   <p:clrMapOvr>
@@ -3742,7 +3814,7 @@
         <p:spPr>
           <a:xfrm>
             <a:off x="365760" y="594360"/>
-            <a:ext cx="11430000" cy="6126480"/>
+            <a:ext cx="6858000" cy="6126480"/>
           </a:xfrm>
           <a:prstGeom prst="rect">
             <a:avLst/>
@@ -3761,7 +3833,7 @@
               </a:spcBef>
             </a:pPr>
             <a:r>
-              <a:rPr sz="2600">
+              <a:rPr sz="2200">
                 <a:solidFill>
                   <a:srgbClr val="111111"/>
                 </a:solidFill>
@@ -3776,7 +3848,7 @@
               </a:spcBef>
             </a:pPr>
             <a:r>
-              <a:rPr sz="2600">
+              <a:rPr sz="2200">
                 <a:solidFill>
                   <a:srgbClr val="111111"/>
                 </a:solidFill>
@@ -3791,7 +3863,7 @@
               </a:spcBef>
             </a:pPr>
             <a:r>
-              <a:rPr sz="2600">
+              <a:rPr sz="2200">
                 <a:solidFill>
                   <a:srgbClr val="111111"/>
                 </a:solidFill>
@@ -3806,7 +3878,7 @@
               </a:spcBef>
             </a:pPr>
             <a:r>
-              <a:rPr sz="2600">
+              <a:rPr sz="2200">
                 <a:solidFill>
                   <a:srgbClr val="111111"/>
                 </a:solidFill>
@@ -3821,7 +3893,7 @@
               </a:spcBef>
             </a:pPr>
             <a:r>
-              <a:rPr sz="2600">
+              <a:rPr sz="2200">
                 <a:solidFill>
                   <a:srgbClr val="111111"/>
                 </a:solidFill>
@@ -3831,6 +3903,30 @@
           </a:p>
         </p:txBody>
       </p:sp>
+      <p:pic>
+        <p:nvPicPr>
+          <p:cNvPr id="4" name="Picture 3" descr="crossbar.png"/>
+          <p:cNvPicPr>
+            <a:picLocks noChangeAspect="1"/>
+          </p:cNvPicPr>
+          <p:nvPr/>
+        </p:nvPicPr>
+        <p:blipFill>
+          <a:blip r:embed="rId2"/>
+          <a:stretch>
+            <a:fillRect/>
+          </a:stretch>
+        </p:blipFill>
+        <p:spPr>
+          <a:xfrm>
+            <a:off x="7406640" y="594360"/>
+            <a:ext cx="4572000" cy="4492540"/>
+          </a:xfrm>
+          <a:prstGeom prst="rect">
+            <a:avLst/>
+          </a:prstGeom>
+        </p:spPr>
+      </p:pic>
     </p:spTree>
   </p:cSld>
   <p:clrMapOvr>
@@ -3891,7 +3987,7 @@
         <p:spPr>
           <a:xfrm>
             <a:off x="365760" y="594360"/>
-            <a:ext cx="11430000" cy="6126480"/>
+            <a:ext cx="6858000" cy="6126480"/>
           </a:xfrm>
           <a:prstGeom prst="rect">
             <a:avLst/>
@@ -3910,7 +4006,7 @@
               </a:spcBef>
             </a:pPr>
             <a:r>
-              <a:rPr sz="2600">
+              <a:rPr sz="2200">
                 <a:solidFill>
                   <a:srgbClr val="111111"/>
                 </a:solidFill>
@@ -3925,7 +4021,7 @@
               </a:spcBef>
             </a:pPr>
             <a:r>
-              <a:rPr sz="2600">
+              <a:rPr sz="2200">
                 <a:solidFill>
                   <a:srgbClr val="111111"/>
                 </a:solidFill>
@@ -3940,7 +4036,7 @@
               </a:spcBef>
             </a:pPr>
             <a:r>
-              <a:rPr sz="2600">
+              <a:rPr sz="2200">
                 <a:solidFill>
                   <a:srgbClr val="111111"/>
                 </a:solidFill>
@@ -3955,7 +4051,7 @@
               </a:spcBef>
             </a:pPr>
             <a:r>
-              <a:rPr sz="2600">
+              <a:rPr sz="2200">
                 <a:solidFill>
                   <a:srgbClr val="111111"/>
                 </a:solidFill>
@@ -3970,7 +4066,7 @@
               </a:spcBef>
             </a:pPr>
             <a:r>
-              <a:rPr sz="2600">
+              <a:rPr sz="2200">
                 <a:solidFill>
                   <a:srgbClr val="111111"/>
                 </a:solidFill>
@@ -3980,6 +4076,30 @@
           </a:p>
         </p:txBody>
       </p:sp>
+      <p:pic>
+        <p:nvPicPr>
+          <p:cNvPr id="4" name="Picture 3" descr="timing.png"/>
+          <p:cNvPicPr>
+            <a:picLocks noChangeAspect="1"/>
+          </p:cNvPicPr>
+          <p:nvPr/>
+        </p:nvPicPr>
+        <p:blipFill>
+          <a:blip r:embed="rId2"/>
+          <a:stretch>
+            <a:fillRect/>
+          </a:stretch>
+        </p:blipFill>
+        <p:spPr>
+          <a:xfrm>
+            <a:off x="7406640" y="594360"/>
+            <a:ext cx="4572000" cy="2145802"/>
+          </a:xfrm>
+          <a:prstGeom prst="rect">
+            <a:avLst/>
+          </a:prstGeom>
+        </p:spPr>
+      </p:pic>
     </p:spTree>
   </p:cSld>
   <p:clrMapOvr>
@@ -4040,7 +4160,7 @@
         <p:spPr>
           <a:xfrm>
             <a:off x="365760" y="594360"/>
-            <a:ext cx="11430000" cy="6126480"/>
+            <a:ext cx="6858000" cy="6126480"/>
           </a:xfrm>
           <a:prstGeom prst="rect">
             <a:avLst/>
@@ -4059,7 +4179,7 @@
               </a:spcBef>
             </a:pPr>
             <a:r>
-              <a:rPr sz="3200">
+              <a:rPr sz="2800">
                 <a:solidFill>
                   <a:srgbClr val="111111"/>
                 </a:solidFill>
@@ -4074,7 +4194,7 @@
               </a:spcBef>
             </a:pPr>
             <a:r>
-              <a:rPr sz="3200">
+              <a:rPr sz="2800">
                 <a:solidFill>
                   <a:srgbClr val="111111"/>
                 </a:solidFill>
@@ -4089,7 +4209,7 @@
               </a:spcBef>
             </a:pPr>
             <a:r>
-              <a:rPr sz="3200">
+              <a:rPr sz="2800">
                 <a:solidFill>
                   <a:srgbClr val="111111"/>
                 </a:solidFill>
@@ -4104,7 +4224,7 @@
               </a:spcBef>
             </a:pPr>
             <a:r>
-              <a:rPr sz="3200">
+              <a:rPr sz="2800">
                 <a:solidFill>
                   <a:srgbClr val="111111"/>
                 </a:solidFill>
@@ -4119,7 +4239,7 @@
               </a:spcBef>
             </a:pPr>
             <a:r>
-              <a:rPr sz="3200">
+              <a:rPr sz="2800">
                 <a:solidFill>
                   <a:srgbClr val="111111"/>
                 </a:solidFill>
@@ -4129,6 +4249,30 @@
           </a:p>
         </p:txBody>
       </p:sp>
+      <p:pic>
+        <p:nvPicPr>
+          <p:cNvPr id="4" name="Picture 3" descr="results.png"/>
+          <p:cNvPicPr>
+            <a:picLocks noChangeAspect="1"/>
+          </p:cNvPicPr>
+          <p:nvPr/>
+        </p:nvPicPr>
+        <p:blipFill>
+          <a:blip r:embed="rId2"/>
+          <a:stretch>
+            <a:fillRect/>
+          </a:stretch>
+        </p:blipFill>
+        <p:spPr>
+          <a:xfrm>
+            <a:off x="7406640" y="594360"/>
+            <a:ext cx="4572000" cy="2209435"/>
+          </a:xfrm>
+          <a:prstGeom prst="rect">
+            <a:avLst/>
+          </a:prstGeom>
+        </p:spPr>
+      </p:pic>
     </p:spTree>
   </p:cSld>
   <p:clrMapOvr>

</xml_diff>